<commit_message>
Final model, Attack lab Try-your-own, live Integrate panel, deck and docs
</commit_message>
<xml_diff>
--- a/docs/BugSlayers_Sentinel_Round2.pptx
+++ b/docs/BugSlayers_Sentinel_Round2.pptx
@@ -203,13 +203,13 @@
                 <c:formatCode>General</c:formatCode>
                 <c:ptCount val="4"/>
                 <c:pt idx="0">
-                  <c:v>43.1</c:v>
+                  <c:v>49.1</c:v>
                 </c:pt>
                 <c:pt idx="1">
-                  <c:v>41.8</c:v>
+                  <c:v>43.2</c:v>
                 </c:pt>
                 <c:pt idx="2">
-                  <c:v>35.7</c:v>
+                  <c:v>41.1</c:v>
                 </c:pt>
                 <c:pt idx="3">
                   <c:v>18.4</c:v>
@@ -293,16 +293,16 @@
                 <c:formatCode>General</c:formatCode>
                 <c:ptCount val="4"/>
                 <c:pt idx="0">
-                  <c:v>83.6</c:v>
+                  <c:v>86.7</c:v>
                 </c:pt>
                 <c:pt idx="1">
-                  <c:v>91.4</c:v>
+                  <c:v>94.4</c:v>
                 </c:pt>
                 <c:pt idx="2">
-                  <c:v>74.9</c:v>
+                  <c:v>83.9</c:v>
                 </c:pt>
                 <c:pt idx="3">
-                  <c:v>6.4</c:v>
+                  <c:v>2.5</c:v>
                 </c:pt>
               </c:numCache>
             </c:numRef>
@@ -1649,7 +1649,7 @@
           <a:p>
             <a:r>
               <a:rPr lang="en-US" dirty="0"/>
-              <a:t>The Attack lab is a live scoreboard. Attacks removed counts a case only when at least ninety percent of the hidden text is taken out. Harmless look-alikes must pass untouched. The two known limits are included because a judge will try them.</a:t>
+              <a:t>The Attack lab is a live scoreboard. Attacks removed counts a case only when at least ninety percent of the hidden text is taken out. Harmless look-alikes must pass untouched. The misses and the French limit are shown because a judge will try them.</a:t>
             </a:r>
             <a:endParaRPr lang="en-US" dirty="0"/>
           </a:p>
@@ -7207,7 +7207,7 @@
                 <a:ea typeface="Calibri" pitchFamily="34" charset="-122"/>
                 <a:cs typeface="Calibri" pitchFamily="34" charset="-120"/>
               </a:rPr>
-              <a:t>1,755 test documents, 29 attack families never seen in training, test web sites never seen either</a:t>
+              <a:t>1,749 test documents, 29 attack families never seen in training, test web sites never seen either</a:t>
             </a:r>
             <a:endParaRPr lang="en-US" sz="1250" dirty="0"/>
           </a:p>
@@ -10695,7 +10695,7 @@
       </p:sp>
       <p:pic>
         <p:nvPicPr>
-          <p:cNvPr id="5" name="Image 0" descr="/private/tmp/claude-501/-Users-ananyasingh-Downloads-WIN-IF-YOU-CAN-PS/bf2c8522-e0b9-476e-a641-e8df935a7bd3/scratchpad/shots/home.png">    </p:cNvPr>
+          <p:cNvPr id="5" name="Image 0" descr="/private/tmp/claude-501/-Users-ananyasingh-Downloads-WIN-IF-YOU-CAN-PS/bf2c8522-e0b9-476e-a641-e8df935a7bd3/scratchpad/shots/home-compare.png">    </p:cNvPr>
           <p:cNvPicPr>
             <a:picLocks noChangeAspect="1"/>
           </p:cNvPicPr>
@@ -10830,7 +10830,7 @@
       </p:sp>
       <p:pic>
         <p:nvPicPr>
-          <p:cNvPr id="9" name="Image 1" descr="/private/tmp/claude-501/-Users-ananyasingh-Downloads-WIN-IF-YOU-CAN-PS/bf2c8522-e0b9-476e-a641-e8df935a7bd3/scratchpad/shots/home.png">    </p:cNvPr>
+          <p:cNvPr id="9" name="Image 1" descr="/private/tmp/claude-501/-Users-ananyasingh-Downloads-WIN-IF-YOU-CAN-PS/bf2c8522-e0b9-476e-a641-e8df935a7bd3/scratchpad/shots/lab.png">    </p:cNvPr>
           <p:cNvPicPr>
             <a:picLocks noChangeAspect="1"/>
           </p:cNvPicPr>
@@ -10965,7 +10965,7 @@
       </p:sp>
       <p:pic>
         <p:nvPicPr>
-          <p:cNvPr id="13" name="Image 2" descr="/private/tmp/claude-501/-Users-ananyasingh-Downloads-WIN-IF-YOU-CAN-PS/bf2c8522-e0b9-476e-a641-e8df935a7bd3/scratchpad/shots/home.png">    </p:cNvPr>
+          <p:cNvPr id="13" name="Image 2" descr="/private/tmp/claude-501/-Users-ananyasingh-Downloads-WIN-IF-YOU-CAN-PS/bf2c8522-e0b9-476e-a641-e8df935a7bd3/scratchpad/shots/how.png">    </p:cNvPr>
           <p:cNvPicPr>
             <a:picLocks noChangeAspect="1"/>
           </p:cNvPicPr>
@@ -11524,7 +11524,7 @@
                 <a:ea typeface="Cambria" pitchFamily="34" charset="-122"/>
                 <a:cs typeface="Cambria" pitchFamily="34" charset="-120"/>
               </a:rPr>
-              <a:t>Held-out attacks and sites, same documents for every system</a:t>
+              <a:t>Results on documents the models never saw</a:t>
             </a:r>
             <a:endParaRPr lang="en-US" sz="3200" dirty="0"/>
           </a:p>
@@ -11597,7 +11597,7 @@
                 <a:ea typeface="Calibri" pitchFamily="34" charset="-122"/>
                 <a:cs typeface="Calibri" pitchFamily="34" charset="-120"/>
               </a:rPr>
-              <a:t>ALL HELD-OUT TEST DOCUMENTS  ·  1,755 DOCS  ·  29 ATTACK FAMILIES</a:t>
+              <a:t>ALL HELD-OUT TEST DOCUMENTS  ·  1,749 DOCS  ·  29 ATTACK FAMILIES</a:t>
             </a:r>
             <a:endParaRPr lang="en-US" sz="1000" dirty="0"/>
           </a:p>
@@ -11686,7 +11686,7 @@
                 <a:ea typeface="Cambria" pitchFamily="34" charset="-122"/>
                 <a:cs typeface="Cambria" pitchFamily="34" charset="-120"/>
               </a:rPr>
-              <a:t>84%</a:t>
+              <a:t>87%</a:t>
             </a:r>
             <a:endParaRPr lang="en-US" sz="4000" dirty="0"/>
           </a:p>
@@ -11764,7 +11764,7 @@
                 <a:ea typeface="Calibri" pitchFamily="34" charset="-122"/>
                 <a:cs typeface="Calibri" pitchFamily="34" charset="-120"/>
               </a:rPr>
-              <a:t>baseline 43%</a:t>
+              <a:t>baseline 49%</a:t>
             </a:r>
             <a:endParaRPr lang="en-US" sz="1100" dirty="0"/>
           </a:p>
@@ -11837,7 +11837,7 @@
                 <a:ea typeface="Cambria" pitchFamily="34" charset="-122"/>
                 <a:cs typeface="Cambria" pitchFamily="34" charset="-120"/>
               </a:rPr>
-              <a:t>91%</a:t>
+              <a:t>94%</a:t>
             </a:r>
             <a:endParaRPr lang="en-US" sz="4000" dirty="0"/>
           </a:p>
@@ -11915,7 +11915,7 @@
                 <a:ea typeface="Calibri" pitchFamily="34" charset="-122"/>
                 <a:cs typeface="Calibri" pitchFamily="34" charset="-120"/>
               </a:rPr>
-              <a:t>baseline 42%</a:t>
+              <a:t>baseline 43%</a:t>
             </a:r>
             <a:endParaRPr lang="en-US" sz="1100" dirty="0"/>
           </a:p>
@@ -12027,7 +12027,7 @@
                 <a:ea typeface="Cambria" pitchFamily="34" charset="-122"/>
                 <a:cs typeface="Cambria" pitchFamily="34" charset="-120"/>
               </a:rPr>
-              <a:t>82%</a:t>
+              <a:t>86%</a:t>
             </a:r>
             <a:pPr indent="0" marL="0">
               <a:buNone/>
@@ -12094,7 +12094,7 @@
                 <a:ea typeface="Calibri" pitchFamily="34" charset="-122"/>
                 <a:cs typeface="Calibri" pitchFamily="34" charset="-120"/>
               </a:rPr>
-              <a:t>92%</a:t>
+              <a:t>98%</a:t>
             </a:r>
             <a:pPr indent="0" marL="0">
               <a:buNone/>
@@ -12161,7 +12161,7 @@
                 <a:ea typeface="Calibri" pitchFamily="34" charset="-122"/>
                 <a:cs typeface="Calibri" pitchFamily="34" charset="-120"/>
               </a:rPr>
-              <a:t>4%</a:t>
+              <a:t>1%</a:t>
             </a:r>
             <a:pPr indent="0" marL="0">
               <a:buNone/>
@@ -13038,6 +13038,218 @@
         </p:nvSpPr>
         <p:spPr>
           <a:xfrm>
+            <a:off x="8092440" y="2240280"/>
+            <a:ext cx="3291840" cy="274320"/>
+          </a:xfrm>
+          <a:prstGeom prst="rect">
+            <a:avLst/>
+          </a:prstGeom>
+          <a:noFill/>
+          <a:ln/>
+        </p:spPr>
+        <p:txBody>
+          <a:bodyPr wrap="square" lIns="0" tIns="0" rIns="0" bIns="0" rtlCol="0" anchor="t"/>
+          <a:lstStyle/>
+          <a:p>
+            <a:pPr indent="0" marL="0">
+              <a:buNone/>
+            </a:pPr>
+            <a:r>
+              <a:rPr lang="en-US" sz="1200" dirty="0">
+                <a:solidFill>
+                  <a:srgbClr val="8A93A0"/>
+                </a:solidFill>
+                <a:latin typeface="Calibri" pitchFamily="34" charset="0"/>
+                <a:ea typeface="Calibri" pitchFamily="34" charset="-122"/>
+                <a:cs typeface="Calibri" pitchFamily="34" charset="-120"/>
+              </a:rPr>
+              <a:t>Attacks removed</a:t>
+            </a:r>
+            <a:endParaRPr lang="en-US" sz="1200" dirty="0"/>
+          </a:p>
+        </p:txBody>
+      </p:sp>
+      <p:sp>
+        <p:nvSpPr>
+          <p:cNvPr id="22" name="Text 20"/>
+          <p:cNvSpPr txBox="1"/>
+          <p:nvPr/>
+        </p:nvSpPr>
+        <p:spPr>
+          <a:xfrm>
+            <a:off x="8092440" y="2496312"/>
+            <a:ext cx="3383280" cy="640080"/>
+          </a:xfrm>
+          <a:prstGeom prst="rect">
+            <a:avLst/>
+          </a:prstGeom>
+          <a:noFill/>
+          <a:ln/>
+        </p:spPr>
+        <p:txBody>
+          <a:bodyPr wrap="square" lIns="0" tIns="0" rIns="0" bIns="0" rtlCol="0" anchor="t"/>
+          <a:lstStyle/>
+          <a:p>
+            <a:pPr indent="0" marL="0">
+              <a:buNone/>
+            </a:pPr>
+            <a:r>
+              <a:rPr lang="en-US" sz="3600" b="1" dirty="0">
+                <a:solidFill>
+                  <a:srgbClr val="FF5A36"/>
+                </a:solidFill>
+                <a:latin typeface="Cambria" pitchFamily="34" charset="0"/>
+                <a:ea typeface="Cambria" pitchFamily="34" charset="-122"/>
+                <a:cs typeface="Cambria" pitchFamily="34" charset="-120"/>
+              </a:rPr>
+              <a:t>12</a:t>
+            </a:r>
+            <a:pPr indent="0" marL="0">
+              <a:buNone/>
+            </a:pPr>
+            <a:r>
+              <a:rPr lang="en-US" sz="1600" dirty="0">
+                <a:solidFill>
+                  <a:srgbClr val="8A93A0"/>
+                </a:solidFill>
+                <a:latin typeface="Calibri" pitchFamily="34" charset="0"/>
+                <a:ea typeface="Calibri" pitchFamily="34" charset="-122"/>
+                <a:cs typeface="Calibri" pitchFamily="34" charset="-120"/>
+              </a:rPr>
+              <a:t> / 14</a:t>
+            </a:r>
+            <a:pPr indent="0" marL="0">
+              <a:buNone/>
+            </a:pPr>
+            <a:r>
+              <a:rPr lang="en-US" sz="1300" dirty="0">
+                <a:solidFill>
+                  <a:srgbClr val="8A93A0"/>
+                </a:solidFill>
+                <a:latin typeface="Calibri" pitchFamily="34" charset="0"/>
+                <a:ea typeface="Calibri" pitchFamily="34" charset="-122"/>
+                <a:cs typeface="Calibri" pitchFamily="34" charset="-120"/>
+              </a:rPr>
+              <a:t>      baseline 9</a:t>
+            </a:r>
+            <a:endParaRPr lang="en-US" sz="1400" dirty="0"/>
+          </a:p>
+        </p:txBody>
+      </p:sp>
+      <p:sp>
+        <p:nvSpPr>
+          <p:cNvPr id="23" name="Text 21"/>
+          <p:cNvSpPr txBox="1"/>
+          <p:nvPr/>
+        </p:nvSpPr>
+        <p:spPr>
+          <a:xfrm>
+            <a:off x="8092440" y="3429000"/>
+            <a:ext cx="3291840" cy="274320"/>
+          </a:xfrm>
+          <a:prstGeom prst="rect">
+            <a:avLst/>
+          </a:prstGeom>
+          <a:noFill/>
+          <a:ln/>
+        </p:spPr>
+        <p:txBody>
+          <a:bodyPr wrap="square" lIns="0" tIns="0" rIns="0" bIns="0" rtlCol="0" anchor="t"/>
+          <a:lstStyle/>
+          <a:p>
+            <a:pPr indent="0" marL="0">
+              <a:buNone/>
+            </a:pPr>
+            <a:r>
+              <a:rPr lang="en-US" sz="1200" dirty="0">
+                <a:solidFill>
+                  <a:srgbClr val="8A93A0"/>
+                </a:solidFill>
+                <a:latin typeface="Calibri" pitchFamily="34" charset="0"/>
+                <a:ea typeface="Calibri" pitchFamily="34" charset="-122"/>
+                <a:cs typeface="Calibri" pitchFamily="34" charset="-120"/>
+              </a:rPr>
+              <a:t>Harmless look-alikes passed</a:t>
+            </a:r>
+            <a:endParaRPr lang="en-US" sz="1200" dirty="0"/>
+          </a:p>
+        </p:txBody>
+      </p:sp>
+      <p:sp>
+        <p:nvSpPr>
+          <p:cNvPr id="24" name="Text 22"/>
+          <p:cNvSpPr txBox="1"/>
+          <p:nvPr/>
+        </p:nvSpPr>
+        <p:spPr>
+          <a:xfrm>
+            <a:off x="8092440" y="3685032"/>
+            <a:ext cx="3383280" cy="640080"/>
+          </a:xfrm>
+          <a:prstGeom prst="rect">
+            <a:avLst/>
+          </a:prstGeom>
+          <a:noFill/>
+          <a:ln/>
+        </p:spPr>
+        <p:txBody>
+          <a:bodyPr wrap="square" lIns="0" tIns="0" rIns="0" bIns="0" rtlCol="0" anchor="t"/>
+          <a:lstStyle/>
+          <a:p>
+            <a:pPr indent="0" marL="0">
+              <a:buNone/>
+            </a:pPr>
+            <a:r>
+              <a:rPr lang="en-US" sz="3600" b="1" dirty="0">
+                <a:solidFill>
+                  <a:srgbClr val="FF5A36"/>
+                </a:solidFill>
+                <a:latin typeface="Cambria" pitchFamily="34" charset="0"/>
+                <a:ea typeface="Cambria" pitchFamily="34" charset="-122"/>
+                <a:cs typeface="Cambria" pitchFamily="34" charset="-120"/>
+              </a:rPr>
+              <a:t>4</a:t>
+            </a:r>
+            <a:pPr indent="0" marL="0">
+              <a:buNone/>
+            </a:pPr>
+            <a:r>
+              <a:rPr lang="en-US" sz="1600" dirty="0">
+                <a:solidFill>
+                  <a:srgbClr val="8A93A0"/>
+                </a:solidFill>
+                <a:latin typeface="Calibri" pitchFamily="34" charset="0"/>
+                <a:ea typeface="Calibri" pitchFamily="34" charset="-122"/>
+                <a:cs typeface="Calibri" pitchFamily="34" charset="-120"/>
+              </a:rPr>
+              <a:t> / 4</a:t>
+            </a:r>
+            <a:pPr indent="0" marL="0">
+              <a:buNone/>
+            </a:pPr>
+            <a:r>
+              <a:rPr lang="en-US" sz="1300" dirty="0">
+                <a:solidFill>
+                  <a:srgbClr val="8A93A0"/>
+                </a:solidFill>
+                <a:latin typeface="Calibri" pitchFamily="34" charset="0"/>
+                <a:ea typeface="Calibri" pitchFamily="34" charset="-122"/>
+                <a:cs typeface="Calibri" pitchFamily="34" charset="-120"/>
+              </a:rPr>
+              <a:t>      baseline 2</a:t>
+            </a:r>
+            <a:endParaRPr lang="en-US" sz="1400" dirty="0"/>
+          </a:p>
+        </p:txBody>
+      </p:sp>
+      <p:sp>
+        <p:nvSpPr>
+          <p:cNvPr id="25" name="Text 23"/>
+          <p:cNvSpPr txBox="1"/>
+          <p:nvPr/>
+        </p:nvSpPr>
+        <p:spPr>
+          <a:xfrm>
             <a:off x="8092440" y="4663440"/>
             <a:ext cx="3291840" cy="1097280"/>
           </a:xfrm>
@@ -13063,7 +13275,7 @@
                 <a:ea typeface="Calibri" pitchFamily="34" charset="-122"/>
                 <a:cs typeface="Calibri" pitchFamily="34" charset="-120"/>
               </a:rPr>
-              <a:t>Plus two known limits, shown on purpose: an override in French, and a genuine question inside an email.</a:t>
+              <a:t>Two attacks slip through, and we show them: a sales push that reads like normal page copy, and one reworded override. An override in French is a stated limit.</a:t>
             </a:r>
             <a:endParaRPr lang="en-US" sz="1200" dirty="0"/>
           </a:p>
@@ -13071,7 +13283,7 @@
       </p:sp>
       <p:pic>
         <p:nvPicPr>
-          <p:cNvPr id="22" name="Image 0" descr="/Users/ananyasingh/Developer/Sentinel/app/static/brand/mark-flat-256.png">    </p:cNvPr>
+          <p:cNvPr id="26" name="Image 0" descr="/Users/ananyasingh/Developer/Sentinel/app/static/brand/mark-flat-256.png">    </p:cNvPr>
           <p:cNvPicPr>
             <a:picLocks noChangeAspect="1"/>
           </p:cNvPicPr>
@@ -13095,7 +13307,7 @@
       </p:pic>
       <p:sp>
         <p:nvSpPr>
-          <p:cNvPr id="23" name="Text 20"/>
+          <p:cNvPr id="27" name="Text 24"/>
           <p:cNvSpPr txBox="1"/>
           <p:nvPr/>
         </p:nvSpPr>
@@ -13134,7 +13346,7 @@
       </p:sp>
       <p:sp>
         <p:nvSpPr>
-          <p:cNvPr id="24" name="Text 21"/>
+          <p:cNvPr id="28" name="Text 25"/>
           <p:cNvSpPr txBox="1"/>
           <p:nvPr/>
         </p:nvSpPr>

</xml_diff>

<commit_message>
Final submission: links, README, packaging
</commit_message>
<xml_diff>
--- a/docs/BugSlayers_Sentinel_Round2.pptx
+++ b/docs/BugSlayers_Sentinel_Round2.pptx
@@ -15,9 +15,10 @@
     <p:sldId id="263" r:id="rId9"/>
     <p:sldId id="264" r:id="rId10"/>
     <p:sldId id="265" r:id="rId11"/>
+    <p:sldId id="266" r:id="rId12"/>
   </p:sldIdLst>
   <p:notesMasterIdLst>
-    <p:notesMasterId r:id="rId12"/>
+    <p:notesMasterId r:id="rId13"/>
   </p:notesMasterIdLst>
   <p:sldSz cx="12192000" cy="6858000"/>
   <p:notesSz cx="6858000" cy="12192000"/>
@@ -945,7 +946,7 @@
           <a:p>
             <a:r>
               <a:rPr lang="en-US" dirty="0"/>
-              <a:t>We list limitations ourselves because the judges will find them anyway. The known-limit cases are in the Attack lab so anyone can try them. The roadmap is ordered by how much each item would move the numbers.</a:t>
+              <a:t>The Attack lab is a live scoreboard. Attacks removed counts a case only when at least ninety percent of the hidden text is taken out. Harmless look-alikes must pass untouched. The misses and the French limit are shown because a judge will try them.</a:t>
             </a:r>
             <a:endParaRPr lang="en-US" dirty="0"/>
           </a:p>
@@ -969,6 +970,94 @@
             <a:fld id="{F7021451-1387-4CA6-816F-3879F97B5CBC}" type="slidenum">
               <a:rPr lang="en-US"/>
               <a:t>10</a:t>
+            </a:fld>
+            <a:endParaRPr lang="en-US"/>
+          </a:p>
+        </p:txBody>
+      </p:sp>
+    </p:spTree>
+    <p:extLst>
+      <p:ext uri="{BB962C8B-B14F-4D97-AF65-F5344CB8AC3E}">
+        <p14:creationId xmlns:p14="http://schemas.microsoft.com/office/powerpoint/2010/main" val="1024086991"/>
+      </p:ext>
+    </p:extLst>
+  </p:cSld>
+  <p:clrMapOvr>
+    <a:masterClrMapping/>
+  </p:clrMapOvr>
+</p:notes>
+</file>
+
+<file path=ppt/notesSlides/notesSlide11.xml><?xml version="1.0" encoding="utf-8"?>
+<p:notes xmlns:a="http://schemas.openxmlformats.org/drawingml/2006/main" xmlns:r="http://schemas.openxmlformats.org/officeDocument/2006/relationships" xmlns:p="http://schemas.openxmlformats.org/presentationml/2006/main">
+  <p:cSld>
+    <p:spTree>
+      <p:nvGrpSpPr>
+        <p:cNvPr id="1" name=""/>
+        <p:cNvGrpSpPr/>
+        <p:nvPr/>
+      </p:nvGrpSpPr>
+      <p:grpSpPr>
+        <a:xfrm>
+          <a:off x="0" y="0"/>
+          <a:ext cx="0" cy="0"/>
+          <a:chOff x="0" y="0"/>
+          <a:chExt cx="0" cy="0"/>
+        </a:xfrm>
+      </p:grpSpPr>
+      <p:sp>
+        <p:nvSpPr>
+          <p:cNvPr id="2" name="Slide Image Placeholder 1"/>
+          <p:cNvSpPr>
+            <a:spLocks noGrp="1" noRot="1" noChangeAspect="1"/>
+          </p:cNvSpPr>
+          <p:nvPr>
+            <p:ph type="sldImg"/>
+          </p:nvPr>
+        </p:nvSpPr>
+        <p:spPr/>
+      </p:sp>
+      <p:sp>
+        <p:nvSpPr>
+          <p:cNvPr id="3" name="Notes Placeholder 2"/>
+          <p:cNvSpPr>
+            <a:spLocks noGrp="1"/>
+          </p:cNvSpPr>
+          <p:nvPr>
+            <p:ph type="body" idx="1"/>
+          </p:nvPr>
+        </p:nvSpPr>
+        <p:spPr/>
+        <p:txBody>
+          <a:bodyPr/>
+          <a:lstStyle/>
+          <a:p>
+            <a:r>
+              <a:rPr lang="en-US" dirty="0"/>
+              <a:t>We list limitations ourselves because the judges will find them anyway. The known-limit cases are in the Attack lab so anyone can try them. The roadmap is ordered by how much each item would move the numbers.</a:t>
+            </a:r>
+            <a:endParaRPr lang="en-US" dirty="0"/>
+          </a:p>
+        </p:txBody>
+      </p:sp>
+      <p:sp>
+        <p:nvSpPr>
+          <p:cNvPr id="4" name="Slide Number Placeholder 3"/>
+          <p:cNvSpPr>
+            <a:spLocks noGrp="1"/>
+          </p:cNvSpPr>
+          <p:nvPr>
+            <p:ph type="sldNum" sz="quarter" idx="10"/>
+          </p:nvPr>
+        </p:nvSpPr>
+        <p:spPr/>
+        <p:txBody>
+          <a:bodyPr/>
+          <a:lstStyle/>
+          <a:p>
+            <a:fld id="{F7021451-1387-4CA6-816F-3879F97B5CBC}" type="slidenum">
+              <a:rPr lang="en-US"/>
+              <a:t>11</a:t>
             </a:fld>
             <a:endParaRPr lang="en-US"/>
           </a:p>
@@ -1473,7 +1562,7 @@
           <a:p>
             <a:r>
               <a:rPr lang="en-US" dirty="0"/>
-              <a:t>The prototype is a real product surface. Home is the playground. The Attack lab is the fastest way to see where it works and where it does not. The Integrate page shows exactly what an agent developer would call. Everything runs offline on this laptop.</a:t>
+              <a:t>The prototype is a real product surface. Home is the playground. The Attack lab is the fastest way to see where it works and where it does not. The Integrate page lets you call the real API and shows exactly what the model receives with and without Sentinel. Everything runs offline on this laptop.</a:t>
             </a:r>
             <a:endParaRPr lang="en-US" dirty="0"/>
           </a:p>
@@ -1649,7 +1738,7 @@
           <a:p>
             <a:r>
               <a:rPr lang="en-US" dirty="0"/>
-              <a:t>The Attack lab is a live scoreboard. Attacks removed counts a case only when at least ninety percent of the hidden text is taken out. Harmless look-alikes must pass untouched. The misses and the French limit are shown because a judge will try them.</a:t>
+              <a:t>Two features that exist to earn trust. The re-run button lets anyone check the numbers on the spot, using a fixed random sample of the held-out test set. The error explorer lists real misses and false alarms with their scores, so we show the failures ourselves. Several misses are instructions that read like ordinary requests, which is the hardest kind.</a:t>
             </a:r>
             <a:endParaRPr lang="en-US" dirty="0"/>
           </a:p>
@@ -2265,7 +2354,67 @@
       </p:sp>
       <p:sp>
         <p:nvSpPr>
-          <p:cNvPr id="8" name="Shape 5"/>
+          <p:cNvPr id="8" name="Text 5"/>
+          <p:cNvSpPr txBox="1"/>
+          <p:nvPr/>
+        </p:nvSpPr>
+        <p:spPr>
+          <a:xfrm>
+            <a:off x="548640" y="5989320"/>
+            <a:ext cx="6766560" cy="274320"/>
+          </a:xfrm>
+          <a:prstGeom prst="rect">
+            <a:avLst/>
+          </a:prstGeom>
+          <a:noFill/>
+          <a:ln/>
+        </p:spPr>
+        <p:txBody>
+          <a:bodyPr wrap="square" lIns="0" tIns="0" rIns="0" bIns="0" rtlCol="0" anchor="t"/>
+          <a:lstStyle/>
+          <a:p>
+            <a:pPr indent="0" marL="0">
+              <a:buNone/>
+            </a:pPr>
+            <a:r>
+              <a:rPr lang="en-US" sz="1300" dirty="0">
+                <a:solidFill>
+                  <a:srgbClr val="8A93A0"/>
+                </a:solidFill>
+                <a:latin typeface="Calibri" pitchFamily="34" charset="0"/>
+                <a:ea typeface="Calibri" pitchFamily="34" charset="-122"/>
+                <a:cs typeface="Calibri" pitchFamily="34" charset="-120"/>
+              </a:rPr>
+              <a:t>Code   </a:t>
+            </a:r>
+            <a:pPr indent="0" marL="0">
+              <a:buNone/>
+            </a:pPr>
+            <a:r>
+              <a:rPr lang="en-US" sz="1300" u="sng" dirty="0">
+                <a:solidFill>
+                  <a:srgbClr val="C9CFD8"/>
+                </a:solidFill>
+                <a:latin typeface="Calibri" pitchFamily="34" charset="0"/>
+                <a:ea typeface="Calibri" pitchFamily="34" charset="-122"/>
+                <a:cs typeface="Calibri" pitchFamily="34" charset="-120"/>
+                <a:hlinkClick r:id="rId2" invalidUrl="" action="" tgtFrame="" tooltip="" history="1" highlightClick="0" endSnd="0">
+                  <a:extLst>
+                    <a:ext uri="{A12FA001-AC4F-418D-AE19-62706E023703}">
+                      <ahyp:hlinkClr xmlns:ahyp="http://schemas.microsoft.com/office/drawing/2018/hyperlinkcolor" val="tx"/>
+                    </a:ext>
+                  </a:extLst>
+                </a:hlinkClick>
+              </a:rPr>
+              <a:t>github.com/ananya24s/Sentinel</a:t>
+            </a:r>
+            <a:endParaRPr lang="en-US" sz="1300" dirty="0"/>
+          </a:p>
+        </p:txBody>
+      </p:sp>
+      <p:sp>
+        <p:nvSpPr>
+          <p:cNvPr id="9" name="Shape 6"/>
           <p:cNvSpPr/>
           <p:nvPr/>
         </p:nvSpPr>
@@ -2290,7 +2439,7 @@
       </p:sp>
       <p:sp>
         <p:nvSpPr>
-          <p:cNvPr id="9" name="Shape 6"/>
+          <p:cNvPr id="10" name="Shape 7"/>
           <p:cNvSpPr/>
           <p:nvPr/>
         </p:nvSpPr>
@@ -2315,7 +2464,7 @@
       </p:sp>
       <p:sp>
         <p:nvSpPr>
-          <p:cNvPr id="10" name="Text 7"/>
+          <p:cNvPr id="11" name="Text 8"/>
           <p:cNvSpPr txBox="1"/>
           <p:nvPr/>
         </p:nvSpPr>
@@ -2354,7 +2503,7 @@
       </p:sp>
       <p:sp>
         <p:nvSpPr>
-          <p:cNvPr id="11" name="Text 8"/>
+          <p:cNvPr id="12" name="Text 9"/>
           <p:cNvSpPr txBox="1"/>
           <p:nvPr/>
         </p:nvSpPr>
@@ -2397,7 +2546,7 @@
       </p:sp>
       <p:sp>
         <p:nvSpPr>
-          <p:cNvPr id="12" name="Shape 9"/>
+          <p:cNvPr id="13" name="Shape 10"/>
           <p:cNvSpPr/>
           <p:nvPr/>
         </p:nvSpPr>
@@ -2420,7 +2569,7 @@
       </p:sp>
       <p:sp>
         <p:nvSpPr>
-          <p:cNvPr id="13" name="Text 10"/>
+          <p:cNvPr id="14" name="Text 11"/>
           <p:cNvSpPr txBox="1"/>
           <p:nvPr/>
         </p:nvSpPr>
@@ -2476,7 +2625,7 @@
       </p:sp>
       <p:sp>
         <p:nvSpPr>
-          <p:cNvPr id="14" name="Text 11"/>
+          <p:cNvPr id="15" name="Text 12"/>
           <p:cNvSpPr txBox="1"/>
           <p:nvPr/>
         </p:nvSpPr>
@@ -2515,7 +2664,7 @@
       </p:sp>
       <p:sp>
         <p:nvSpPr>
-          <p:cNvPr id="15" name="Shape 12"/>
+          <p:cNvPr id="16" name="Shape 13"/>
           <p:cNvSpPr/>
           <p:nvPr/>
         </p:nvSpPr>
@@ -2542,7 +2691,7 @@
       </p:sp>
       <p:sp>
         <p:nvSpPr>
-          <p:cNvPr id="16" name="Shape 13"/>
+          <p:cNvPr id="17" name="Shape 14"/>
           <p:cNvSpPr/>
           <p:nvPr/>
         </p:nvSpPr>
@@ -2569,7 +2718,7 @@
       </p:sp>
       <p:sp>
         <p:nvSpPr>
-          <p:cNvPr id="17" name="Text 14"/>
+          <p:cNvPr id="18" name="Text 15"/>
           <p:cNvSpPr txBox="1"/>
           <p:nvPr/>
         </p:nvSpPr>
@@ -2608,7 +2757,7 @@
       </p:sp>
       <p:sp>
         <p:nvSpPr>
-          <p:cNvPr id="18" name="Text 15"/>
+          <p:cNvPr id="19" name="Text 16"/>
           <p:cNvSpPr txBox="1"/>
           <p:nvPr/>
         </p:nvSpPr>
@@ -2647,7 +2796,7 @@
       </p:sp>
       <p:sp>
         <p:nvSpPr>
-          <p:cNvPr id="19" name="Shape 16"/>
+          <p:cNvPr id="20" name="Shape 17"/>
           <p:cNvSpPr/>
           <p:nvPr/>
         </p:nvSpPr>
@@ -2672,7 +2821,7 @@
       </p:sp>
       <p:sp>
         <p:nvSpPr>
-          <p:cNvPr id="20" name="Shape 17"/>
+          <p:cNvPr id="21" name="Shape 18"/>
           <p:cNvSpPr/>
           <p:nvPr/>
         </p:nvSpPr>
@@ -2697,7 +2846,7 @@
       </p:sp>
       <p:sp>
         <p:nvSpPr>
-          <p:cNvPr id="21" name="Text 18"/>
+          <p:cNvPr id="22" name="Text 19"/>
           <p:cNvSpPr txBox="1"/>
           <p:nvPr/>
         </p:nvSpPr>
@@ -2736,7 +2885,7 @@
       </p:sp>
       <p:sp>
         <p:nvSpPr>
-          <p:cNvPr id="22" name="Text 19"/>
+          <p:cNvPr id="23" name="Text 20"/>
           <p:cNvSpPr txBox="1"/>
           <p:nvPr/>
         </p:nvSpPr>
@@ -2775,7 +2924,7 @@
       </p:sp>
       <p:sp>
         <p:nvSpPr>
-          <p:cNvPr id="23" name="Shape 20"/>
+          <p:cNvPr id="24" name="Shape 21"/>
           <p:cNvSpPr/>
           <p:nvPr/>
         </p:nvSpPr>
@@ -2802,7 +2951,7 @@
       </p:sp>
       <p:sp>
         <p:nvSpPr>
-          <p:cNvPr id="24" name="Text 21"/>
+          <p:cNvPr id="25" name="Text 22"/>
           <p:cNvSpPr txBox="1"/>
           <p:nvPr/>
         </p:nvSpPr>
@@ -2917,7 +3066,7 @@
                 <a:ea typeface="Calibri" pitchFamily="34" charset="-122"/>
                 <a:cs typeface="Calibri" pitchFamily="34" charset="-120"/>
               </a:rPr>
-              <a:t>09  ·  LIMITATIONS AND NEXT STEPS</a:t>
+              <a:t>09  ·  RESTRICTION HANDLING</a:t>
             </a:r>
             <a:endParaRPr lang="en-US" sz="1200" dirty="0"/>
           </a:p>
@@ -2956,7 +3105,7 @@
                 <a:ea typeface="Cambria" pitchFamily="34" charset="-122"/>
                 <a:cs typeface="Cambria" pitchFamily="34" charset="-120"/>
               </a:rPr>
-              <a:t>What it does not do yet</a:t>
+              <a:t>Where it could go wrong, and what we do about it</a:t>
             </a:r>
             <a:endParaRPr lang="en-US" sz="3200" dirty="0"/>
           </a:p>
@@ -2964,57 +3113,18 @@
       </p:sp>
       <p:sp>
         <p:nvSpPr>
-          <p:cNvPr id="4" name="Text 2"/>
-          <p:cNvSpPr txBox="1"/>
-          <p:nvPr/>
-        </p:nvSpPr>
-        <p:spPr>
-          <a:xfrm>
-            <a:off x="548640" y="1627632"/>
-            <a:ext cx="4572000" cy="256032"/>
-          </a:xfrm>
-          <a:prstGeom prst="rect">
-            <a:avLst/>
-          </a:prstGeom>
-          <a:noFill/>
-          <a:ln/>
-        </p:spPr>
-        <p:txBody>
-          <a:bodyPr wrap="square" lIns="0" tIns="0" rIns="0" bIns="0" rtlCol="0" anchor="t"/>
-          <a:lstStyle/>
-          <a:p>
-            <a:pPr indent="0" marL="0">
-              <a:buNone/>
-            </a:pPr>
-            <a:r>
-              <a:rPr lang="en-US" sz="1100" b="1" spc="250" kern="0" dirty="0">
-                <a:solidFill>
-                  <a:srgbClr val="FF5A36"/>
-                </a:solidFill>
-                <a:latin typeface="Calibri" pitchFamily="34" charset="0"/>
-                <a:ea typeface="Calibri" pitchFamily="34" charset="-122"/>
-                <a:cs typeface="Calibri" pitchFamily="34" charset="-120"/>
-              </a:rPr>
-              <a:t>STATED PLAINLY</a:t>
-            </a:r>
-            <a:endParaRPr lang="en-US" sz="1100" dirty="0"/>
-          </a:p>
-        </p:txBody>
-      </p:sp>
-      <p:sp>
-        <p:nvSpPr>
-          <p:cNvPr id="5" name="Shape 3"/>
+          <p:cNvPr id="4" name="Shape 2"/>
           <p:cNvSpPr/>
           <p:nvPr/>
         </p:nvSpPr>
         <p:spPr>
           <a:xfrm>
-            <a:off x="548640" y="1965960"/>
-            <a:ext cx="6766560" cy="749808"/>
+            <a:off x="548640" y="1600200"/>
+            <a:ext cx="7040880" cy="804672"/>
           </a:xfrm>
           <a:prstGeom prst="roundRect">
             <a:avLst>
-              <a:gd name="adj" fmla="val 14634"/>
+              <a:gd name="adj" fmla="val 13636"/>
             </a:avLst>
           </a:prstGeom>
           <a:solidFill>
@@ -3030,69 +3140,69 @@
       </p:sp>
       <p:sp>
         <p:nvSpPr>
+          <p:cNvPr id="5" name="Text 3"/>
+          <p:cNvSpPr txBox="1"/>
+          <p:nvPr/>
+        </p:nvSpPr>
+        <p:spPr>
+          <a:xfrm>
+            <a:off x="777240" y="1691640"/>
+            <a:ext cx="6583680" cy="292608"/>
+          </a:xfrm>
+          <a:prstGeom prst="rect">
+            <a:avLst/>
+          </a:prstGeom>
+          <a:noFill/>
+          <a:ln/>
+        </p:spPr>
+        <p:txBody>
+          <a:bodyPr wrap="square" lIns="0" tIns="0" rIns="0" bIns="0" rtlCol="0" anchor="t"/>
+          <a:lstStyle/>
+          <a:p>
+            <a:pPr indent="0" marL="0">
+              <a:buNone/>
+            </a:pPr>
+            <a:r>
+              <a:rPr lang="en-US" sz="1400" b="1" dirty="0">
+                <a:solidFill>
+                  <a:srgbClr val="12161C"/>
+                </a:solidFill>
+                <a:latin typeface="Calibri" pitchFamily="34" charset="0"/>
+                <a:ea typeface="Calibri" pitchFamily="34" charset="-122"/>
+                <a:cs typeface="Calibri" pitchFamily="34" charset="-120"/>
+              </a:rPr>
+              <a:t>Useful content must survive</a:t>
+            </a:r>
+            <a:endParaRPr lang="en-US" sz="1400" dirty="0"/>
+          </a:p>
+        </p:txBody>
+      </p:sp>
+      <p:sp>
+        <p:nvSpPr>
           <p:cNvPr id="6" name="Text 4"/>
           <p:cNvSpPr txBox="1"/>
           <p:nvPr/>
         </p:nvSpPr>
         <p:spPr>
           <a:xfrm>
-            <a:off x="777240" y="2048256"/>
-            <a:ext cx="6309360" cy="274320"/>
-          </a:xfrm>
-          <a:prstGeom prst="rect">
-            <a:avLst/>
-          </a:prstGeom>
-          <a:noFill/>
-          <a:ln/>
-        </p:spPr>
-        <p:txBody>
-          <a:bodyPr wrap="square" lIns="0" tIns="0" rIns="0" bIns="0" rtlCol="0" anchor="t"/>
-          <a:lstStyle/>
-          <a:p>
-            <a:pPr indent="0" marL="0">
-              <a:buNone/>
-            </a:pPr>
-            <a:r>
-              <a:rPr lang="en-US" sz="1350" b="1" dirty="0">
-                <a:solidFill>
-                  <a:srgbClr val="12161C"/>
-                </a:solidFill>
-                <a:latin typeface="Calibri" pitchFamily="34" charset="0"/>
-                <a:ea typeface="Calibri" pitchFamily="34" charset="-122"/>
-                <a:cs typeface="Calibri" pitchFamily="34" charset="-120"/>
-              </a:rPr>
-              <a:t>English only</a:t>
-            </a:r>
-            <a:endParaRPr lang="en-US" sz="1350" dirty="0"/>
-          </a:p>
-        </p:txBody>
-      </p:sp>
-      <p:sp>
-        <p:nvSpPr>
-          <p:cNvPr id="7" name="Text 5"/>
-          <p:cNvSpPr txBox="1"/>
-          <p:nvPr/>
-        </p:nvSpPr>
-        <p:spPr>
-          <a:xfrm>
-            <a:off x="777240" y="2340864"/>
-            <a:ext cx="6309360" cy="365760"/>
-          </a:xfrm>
-          <a:prstGeom prst="rect">
-            <a:avLst/>
-          </a:prstGeom>
-          <a:noFill/>
-          <a:ln/>
-        </p:spPr>
-        <p:txBody>
-          <a:bodyPr wrap="square" lIns="0" tIns="0" rIns="0" bIns="0" rtlCol="0" anchor="t"/>
-          <a:lstStyle/>
-          <a:p>
-            <a:pPr indent="0" marL="0">
-              <a:buNone/>
-            </a:pPr>
-            <a:r>
-              <a:rPr lang="en-US" sz="1150" dirty="0">
+            <a:off x="777240" y="2011680"/>
+            <a:ext cx="6583680" cy="365760"/>
+          </a:xfrm>
+          <a:prstGeom prst="rect">
+            <a:avLst/>
+          </a:prstGeom>
+          <a:noFill/>
+          <a:ln/>
+        </p:spPr>
+        <p:txBody>
+          <a:bodyPr wrap="square" lIns="0" tIns="0" rIns="0" bIns="0" rtlCol="0" anchor="t"/>
+          <a:lstStyle/>
+          <a:p>
+            <a:pPr indent="0" marL="0">
+              <a:buNone/>
+            </a:pPr>
+            <a:r>
+              <a:rPr lang="en-US" sz="1200" dirty="0">
                 <a:solidFill>
                   <a:srgbClr val="5B6472"/>
                 </a:solidFill>
@@ -3100,26 +3210,26 @@
                 <a:ea typeface="Calibri" pitchFamily="34" charset="-122"/>
                 <a:cs typeface="Calibri" pitchFamily="34" charset="-120"/>
               </a:rPr>
-              <a:t>Training data is English; an override in another language is likely missed.</a:t>
-            </a:r>
-            <a:endParaRPr lang="en-US" sz="1150" dirty="0"/>
-          </a:p>
-        </p:txBody>
-      </p:sp>
-      <p:sp>
-        <p:nvSpPr>
-          <p:cNvPr id="8" name="Shape 6"/>
+              <a:t>Only the offending span is removed; every other word passes through unchanged.</a:t>
+            </a:r>
+            <a:endParaRPr lang="en-US" sz="1200" dirty="0"/>
+          </a:p>
+        </p:txBody>
+      </p:sp>
+      <p:sp>
+        <p:nvSpPr>
+          <p:cNvPr id="7" name="Shape 5"/>
           <p:cNvSpPr/>
           <p:nvPr/>
         </p:nvSpPr>
         <p:spPr>
           <a:xfrm>
-            <a:off x="548640" y="2807208"/>
-            <a:ext cx="6766560" cy="749808"/>
+            <a:off x="548640" y="2496312"/>
+            <a:ext cx="7040880" cy="804672"/>
           </a:xfrm>
           <a:prstGeom prst="roundRect">
             <a:avLst>
-              <a:gd name="adj" fmla="val 14634"/>
+              <a:gd name="adj" fmla="val 13636"/>
             </a:avLst>
           </a:prstGeom>
           <a:solidFill>
@@ -3135,69 +3245,69 @@
       </p:sp>
       <p:sp>
         <p:nvSpPr>
+          <p:cNvPr id="8" name="Text 6"/>
+          <p:cNvSpPr txBox="1"/>
+          <p:nvPr/>
+        </p:nvSpPr>
+        <p:spPr>
+          <a:xfrm>
+            <a:off x="777240" y="2587752"/>
+            <a:ext cx="6583680" cy="292608"/>
+          </a:xfrm>
+          <a:prstGeom prst="rect">
+            <a:avLst/>
+          </a:prstGeom>
+          <a:noFill/>
+          <a:ln/>
+        </p:spPr>
+        <p:txBody>
+          <a:bodyPr wrap="square" lIns="0" tIns="0" rIns="0" bIns="0" rtlCol="0" anchor="t"/>
+          <a:lstStyle/>
+          <a:p>
+            <a:pPr indent="0" marL="0">
+              <a:buNone/>
+            </a:pPr>
+            <a:r>
+              <a:rPr lang="en-US" sz="1400" b="1" dirty="0">
+                <a:solidFill>
+                  <a:srgbClr val="12161C"/>
+                </a:solidFill>
+                <a:latin typeface="Calibri" pitchFamily="34" charset="0"/>
+                <a:ea typeface="Calibri" pitchFamily="34" charset="-122"/>
+                <a:cs typeface="Calibri" pitchFamily="34" charset="-120"/>
+              </a:rPr>
+              <a:t>Harmless commands must not be blocked</a:t>
+            </a:r>
+            <a:endParaRPr lang="en-US" sz="1400" dirty="0"/>
+          </a:p>
+        </p:txBody>
+      </p:sp>
+      <p:sp>
+        <p:nvSpPr>
           <p:cNvPr id="9" name="Text 7"/>
           <p:cNvSpPr txBox="1"/>
           <p:nvPr/>
         </p:nvSpPr>
         <p:spPr>
           <a:xfrm>
-            <a:off x="777240" y="2889504"/>
-            <a:ext cx="6309360" cy="274320"/>
-          </a:xfrm>
-          <a:prstGeom prst="rect">
-            <a:avLst/>
-          </a:prstGeom>
-          <a:noFill/>
-          <a:ln/>
-        </p:spPr>
-        <p:txBody>
-          <a:bodyPr wrap="square" lIns="0" tIns="0" rIns="0" bIns="0" rtlCol="0" anchor="t"/>
-          <a:lstStyle/>
-          <a:p>
-            <a:pPr indent="0" marL="0">
-              <a:buNone/>
-            </a:pPr>
-            <a:r>
-              <a:rPr lang="en-US" sz="1350" b="1" dirty="0">
-                <a:solidFill>
-                  <a:srgbClr val="12161C"/>
-                </a:solidFill>
-                <a:latin typeface="Calibri" pitchFamily="34" charset="0"/>
-                <a:ea typeface="Calibri" pitchFamily="34" charset="-122"/>
-                <a:cs typeface="Calibri" pitchFamily="34" charset="-120"/>
-              </a:rPr>
-              <a:t>Question-shaped text is hardest</a:t>
-            </a:r>
-            <a:endParaRPr lang="en-US" sz="1350" dirty="0"/>
-          </a:p>
-        </p:txBody>
-      </p:sp>
-      <p:sp>
-        <p:nvSpPr>
-          <p:cNvPr id="10" name="Text 8"/>
-          <p:cNvSpPr txBox="1"/>
-          <p:nvPr/>
-        </p:nvSpPr>
-        <p:spPr>
-          <a:xfrm>
-            <a:off x="777240" y="3182112"/>
-            <a:ext cx="6309360" cy="365760"/>
-          </a:xfrm>
-          <a:prstGeom prst="rect">
-            <a:avLst/>
-          </a:prstGeom>
-          <a:noFill/>
-          <a:ln/>
-        </p:spPr>
-        <p:txBody>
-          <a:bodyPr wrap="square" lIns="0" tIns="0" rIns="0" bIns="0" rtlCol="0" anchor="t"/>
-          <a:lstStyle/>
-          <a:p>
-            <a:pPr indent="0" marL="0">
-              <a:buNone/>
-            </a:pPr>
-            <a:r>
-              <a:rPr lang="en-US" sz="1150" dirty="0">
+            <a:off x="777240" y="2907792"/>
+            <a:ext cx="6583680" cy="365760"/>
+          </a:xfrm>
+          <a:prstGeom prst="rect">
+            <a:avLst/>
+          </a:prstGeom>
+          <a:noFill/>
+          <a:ln/>
+        </p:spPr>
+        <p:txBody>
+          <a:bodyPr wrap="square" lIns="0" tIns="0" rIns="0" bIns="0" rtlCol="0" anchor="t"/>
+          <a:lstStyle/>
+          <a:p>
+            <a:pPr indent="0" marL="0">
+              <a:buNone/>
+            </a:pPr>
+            <a:r>
+              <a:rPr lang="en-US" sz="1200" dirty="0">
                 <a:solidFill>
                   <a:srgbClr val="5B6472"/>
                 </a:solidFill>
@@ -3205,26 +3315,26 @@
                 <a:ea typeface="Calibri" pitchFamily="34" charset="-122"/>
                 <a:cs typeface="Calibri" pitchFamily="34" charset="-120"/>
               </a:rPr>
-              <a:t>A genuine question inside an email can be flagged.</a:t>
-            </a:r>
-            <a:endParaRPr lang="en-US" sz="1150" dirty="0"/>
-          </a:p>
-        </p:txBody>
-      </p:sp>
-      <p:sp>
-        <p:nvSpPr>
-          <p:cNvPr id="11" name="Shape 9"/>
+              <a:t>The off-task check clears command-shaped text that belongs on the page; harmless look-alikes are scored.</a:t>
+            </a:r>
+            <a:endParaRPr lang="en-US" sz="1200" dirty="0"/>
+          </a:p>
+        </p:txBody>
+      </p:sp>
+      <p:sp>
+        <p:nvSpPr>
+          <p:cNvPr id="10" name="Shape 8"/>
           <p:cNvSpPr/>
           <p:nvPr/>
         </p:nvSpPr>
         <p:spPr>
           <a:xfrm>
-            <a:off x="548640" y="3648456"/>
-            <a:ext cx="6766560" cy="749808"/>
+            <a:off x="548640" y="3392424"/>
+            <a:ext cx="7040880" cy="804672"/>
           </a:xfrm>
           <a:prstGeom prst="roundRect">
             <a:avLst>
-              <a:gd name="adj" fmla="val 14634"/>
+              <a:gd name="adj" fmla="val 13636"/>
             </a:avLst>
           </a:prstGeom>
           <a:solidFill>
@@ -3240,69 +3350,69 @@
       </p:sp>
       <p:sp>
         <p:nvSpPr>
+          <p:cNvPr id="11" name="Text 9"/>
+          <p:cNvSpPr txBox="1"/>
+          <p:nvPr/>
+        </p:nvSpPr>
+        <p:spPr>
+          <a:xfrm>
+            <a:off x="777240" y="3483864"/>
+            <a:ext cx="6583680" cy="292608"/>
+          </a:xfrm>
+          <a:prstGeom prst="rect">
+            <a:avLst/>
+          </a:prstGeom>
+          <a:noFill/>
+          <a:ln/>
+        </p:spPr>
+        <p:txBody>
+          <a:bodyPr wrap="square" lIns="0" tIns="0" rIns="0" bIns="0" rtlCol="0" anchor="t"/>
+          <a:lstStyle/>
+          <a:p>
+            <a:pPr indent="0" marL="0">
+              <a:buNone/>
+            </a:pPr>
+            <a:r>
+              <a:rPr lang="en-US" sz="1400" b="1" dirty="0">
+                <a:solidFill>
+                  <a:srgbClr val="12161C"/>
+                </a:solidFill>
+                <a:latin typeface="Calibri" pitchFamily="34" charset="0"/>
+                <a:ea typeface="Calibri" pitchFamily="34" charset="-122"/>
+                <a:cs typeface="Calibri" pitchFamily="34" charset="-120"/>
+              </a:rPr>
+              <a:t>Unseen attack styles</a:t>
+            </a:r>
+            <a:endParaRPr lang="en-US" sz="1400" dirty="0"/>
+          </a:p>
+        </p:txBody>
+      </p:sp>
+      <p:sp>
+        <p:nvSpPr>
           <p:cNvPr id="12" name="Text 10"/>
           <p:cNvSpPr txBox="1"/>
           <p:nvPr/>
         </p:nvSpPr>
         <p:spPr>
           <a:xfrm>
-            <a:off x="777240" y="3730752"/>
-            <a:ext cx="6309360" cy="274320"/>
-          </a:xfrm>
-          <a:prstGeom prst="rect">
-            <a:avLst/>
-          </a:prstGeom>
-          <a:noFill/>
-          <a:ln/>
-        </p:spPr>
-        <p:txBody>
-          <a:bodyPr wrap="square" lIns="0" tIns="0" rIns="0" bIns="0" rtlCol="0" anchor="t"/>
-          <a:lstStyle/>
-          <a:p>
-            <a:pPr indent="0" marL="0">
-              <a:buNone/>
-            </a:pPr>
-            <a:r>
-              <a:rPr lang="en-US" sz="1350" b="1" dirty="0">
-                <a:solidFill>
-                  <a:srgbClr val="12161C"/>
-                </a:solidFill>
-                <a:latin typeface="Calibri" pitchFamily="34" charset="0"/>
-                <a:ea typeface="Calibri" pitchFamily="34" charset="-122"/>
-                <a:cs typeface="Calibri" pitchFamily="34" charset="-120"/>
-              </a:rPr>
-              <a:t>Benchmark plus generated attacks</a:t>
-            </a:r>
-            <a:endParaRPr lang="en-US" sz="1350" dirty="0"/>
-          </a:p>
-        </p:txBody>
-      </p:sp>
-      <p:sp>
-        <p:nvSpPr>
-          <p:cNvPr id="13" name="Text 11"/>
-          <p:cNvSpPr txBox="1"/>
-          <p:nvPr/>
-        </p:nvSpPr>
-        <p:spPr>
-          <a:xfrm>
-            <a:off x="777240" y="4023360"/>
-            <a:ext cx="6309360" cy="365760"/>
-          </a:xfrm>
-          <a:prstGeom prst="rect">
-            <a:avLst/>
-          </a:prstGeom>
-          <a:noFill/>
-          <a:ln/>
-        </p:spPr>
-        <p:txBody>
-          <a:bodyPr wrap="square" lIns="0" tIns="0" rIns="0" bIns="0" rtlCol="0" anchor="t"/>
-          <a:lstStyle/>
-          <a:p>
-            <a:pPr indent="0" marL="0">
-              <a:buNone/>
-            </a:pPr>
-            <a:r>
-              <a:rPr lang="en-US" sz="1150" dirty="0">
+            <a:off x="777240" y="3803904"/>
+            <a:ext cx="6583680" cy="365760"/>
+          </a:xfrm>
+          <a:prstGeom prst="rect">
+            <a:avLst/>
+          </a:prstGeom>
+          <a:noFill/>
+          <a:ln/>
+        </p:spPr>
+        <p:txBody>
+          <a:bodyPr wrap="square" lIns="0" tIns="0" rIns="0" bIns="0" rtlCol="0" anchor="t"/>
+          <a:lstStyle/>
+          <a:p>
+            <a:pPr indent="0" marL="0">
+              <a:buNone/>
+            </a:pPr>
+            <a:r>
+              <a:rPr lang="en-US" sz="1200" dirty="0">
                 <a:solidFill>
                   <a:srgbClr val="5B6472"/>
                 </a:solidFill>
@@ -3310,26 +3420,26 @@
                 <a:ea typeface="Calibri" pitchFamily="34" charset="-122"/>
                 <a:cs typeface="Calibri" pitchFamily="34" charset="-120"/>
               </a:rPr>
-              <a:t>An attack style far from every training source may slip through.</a:t>
-            </a:r>
-            <a:endParaRPr lang="en-US" sz="1150" dirty="0"/>
-          </a:p>
-        </p:txBody>
-      </p:sp>
-      <p:sp>
-        <p:nvSpPr>
-          <p:cNvPr id="14" name="Shape 12"/>
+              <a:t>Whole attack families and whole sites are held out of training and calibration.</a:t>
+            </a:r>
+            <a:endParaRPr lang="en-US" sz="1200" dirty="0"/>
+          </a:p>
+        </p:txBody>
+      </p:sp>
+      <p:sp>
+        <p:nvSpPr>
+          <p:cNvPr id="13" name="Shape 11"/>
           <p:cNvSpPr/>
           <p:nvPr/>
         </p:nvSpPr>
         <p:spPr>
           <a:xfrm>
-            <a:off x="548640" y="4489704"/>
-            <a:ext cx="6766560" cy="749808"/>
+            <a:off x="548640" y="4288536"/>
+            <a:ext cx="7040880" cy="804672"/>
           </a:xfrm>
           <a:prstGeom prst="roundRect">
             <a:avLst>
-              <a:gd name="adj" fmla="val 14634"/>
+              <a:gd name="adj" fmla="val 13636"/>
             </a:avLst>
           </a:prstGeom>
           <a:solidFill>
@@ -3345,69 +3455,69 @@
       </p:sp>
       <p:sp>
         <p:nvSpPr>
+          <p:cNvPr id="14" name="Text 12"/>
+          <p:cNvSpPr txBox="1"/>
+          <p:nvPr/>
+        </p:nvSpPr>
+        <p:spPr>
+          <a:xfrm>
+            <a:off x="777240" y="4379976"/>
+            <a:ext cx="6583680" cy="292608"/>
+          </a:xfrm>
+          <a:prstGeom prst="rect">
+            <a:avLst/>
+          </a:prstGeom>
+          <a:noFill/>
+          <a:ln/>
+        </p:spPr>
+        <p:txBody>
+          <a:bodyPr wrap="square" lIns="0" tIns="0" rIns="0" bIns="0" rtlCol="0" anchor="t"/>
+          <a:lstStyle/>
+          <a:p>
+            <a:pPr indent="0" marL="0">
+              <a:buNone/>
+            </a:pPr>
+            <a:r>
+              <a:rPr lang="en-US" sz="1400" b="1" dirty="0">
+                <a:solidFill>
+                  <a:srgbClr val="12161C"/>
+                </a:solidFill>
+                <a:latin typeface="Calibri" pitchFamily="34" charset="0"/>
+                <a:ea typeface="Calibri" pitchFamily="34" charset="-122"/>
+                <a:cs typeface="Calibri" pitchFamily="34" charset="-120"/>
+              </a:rPr>
+              <a:t>Hidden and forged instructions</a:t>
+            </a:r>
+            <a:endParaRPr lang="en-US" sz="1400" dirty="0"/>
+          </a:p>
+        </p:txBody>
+      </p:sp>
+      <p:sp>
+        <p:nvSpPr>
           <p:cNvPr id="15" name="Text 13"/>
           <p:cNvSpPr txBox="1"/>
           <p:nvPr/>
         </p:nvSpPr>
         <p:spPr>
           <a:xfrm>
-            <a:off x="777240" y="4572000"/>
-            <a:ext cx="6309360" cy="274320"/>
-          </a:xfrm>
-          <a:prstGeom prst="rect">
-            <a:avLst/>
-          </a:prstGeom>
-          <a:noFill/>
-          <a:ln/>
-        </p:spPr>
-        <p:txBody>
-          <a:bodyPr wrap="square" lIns="0" tIns="0" rIns="0" bIns="0" rtlCol="0" anchor="t"/>
-          <a:lstStyle/>
-          <a:p>
-            <a:pPr indent="0" marL="0">
-              <a:buNone/>
-            </a:pPr>
-            <a:r>
-              <a:rPr lang="en-US" sz="1350" b="1" dirty="0">
-                <a:solidFill>
-                  <a:srgbClr val="12161C"/>
-                </a:solidFill>
-                <a:latin typeface="Calibri" pitchFamily="34" charset="0"/>
-                <a:ea typeface="Calibri" pitchFamily="34" charset="-122"/>
-                <a:cs typeface="Calibri" pitchFamily="34" charset="-120"/>
-              </a:rPr>
-              <a:t>Small boundary test</a:t>
-            </a:r>
-            <a:endParaRPr lang="en-US" sz="1350" dirty="0"/>
-          </a:p>
-        </p:txBody>
-      </p:sp>
-      <p:sp>
-        <p:nvSpPr>
-          <p:cNvPr id="16" name="Text 14"/>
-          <p:cNvSpPr txBox="1"/>
-          <p:nvPr/>
-        </p:nvSpPr>
-        <p:spPr>
-          <a:xfrm>
-            <a:off x="777240" y="4864608"/>
-            <a:ext cx="6309360" cy="365760"/>
-          </a:xfrm>
-          <a:prstGeom prst="rect">
-            <a:avLst/>
-          </a:prstGeom>
-          <a:noFill/>
-          <a:ln/>
-        </p:spPr>
-        <p:txBody>
-          <a:bodyPr wrap="square" lIns="0" tIns="0" rIns="0" bIns="0" rtlCol="0" anchor="t"/>
-          <a:lstStyle/>
-          <a:p>
-            <a:pPr indent="0" marL="0">
-              <a:buNone/>
-            </a:pPr>
-            <a:r>
-              <a:rPr lang="en-US" sz="1150" dirty="0">
+            <a:off x="777240" y="4700016"/>
+            <a:ext cx="6583680" cy="365760"/>
+          </a:xfrm>
+          <a:prstGeom prst="rect">
+            <a:avLst/>
+          </a:prstGeom>
+          <a:noFill/>
+          <a:ln/>
+        </p:spPr>
+        <p:txBody>
+          <a:bodyPr wrap="square" lIns="0" tIns="0" rIns="0" bIns="0" rtlCol="0" anchor="t"/>
+          <a:lstStyle/>
+          <a:p>
+            <a:pPr indent="0" marL="0">
+              <a:buNone/>
+            </a:pPr>
+            <a:r>
+              <a:rPr lang="en-US" sz="1200" dirty="0">
                 <a:solidFill>
                   <a:srgbClr val="5B6472"/>
                 </a:solidFill>
@@ -3415,26 +3525,26 @@
                 <a:ea typeface="Calibri" pitchFamily="34" charset="-122"/>
                 <a:cs typeface="Calibri" pitchFamily="34" charset="-120"/>
               </a:rPr>
-              <a:t>Boundary accuracy is 100% on 16 hand-written cases; the rule is structural, the set is small.</a:t>
-            </a:r>
-            <a:endParaRPr lang="en-US" sz="1150" dirty="0"/>
-          </a:p>
-        </p:txBody>
-      </p:sp>
-      <p:sp>
-        <p:nvSpPr>
-          <p:cNvPr id="17" name="Shape 15"/>
+              <a:t>HTML comments and code blocks stay whole; forged system or assistant roles are removed by rule.</a:t>
+            </a:r>
+            <a:endParaRPr lang="en-US" sz="1200" dirty="0"/>
+          </a:p>
+        </p:txBody>
+      </p:sp>
+      <p:sp>
+        <p:nvSpPr>
+          <p:cNvPr id="16" name="Shape 14"/>
           <p:cNvSpPr/>
           <p:nvPr/>
         </p:nvSpPr>
         <p:spPr>
           <a:xfrm>
-            <a:off x="548640" y="5330952"/>
-            <a:ext cx="6766560" cy="749808"/>
+            <a:off x="548640" y="5184648"/>
+            <a:ext cx="7040880" cy="804672"/>
           </a:xfrm>
           <a:prstGeom prst="roundRect">
             <a:avLst>
-              <a:gd name="adj" fmla="val 14634"/>
+              <a:gd name="adj" fmla="val 13636"/>
             </a:avLst>
           </a:prstGeom>
           <a:solidFill>
@@ -3450,69 +3560,69 @@
       </p:sp>
       <p:sp>
         <p:nvSpPr>
+          <p:cNvPr id="17" name="Text 15"/>
+          <p:cNvSpPr txBox="1"/>
+          <p:nvPr/>
+        </p:nvSpPr>
+        <p:spPr>
+          <a:xfrm>
+            <a:off x="777240" y="5276088"/>
+            <a:ext cx="6583680" cy="292608"/>
+          </a:xfrm>
+          <a:prstGeom prst="rect">
+            <a:avLst/>
+          </a:prstGeom>
+          <a:noFill/>
+          <a:ln/>
+        </p:spPr>
+        <p:txBody>
+          <a:bodyPr wrap="square" lIns="0" tIns="0" rIns="0" bIns="0" rtlCol="0" anchor="t"/>
+          <a:lstStyle/>
+          <a:p>
+            <a:pPr indent="0" marL="0">
+              <a:buNone/>
+            </a:pPr>
+            <a:r>
+              <a:rPr lang="en-US" sz="1400" b="1" dirty="0">
+                <a:solidFill>
+                  <a:srgbClr val="12161C"/>
+                </a:solidFill>
+                <a:latin typeface="Calibri" pitchFamily="34" charset="0"/>
+                <a:ea typeface="Calibri" pitchFamily="34" charset="-122"/>
+                <a:cs typeface="Calibri" pitchFamily="34" charset="-120"/>
+              </a:rPr>
+              <a:t>Latency and cost</a:t>
+            </a:r>
+            <a:endParaRPr lang="en-US" sz="1400" dirty="0"/>
+          </a:p>
+        </p:txBody>
+      </p:sp>
+      <p:sp>
+        <p:nvSpPr>
           <p:cNvPr id="18" name="Text 16"/>
           <p:cNvSpPr txBox="1"/>
           <p:nvPr/>
         </p:nvSpPr>
         <p:spPr>
           <a:xfrm>
-            <a:off x="777240" y="5413248"/>
-            <a:ext cx="6309360" cy="274320"/>
-          </a:xfrm>
-          <a:prstGeom prst="rect">
-            <a:avLst/>
-          </a:prstGeom>
-          <a:noFill/>
-          <a:ln/>
-        </p:spPr>
-        <p:txBody>
-          <a:bodyPr wrap="square" lIns="0" tIns="0" rIns="0" bIns="0" rtlCol="0" anchor="t"/>
-          <a:lstStyle/>
-          <a:p>
-            <a:pPr indent="0" marL="0">
-              <a:buNone/>
-            </a:pPr>
-            <a:r>
-              <a:rPr lang="en-US" sz="1350" b="1" dirty="0">
-                <a:solidFill>
-                  <a:srgbClr val="12161C"/>
-                </a:solidFill>
-                <a:latin typeface="Calibri" pitchFamily="34" charset="0"/>
-                <a:ea typeface="Calibri" pitchFamily="34" charset="-122"/>
-                <a:cs typeface="Calibri" pitchFamily="34" charset="-120"/>
-              </a:rPr>
-              <a:t>Not a complete defense</a:t>
-            </a:r>
-            <a:endParaRPr lang="en-US" sz="1350" dirty="0"/>
-          </a:p>
-        </p:txBody>
-      </p:sp>
-      <p:sp>
-        <p:nvSpPr>
-          <p:cNvPr id="19" name="Text 17"/>
-          <p:cNvSpPr txBox="1"/>
-          <p:nvPr/>
-        </p:nvSpPr>
-        <p:spPr>
-          <a:xfrm>
-            <a:off x="777240" y="5705856"/>
-            <a:ext cx="6309360" cy="365760"/>
-          </a:xfrm>
-          <a:prstGeom prst="rect">
-            <a:avLst/>
-          </a:prstGeom>
-          <a:noFill/>
-          <a:ln/>
-        </p:spPr>
-        <p:txBody>
-          <a:bodyPr wrap="square" lIns="0" tIns="0" rIns="0" bIns="0" rtlCol="0" anchor="t"/>
-          <a:lstStyle/>
-          <a:p>
-            <a:pPr indent="0" marL="0">
-              <a:buNone/>
-            </a:pPr>
-            <a:r>
-              <a:rPr lang="en-US" sz="1150" dirty="0">
+            <a:off x="777240" y="5596128"/>
+            <a:ext cx="6583680" cy="365760"/>
+          </a:xfrm>
+          <a:prstGeom prst="rect">
+            <a:avLst/>
+          </a:prstGeom>
+          <a:noFill/>
+          <a:ln/>
+        </p:spPr>
+        <p:txBody>
+          <a:bodyPr wrap="square" lIns="0" tIns="0" rIns="0" bIns="0" rtlCol="0" anchor="t"/>
+          <a:lstStyle/>
+          <a:p>
+            <a:pPr indent="0" marL="0">
+              <a:buNone/>
+            </a:pPr>
+            <a:r>
+              <a:rPr lang="en-US" sz="1200" dirty="0">
                 <a:solidFill>
                   <a:srgbClr val="5B6472"/>
                 </a:solidFill>
@@ -3520,64 +3630,27 @@
                 <a:ea typeface="Calibri" pitchFamily="34" charset="-122"/>
                 <a:cs typeface="Calibri" pitchFamily="34" charset="-120"/>
               </a:rPr>
-              <a:t>Sentinel reduces what reaches the model. It does not replace least-privilege tools or human approval for risky actions.</a:t>
-            </a:r>
-            <a:endParaRPr lang="en-US" sz="1150" dirty="0"/>
-          </a:p>
-        </p:txBody>
-      </p:sp>
-      <p:sp>
-        <p:nvSpPr>
-          <p:cNvPr id="20" name="Text 18"/>
-          <p:cNvSpPr txBox="1"/>
-          <p:nvPr/>
-        </p:nvSpPr>
-        <p:spPr>
-          <a:xfrm>
-            <a:off x="7680960" y="1627632"/>
-            <a:ext cx="3931920" cy="256032"/>
-          </a:xfrm>
-          <a:prstGeom prst="rect">
-            <a:avLst/>
-          </a:prstGeom>
-          <a:noFill/>
-          <a:ln/>
-        </p:spPr>
-        <p:txBody>
-          <a:bodyPr wrap="square" lIns="0" tIns="0" rIns="0" bIns="0" rtlCol="0" anchor="t"/>
-          <a:lstStyle/>
-          <a:p>
-            <a:pPr indent="0" marL="0">
-              <a:buNone/>
-            </a:pPr>
-            <a:r>
-              <a:rPr lang="en-US" sz="1100" b="1" spc="250" kern="0" dirty="0">
-                <a:solidFill>
-                  <a:srgbClr val="FF5A36"/>
-                </a:solidFill>
-                <a:latin typeface="Calibri" pitchFamily="34" charset="0"/>
-                <a:ea typeface="Calibri" pitchFamily="34" charset="-122"/>
-                <a:cs typeface="Calibri" pitchFamily="34" charset="-120"/>
-              </a:rPr>
-              <a:t>WHAT WE WOULD BUILD NEXT</a:t>
-            </a:r>
-            <a:endParaRPr lang="en-US" sz="1100" dirty="0"/>
-          </a:p>
-        </p:txBody>
-      </p:sp>
-      <p:sp>
-        <p:nvSpPr>
-          <p:cNvPr id="21" name="Shape 19"/>
+              <a:t>A small local model and a tiny fusion: about a fifth of a second, no API calls.</a:t>
+            </a:r>
+            <a:endParaRPr lang="en-US" sz="1200" dirty="0"/>
+          </a:p>
+        </p:txBody>
+      </p:sp>
+      <p:sp>
+        <p:nvSpPr>
+          <p:cNvPr id="19" name="Shape 17"/>
           <p:cNvSpPr/>
           <p:nvPr/>
         </p:nvSpPr>
         <p:spPr>
           <a:xfrm>
-            <a:off x="7680960" y="2011680"/>
-            <a:ext cx="384048" cy="384048"/>
-          </a:xfrm>
-          <a:prstGeom prst="ellipse">
-            <a:avLst/>
+            <a:off x="7818120" y="1600200"/>
+            <a:ext cx="3822192" cy="4389120"/>
+          </a:xfrm>
+          <a:prstGeom prst="roundRect">
+            <a:avLst>
+              <a:gd name="adj" fmla="val 2871"/>
+            </a:avLst>
           </a:prstGeom>
           <a:solidFill>
             <a:srgbClr val="0E1116"/>
@@ -3588,7 +3661,92 @@
             </a:solidFill>
             <a:prstDash val="solid"/>
           </a:ln>
-        </p:spPr>
+          <a:effectLst>
+            <a:outerShdw sx="100000" sy="100000" kx="0" ky="0" algn="bl" rotWithShape="0" blurRad="127000" dist="25400" dir="5400000">
+              <a:srgbClr val="000000">
+                <a:alpha val="10000"/>
+              </a:srgbClr>
+            </a:outerShdw>
+          </a:effectLst>
+        </p:spPr>
+      </p:sp>
+      <p:sp>
+        <p:nvSpPr>
+          <p:cNvPr id="20" name="Text 18"/>
+          <p:cNvSpPr txBox="1"/>
+          <p:nvPr/>
+        </p:nvSpPr>
+        <p:spPr>
+          <a:xfrm>
+            <a:off x="8092440" y="1783080"/>
+            <a:ext cx="3383280" cy="256032"/>
+          </a:xfrm>
+          <a:prstGeom prst="rect">
+            <a:avLst/>
+          </a:prstGeom>
+          <a:noFill/>
+          <a:ln/>
+        </p:spPr>
+        <p:txBody>
+          <a:bodyPr wrap="square" lIns="0" tIns="0" rIns="0" bIns="0" rtlCol="0" anchor="t"/>
+          <a:lstStyle/>
+          <a:p>
+            <a:pPr indent="0" marL="0">
+              <a:buNone/>
+            </a:pPr>
+            <a:r>
+              <a:rPr lang="en-US" sz="1000" b="1" spc="180" kern="0" dirty="0">
+                <a:solidFill>
+                  <a:srgbClr val="FF5A36"/>
+                </a:solidFill>
+                <a:latin typeface="Calibri" pitchFamily="34" charset="0"/>
+                <a:ea typeface="Calibri" pitchFamily="34" charset="-122"/>
+                <a:cs typeface="Calibri" pitchFamily="34" charset="-120"/>
+              </a:rPr>
+              <a:t>ATTACK LAB · 20 CASES RUN LIVE</a:t>
+            </a:r>
+            <a:endParaRPr lang="en-US" sz="1000" dirty="0"/>
+          </a:p>
+        </p:txBody>
+      </p:sp>
+      <p:sp>
+        <p:nvSpPr>
+          <p:cNvPr id="21" name="Text 19"/>
+          <p:cNvSpPr txBox="1"/>
+          <p:nvPr/>
+        </p:nvSpPr>
+        <p:spPr>
+          <a:xfrm>
+            <a:off x="8092440" y="2240280"/>
+            <a:ext cx="3291840" cy="274320"/>
+          </a:xfrm>
+          <a:prstGeom prst="rect">
+            <a:avLst/>
+          </a:prstGeom>
+          <a:noFill/>
+          <a:ln/>
+        </p:spPr>
+        <p:txBody>
+          <a:bodyPr wrap="square" lIns="0" tIns="0" rIns="0" bIns="0" rtlCol="0" anchor="t"/>
+          <a:lstStyle/>
+          <a:p>
+            <a:pPr indent="0" marL="0">
+              <a:buNone/>
+            </a:pPr>
+            <a:r>
+              <a:rPr lang="en-US" sz="1200" dirty="0">
+                <a:solidFill>
+                  <a:srgbClr val="8A93A0"/>
+                </a:solidFill>
+                <a:latin typeface="Calibri" pitchFamily="34" charset="0"/>
+                <a:ea typeface="Calibri" pitchFamily="34" charset="-122"/>
+                <a:cs typeface="Calibri" pitchFamily="34" charset="-120"/>
+              </a:rPr>
+              <a:t>Attacks removed</a:t>
+            </a:r>
+            <a:endParaRPr lang="en-US" sz="1200" dirty="0"/>
+          </a:p>
+        </p:txBody>
       </p:sp>
       <p:sp>
         <p:nvSpPr>
@@ -3598,85 +3756,1034 @@
         </p:nvSpPr>
         <p:spPr>
           <a:xfrm>
+            <a:off x="8092440" y="2496312"/>
+            <a:ext cx="3383280" cy="640080"/>
+          </a:xfrm>
+          <a:prstGeom prst="rect">
+            <a:avLst/>
+          </a:prstGeom>
+          <a:noFill/>
+          <a:ln/>
+        </p:spPr>
+        <p:txBody>
+          <a:bodyPr wrap="square" lIns="0" tIns="0" rIns="0" bIns="0" rtlCol="0" anchor="t"/>
+          <a:lstStyle/>
+          <a:p>
+            <a:pPr indent="0" marL="0">
+              <a:buNone/>
+            </a:pPr>
+            <a:r>
+              <a:rPr lang="en-US" sz="3600" b="1" dirty="0">
+                <a:solidFill>
+                  <a:srgbClr val="FF5A36"/>
+                </a:solidFill>
+                <a:latin typeface="Cambria" pitchFamily="34" charset="0"/>
+                <a:ea typeface="Cambria" pitchFamily="34" charset="-122"/>
+                <a:cs typeface="Cambria" pitchFamily="34" charset="-120"/>
+              </a:rPr>
+              <a:t>12</a:t>
+            </a:r>
+            <a:pPr indent="0" marL="0">
+              <a:buNone/>
+            </a:pPr>
+            <a:r>
+              <a:rPr lang="en-US" sz="1600" dirty="0">
+                <a:solidFill>
+                  <a:srgbClr val="8A93A0"/>
+                </a:solidFill>
+                <a:latin typeface="Calibri" pitchFamily="34" charset="0"/>
+                <a:ea typeface="Calibri" pitchFamily="34" charset="-122"/>
+                <a:cs typeface="Calibri" pitchFamily="34" charset="-120"/>
+              </a:rPr>
+              <a:t> / 14</a:t>
+            </a:r>
+            <a:pPr indent="0" marL="0">
+              <a:buNone/>
+            </a:pPr>
+            <a:r>
+              <a:rPr lang="en-US" sz="1300" dirty="0">
+                <a:solidFill>
+                  <a:srgbClr val="8A93A0"/>
+                </a:solidFill>
+                <a:latin typeface="Calibri" pitchFamily="34" charset="0"/>
+                <a:ea typeface="Calibri" pitchFamily="34" charset="-122"/>
+                <a:cs typeface="Calibri" pitchFamily="34" charset="-120"/>
+              </a:rPr>
+              <a:t>      baseline 9</a:t>
+            </a:r>
+            <a:endParaRPr lang="en-US" sz="1400" dirty="0"/>
+          </a:p>
+        </p:txBody>
+      </p:sp>
+      <p:sp>
+        <p:nvSpPr>
+          <p:cNvPr id="23" name="Text 21"/>
+          <p:cNvSpPr txBox="1"/>
+          <p:nvPr/>
+        </p:nvSpPr>
+        <p:spPr>
+          <a:xfrm>
+            <a:off x="8092440" y="3429000"/>
+            <a:ext cx="3291840" cy="274320"/>
+          </a:xfrm>
+          <a:prstGeom prst="rect">
+            <a:avLst/>
+          </a:prstGeom>
+          <a:noFill/>
+          <a:ln/>
+        </p:spPr>
+        <p:txBody>
+          <a:bodyPr wrap="square" lIns="0" tIns="0" rIns="0" bIns="0" rtlCol="0" anchor="t"/>
+          <a:lstStyle/>
+          <a:p>
+            <a:pPr indent="0" marL="0">
+              <a:buNone/>
+            </a:pPr>
+            <a:r>
+              <a:rPr lang="en-US" sz="1200" dirty="0">
+                <a:solidFill>
+                  <a:srgbClr val="8A93A0"/>
+                </a:solidFill>
+                <a:latin typeface="Calibri" pitchFamily="34" charset="0"/>
+                <a:ea typeface="Calibri" pitchFamily="34" charset="-122"/>
+                <a:cs typeface="Calibri" pitchFamily="34" charset="-120"/>
+              </a:rPr>
+              <a:t>Harmless look-alikes passed</a:t>
+            </a:r>
+            <a:endParaRPr lang="en-US" sz="1200" dirty="0"/>
+          </a:p>
+        </p:txBody>
+      </p:sp>
+      <p:sp>
+        <p:nvSpPr>
+          <p:cNvPr id="24" name="Text 22"/>
+          <p:cNvSpPr txBox="1"/>
+          <p:nvPr/>
+        </p:nvSpPr>
+        <p:spPr>
+          <a:xfrm>
+            <a:off x="8092440" y="3685032"/>
+            <a:ext cx="3383280" cy="640080"/>
+          </a:xfrm>
+          <a:prstGeom prst="rect">
+            <a:avLst/>
+          </a:prstGeom>
+          <a:noFill/>
+          <a:ln/>
+        </p:spPr>
+        <p:txBody>
+          <a:bodyPr wrap="square" lIns="0" tIns="0" rIns="0" bIns="0" rtlCol="0" anchor="t"/>
+          <a:lstStyle/>
+          <a:p>
+            <a:pPr indent="0" marL="0">
+              <a:buNone/>
+            </a:pPr>
+            <a:r>
+              <a:rPr lang="en-US" sz="3600" b="1" dirty="0">
+                <a:solidFill>
+                  <a:srgbClr val="FF5A36"/>
+                </a:solidFill>
+                <a:latin typeface="Cambria" pitchFamily="34" charset="0"/>
+                <a:ea typeface="Cambria" pitchFamily="34" charset="-122"/>
+                <a:cs typeface="Cambria" pitchFamily="34" charset="-120"/>
+              </a:rPr>
+              <a:t>4</a:t>
+            </a:r>
+            <a:pPr indent="0" marL="0">
+              <a:buNone/>
+            </a:pPr>
+            <a:r>
+              <a:rPr lang="en-US" sz="1600" dirty="0">
+                <a:solidFill>
+                  <a:srgbClr val="8A93A0"/>
+                </a:solidFill>
+                <a:latin typeface="Calibri" pitchFamily="34" charset="0"/>
+                <a:ea typeface="Calibri" pitchFamily="34" charset="-122"/>
+                <a:cs typeface="Calibri" pitchFamily="34" charset="-120"/>
+              </a:rPr>
+              <a:t> / 4</a:t>
+            </a:r>
+            <a:pPr indent="0" marL="0">
+              <a:buNone/>
+            </a:pPr>
+            <a:r>
+              <a:rPr lang="en-US" sz="1300" dirty="0">
+                <a:solidFill>
+                  <a:srgbClr val="8A93A0"/>
+                </a:solidFill>
+                <a:latin typeface="Calibri" pitchFamily="34" charset="0"/>
+                <a:ea typeface="Calibri" pitchFamily="34" charset="-122"/>
+                <a:cs typeface="Calibri" pitchFamily="34" charset="-120"/>
+              </a:rPr>
+              <a:t>      baseline 2</a:t>
+            </a:r>
+            <a:endParaRPr lang="en-US" sz="1400" dirty="0"/>
+          </a:p>
+        </p:txBody>
+      </p:sp>
+      <p:sp>
+        <p:nvSpPr>
+          <p:cNvPr id="25" name="Text 23"/>
+          <p:cNvSpPr txBox="1"/>
+          <p:nvPr/>
+        </p:nvSpPr>
+        <p:spPr>
+          <a:xfrm>
+            <a:off x="8092440" y="4663440"/>
+            <a:ext cx="3291840" cy="1097280"/>
+          </a:xfrm>
+          <a:prstGeom prst="rect">
+            <a:avLst/>
+          </a:prstGeom>
+          <a:noFill/>
+          <a:ln/>
+        </p:spPr>
+        <p:txBody>
+          <a:bodyPr wrap="square" lIns="0" tIns="0" rIns="0" bIns="0" rtlCol="0" anchor="t"/>
+          <a:lstStyle/>
+          <a:p>
+            <a:pPr indent="0" marL="0">
+              <a:buNone/>
+            </a:pPr>
+            <a:r>
+              <a:rPr lang="en-US" sz="1200" i="1" dirty="0">
+                <a:solidFill>
+                  <a:srgbClr val="C9CFD8"/>
+                </a:solidFill>
+                <a:latin typeface="Calibri" pitchFamily="34" charset="0"/>
+                <a:ea typeface="Calibri" pitchFamily="34" charset="-122"/>
+                <a:cs typeface="Calibri" pitchFamily="34" charset="-120"/>
+              </a:rPr>
+              <a:t>Two attacks slip through, and we show them: a sales push that reads like normal page copy, and one reworded override. An override in French is a stated limit.</a:t>
+            </a:r>
+            <a:endParaRPr lang="en-US" sz="1200" dirty="0"/>
+          </a:p>
+        </p:txBody>
+      </p:sp>
+      <p:pic>
+        <p:nvPicPr>
+          <p:cNvPr id="26" name="Image 0" descr="/Users/ananyasingh/Developer/Sentinel/app/static/brand/mark-flat-256.png">    </p:cNvPr>
+          <p:cNvPicPr>
+            <a:picLocks noChangeAspect="1"/>
+          </p:cNvPicPr>
+          <p:nvPr/>
+        </p:nvPicPr>
+        <p:blipFill>
+          <a:blip r:embed="rId1"/>
+          <a:stretch>
+            <a:fillRect/>
+          </a:stretch>
+        </p:blipFill>
+        <p:spPr>
+          <a:xfrm>
+            <a:off x="548640" y="6382512"/>
+            <a:ext cx="201168" cy="201168"/>
+          </a:xfrm>
+          <a:prstGeom prst="rect">
+            <a:avLst/>
+          </a:prstGeom>
+        </p:spPr>
+      </p:pic>
+      <p:sp>
+        <p:nvSpPr>
+          <p:cNvPr id="27" name="Text 24"/>
+          <p:cNvSpPr txBox="1"/>
+          <p:nvPr/>
+        </p:nvSpPr>
+        <p:spPr>
+          <a:xfrm>
+            <a:off x="841248" y="6419088"/>
+            <a:ext cx="7315200" cy="228600"/>
+          </a:xfrm>
+          <a:prstGeom prst="rect">
+            <a:avLst/>
+          </a:prstGeom>
+          <a:noFill/>
+          <a:ln/>
+        </p:spPr>
+        <p:txBody>
+          <a:bodyPr wrap="square" lIns="0" tIns="0" rIns="0" bIns="0" rtlCol="0" anchor="t"/>
+          <a:lstStyle/>
+          <a:p>
+            <a:pPr indent="0" marL="0">
+              <a:buNone/>
+            </a:pPr>
+            <a:r>
+              <a:rPr lang="en-US" sz="1000" dirty="0">
+                <a:solidFill>
+                  <a:srgbClr val="8A93A0"/>
+                </a:solidFill>
+                <a:latin typeface="Calibri" pitchFamily="34" charset="0"/>
+                <a:ea typeface="Calibri" pitchFamily="34" charset="-122"/>
+                <a:cs typeface="Calibri" pitchFamily="34" charset="-120"/>
+              </a:rPr>
+              <a:t>Bug Slayers  ·  Sentinel  ·  LLM Engineering Challenge, Problem 5</a:t>
+            </a:r>
+            <a:endParaRPr lang="en-US" sz="1000" dirty="0"/>
+          </a:p>
+        </p:txBody>
+      </p:sp>
+      <p:sp>
+        <p:nvSpPr>
+          <p:cNvPr id="28" name="Text 25"/>
+          <p:cNvSpPr txBox="1"/>
+          <p:nvPr/>
+        </p:nvSpPr>
+        <p:spPr>
+          <a:xfrm>
+            <a:off x="10725912" y="6419088"/>
+            <a:ext cx="914400" cy="228600"/>
+          </a:xfrm>
+          <a:prstGeom prst="rect">
+            <a:avLst/>
+          </a:prstGeom>
+          <a:noFill/>
+          <a:ln/>
+        </p:spPr>
+        <p:txBody>
+          <a:bodyPr wrap="square" lIns="0" tIns="0" rIns="0" bIns="0" rtlCol="0" anchor="t"/>
+          <a:lstStyle/>
+          <a:p>
+            <a:pPr algn="r" indent="0" marL="0">
+              <a:buNone/>
+            </a:pPr>
+            <a:r>
+              <a:rPr lang="en-US" sz="1000" dirty="0">
+                <a:solidFill>
+                  <a:srgbClr val="8A93A0"/>
+                </a:solidFill>
+                <a:latin typeface="Calibri" pitchFamily="34" charset="0"/>
+                <a:ea typeface="Calibri" pitchFamily="34" charset="-122"/>
+                <a:cs typeface="Calibri" pitchFamily="34" charset="-120"/>
+              </a:rPr>
+              <a:t>10 / 11</a:t>
+            </a:r>
+            <a:endParaRPr lang="en-US" sz="1000" dirty="0"/>
+          </a:p>
+        </p:txBody>
+      </p:sp>
+    </p:spTree>
+  </p:cSld>
+  <p:clrMapOvr>
+    <a:masterClrMapping/>
+  </p:clrMapOvr>
+</p:sld>
+</file>
+
+<file path=ppt/slides/slide11.xml><?xml version="1.0" encoding="utf-8"?>
+<p:sld xmlns:a="http://schemas.openxmlformats.org/drawingml/2006/main" xmlns:r="http://schemas.openxmlformats.org/officeDocument/2006/relationships" xmlns:p="http://schemas.openxmlformats.org/presentationml/2006/main">
+  <p:cSld name="Slide 11">
+    <p:bg>
+      <p:bgPr>
+        <a:solidFill>
+          <a:srgbClr val="F5F6F8"/>
+        </a:solidFill>
+      </p:bgPr>
+    </p:bg>
+    <p:spTree>
+      <p:nvGrpSpPr>
+        <p:cNvPr id="1" name=""/>
+        <p:cNvGrpSpPr/>
+        <p:nvPr/>
+      </p:nvGrpSpPr>
+      <p:grpSpPr>
+        <a:xfrm>
+          <a:off x="0" y="0"/>
+          <a:ext cx="0" cy="0"/>
+          <a:chOff x="0" y="0"/>
+          <a:chExt cx="0" cy="0"/>
+        </a:xfrm>
+      </p:grpSpPr>
+      <p:sp>
+        <p:nvSpPr>
+          <p:cNvPr id="2" name="Text 0"/>
+          <p:cNvSpPr txBox="1"/>
+          <p:nvPr/>
+        </p:nvSpPr>
+        <p:spPr>
+          <a:xfrm>
+            <a:off x="548640" y="411480"/>
+            <a:ext cx="8229600" cy="274320"/>
+          </a:xfrm>
+          <a:prstGeom prst="rect">
+            <a:avLst/>
+          </a:prstGeom>
+          <a:noFill/>
+          <a:ln/>
+        </p:spPr>
+        <p:txBody>
+          <a:bodyPr wrap="square" lIns="0" tIns="0" rIns="0" bIns="0" rtlCol="0" anchor="t"/>
+          <a:lstStyle/>
+          <a:p>
+            <a:pPr indent="0" marL="0">
+              <a:buNone/>
+            </a:pPr>
+            <a:r>
+              <a:rPr lang="en-US" sz="1200" b="1" spc="300" kern="0" dirty="0">
+                <a:solidFill>
+                  <a:srgbClr val="FF5A36"/>
+                </a:solidFill>
+                <a:latin typeface="Calibri" pitchFamily="34" charset="0"/>
+                <a:ea typeface="Calibri" pitchFamily="34" charset="-122"/>
+                <a:cs typeface="Calibri" pitchFamily="34" charset="-120"/>
+              </a:rPr>
+              <a:t>10  ·  LIMITATIONS AND NEXT STEPS</a:t>
+            </a:r>
+            <a:endParaRPr lang="en-US" sz="1200" dirty="0"/>
+          </a:p>
+        </p:txBody>
+      </p:sp>
+      <p:sp>
+        <p:nvSpPr>
+          <p:cNvPr id="3" name="Text 1"/>
+          <p:cNvSpPr txBox="1"/>
+          <p:nvPr/>
+        </p:nvSpPr>
+        <p:spPr>
+          <a:xfrm>
+            <a:off x="548640" y="713232"/>
+            <a:ext cx="11064240" cy="685800"/>
+          </a:xfrm>
+          <a:prstGeom prst="rect">
+            <a:avLst/>
+          </a:prstGeom>
+          <a:noFill/>
+          <a:ln/>
+        </p:spPr>
+        <p:txBody>
+          <a:bodyPr wrap="square" lIns="0" tIns="0" rIns="0" bIns="0" rtlCol="0" anchor="t"/>
+          <a:lstStyle/>
+          <a:p>
+            <a:pPr indent="0" marL="0">
+              <a:buNone/>
+            </a:pPr>
+            <a:r>
+              <a:rPr lang="en-US" sz="3200" b="1" dirty="0">
+                <a:solidFill>
+                  <a:srgbClr val="12161C"/>
+                </a:solidFill>
+                <a:latin typeface="Cambria" pitchFamily="34" charset="0"/>
+                <a:ea typeface="Cambria" pitchFamily="34" charset="-122"/>
+                <a:cs typeface="Cambria" pitchFamily="34" charset="-120"/>
+              </a:rPr>
+              <a:t>What it does not do yet</a:t>
+            </a:r>
+            <a:endParaRPr lang="en-US" sz="3200" dirty="0"/>
+          </a:p>
+        </p:txBody>
+      </p:sp>
+      <p:sp>
+        <p:nvSpPr>
+          <p:cNvPr id="4" name="Text 2"/>
+          <p:cNvSpPr txBox="1"/>
+          <p:nvPr/>
+        </p:nvSpPr>
+        <p:spPr>
+          <a:xfrm>
+            <a:off x="548640" y="1627632"/>
+            <a:ext cx="4572000" cy="256032"/>
+          </a:xfrm>
+          <a:prstGeom prst="rect">
+            <a:avLst/>
+          </a:prstGeom>
+          <a:noFill/>
+          <a:ln/>
+        </p:spPr>
+        <p:txBody>
+          <a:bodyPr wrap="square" lIns="0" tIns="0" rIns="0" bIns="0" rtlCol="0" anchor="t"/>
+          <a:lstStyle/>
+          <a:p>
+            <a:pPr indent="0" marL="0">
+              <a:buNone/>
+            </a:pPr>
+            <a:r>
+              <a:rPr lang="en-US" sz="1100" b="1" spc="250" kern="0" dirty="0">
+                <a:solidFill>
+                  <a:srgbClr val="FF5A36"/>
+                </a:solidFill>
+                <a:latin typeface="Calibri" pitchFamily="34" charset="0"/>
+                <a:ea typeface="Calibri" pitchFamily="34" charset="-122"/>
+                <a:cs typeface="Calibri" pitchFamily="34" charset="-120"/>
+              </a:rPr>
+              <a:t>STATED PLAINLY</a:t>
+            </a:r>
+            <a:endParaRPr lang="en-US" sz="1100" dirty="0"/>
+          </a:p>
+        </p:txBody>
+      </p:sp>
+      <p:sp>
+        <p:nvSpPr>
+          <p:cNvPr id="5" name="Shape 3"/>
+          <p:cNvSpPr/>
+          <p:nvPr/>
+        </p:nvSpPr>
+        <p:spPr>
+          <a:xfrm>
+            <a:off x="548640" y="1965960"/>
+            <a:ext cx="6766560" cy="749808"/>
+          </a:xfrm>
+          <a:prstGeom prst="roundRect">
+            <a:avLst>
+              <a:gd name="adj" fmla="val 14634"/>
+            </a:avLst>
+          </a:prstGeom>
+          <a:solidFill>
+            <a:srgbClr val="FFFFFF"/>
+          </a:solidFill>
+          <a:ln w="9525">
+            <a:solidFill>
+              <a:srgbClr val="E1E4E9"/>
+            </a:solidFill>
+            <a:prstDash val="solid"/>
+          </a:ln>
+        </p:spPr>
+      </p:sp>
+      <p:sp>
+        <p:nvSpPr>
+          <p:cNvPr id="6" name="Text 4"/>
+          <p:cNvSpPr txBox="1"/>
+          <p:nvPr/>
+        </p:nvSpPr>
+        <p:spPr>
+          <a:xfrm>
+            <a:off x="777240" y="2048256"/>
+            <a:ext cx="6309360" cy="274320"/>
+          </a:xfrm>
+          <a:prstGeom prst="rect">
+            <a:avLst/>
+          </a:prstGeom>
+          <a:noFill/>
+          <a:ln/>
+        </p:spPr>
+        <p:txBody>
+          <a:bodyPr wrap="square" lIns="0" tIns="0" rIns="0" bIns="0" rtlCol="0" anchor="t"/>
+          <a:lstStyle/>
+          <a:p>
+            <a:pPr indent="0" marL="0">
+              <a:buNone/>
+            </a:pPr>
+            <a:r>
+              <a:rPr lang="en-US" sz="1350" b="1" dirty="0">
+                <a:solidFill>
+                  <a:srgbClr val="12161C"/>
+                </a:solidFill>
+                <a:latin typeface="Calibri" pitchFamily="34" charset="0"/>
+                <a:ea typeface="Calibri" pitchFamily="34" charset="-122"/>
+                <a:cs typeface="Calibri" pitchFamily="34" charset="-120"/>
+              </a:rPr>
+              <a:t>English only</a:t>
+            </a:r>
+            <a:endParaRPr lang="en-US" sz="1350" dirty="0"/>
+          </a:p>
+        </p:txBody>
+      </p:sp>
+      <p:sp>
+        <p:nvSpPr>
+          <p:cNvPr id="7" name="Text 5"/>
+          <p:cNvSpPr txBox="1"/>
+          <p:nvPr/>
+        </p:nvSpPr>
+        <p:spPr>
+          <a:xfrm>
+            <a:off x="777240" y="2340864"/>
+            <a:ext cx="6309360" cy="365760"/>
+          </a:xfrm>
+          <a:prstGeom prst="rect">
+            <a:avLst/>
+          </a:prstGeom>
+          <a:noFill/>
+          <a:ln/>
+        </p:spPr>
+        <p:txBody>
+          <a:bodyPr wrap="square" lIns="0" tIns="0" rIns="0" bIns="0" rtlCol="0" anchor="t"/>
+          <a:lstStyle/>
+          <a:p>
+            <a:pPr indent="0" marL="0">
+              <a:buNone/>
+            </a:pPr>
+            <a:r>
+              <a:rPr lang="en-US" sz="1150" dirty="0">
+                <a:solidFill>
+                  <a:srgbClr val="5B6472"/>
+                </a:solidFill>
+                <a:latin typeface="Calibri" pitchFamily="34" charset="0"/>
+                <a:ea typeface="Calibri" pitchFamily="34" charset="-122"/>
+                <a:cs typeface="Calibri" pitchFamily="34" charset="-120"/>
+              </a:rPr>
+              <a:t>Training data is English; an override in another language is likely missed.</a:t>
+            </a:r>
+            <a:endParaRPr lang="en-US" sz="1150" dirty="0"/>
+          </a:p>
+        </p:txBody>
+      </p:sp>
+      <p:sp>
+        <p:nvSpPr>
+          <p:cNvPr id="8" name="Shape 6"/>
+          <p:cNvSpPr/>
+          <p:nvPr/>
+        </p:nvSpPr>
+        <p:spPr>
+          <a:xfrm>
+            <a:off x="548640" y="2807208"/>
+            <a:ext cx="6766560" cy="749808"/>
+          </a:xfrm>
+          <a:prstGeom prst="roundRect">
+            <a:avLst>
+              <a:gd name="adj" fmla="val 14634"/>
+            </a:avLst>
+          </a:prstGeom>
+          <a:solidFill>
+            <a:srgbClr val="FFFFFF"/>
+          </a:solidFill>
+          <a:ln w="9525">
+            <a:solidFill>
+              <a:srgbClr val="E1E4E9"/>
+            </a:solidFill>
+            <a:prstDash val="solid"/>
+          </a:ln>
+        </p:spPr>
+      </p:sp>
+      <p:sp>
+        <p:nvSpPr>
+          <p:cNvPr id="9" name="Text 7"/>
+          <p:cNvSpPr txBox="1"/>
+          <p:nvPr/>
+        </p:nvSpPr>
+        <p:spPr>
+          <a:xfrm>
+            <a:off x="777240" y="2889504"/>
+            <a:ext cx="6309360" cy="274320"/>
+          </a:xfrm>
+          <a:prstGeom prst="rect">
+            <a:avLst/>
+          </a:prstGeom>
+          <a:noFill/>
+          <a:ln/>
+        </p:spPr>
+        <p:txBody>
+          <a:bodyPr wrap="square" lIns="0" tIns="0" rIns="0" bIns="0" rtlCol="0" anchor="t"/>
+          <a:lstStyle/>
+          <a:p>
+            <a:pPr indent="0" marL="0">
+              <a:buNone/>
+            </a:pPr>
+            <a:r>
+              <a:rPr lang="en-US" sz="1350" b="1" dirty="0">
+                <a:solidFill>
+                  <a:srgbClr val="12161C"/>
+                </a:solidFill>
+                <a:latin typeface="Calibri" pitchFamily="34" charset="0"/>
+                <a:ea typeface="Calibri" pitchFamily="34" charset="-122"/>
+                <a:cs typeface="Calibri" pitchFamily="34" charset="-120"/>
+              </a:rPr>
+              <a:t>Subtle attacks near the threshold</a:t>
+            </a:r>
+            <a:endParaRPr lang="en-US" sz="1350" dirty="0"/>
+          </a:p>
+        </p:txBody>
+      </p:sp>
+      <p:sp>
+        <p:nvSpPr>
+          <p:cNvPr id="10" name="Text 8"/>
+          <p:cNvSpPr txBox="1"/>
+          <p:nvPr/>
+        </p:nvSpPr>
+        <p:spPr>
+          <a:xfrm>
+            <a:off x="777240" y="3182112"/>
+            <a:ext cx="6309360" cy="365760"/>
+          </a:xfrm>
+          <a:prstGeom prst="rect">
+            <a:avLst/>
+          </a:prstGeom>
+          <a:noFill/>
+          <a:ln/>
+        </p:spPr>
+        <p:txBody>
+          <a:bodyPr wrap="square" lIns="0" tIns="0" rIns="0" bIns="0" rtlCol="0" anchor="t"/>
+          <a:lstStyle/>
+          <a:p>
+            <a:pPr indent="0" marL="0">
+              <a:buNone/>
+            </a:pPr>
+            <a:r>
+              <a:rPr lang="en-US" sz="1150" dirty="0">
+                <a:solidFill>
+                  <a:srgbClr val="5B6472"/>
+                </a:solidFill>
+                <a:latin typeface="Calibri" pitchFamily="34" charset="0"/>
+                <a:ea typeface="Calibri" pitchFamily="34" charset="-122"/>
+                <a:cs typeface="Calibri" pitchFamily="34" charset="-120"/>
+              </a:rPr>
+              <a:t>A sales push that reads like normal page copy can slip through: 2 of 14 attacks in the Attack lab.</a:t>
+            </a:r>
+            <a:endParaRPr lang="en-US" sz="1150" dirty="0"/>
+          </a:p>
+        </p:txBody>
+      </p:sp>
+      <p:sp>
+        <p:nvSpPr>
+          <p:cNvPr id="11" name="Shape 9"/>
+          <p:cNvSpPr/>
+          <p:nvPr/>
+        </p:nvSpPr>
+        <p:spPr>
+          <a:xfrm>
+            <a:off x="548640" y="3648456"/>
+            <a:ext cx="6766560" cy="749808"/>
+          </a:xfrm>
+          <a:prstGeom prst="roundRect">
+            <a:avLst>
+              <a:gd name="adj" fmla="val 14634"/>
+            </a:avLst>
+          </a:prstGeom>
+          <a:solidFill>
+            <a:srgbClr val="FFFFFF"/>
+          </a:solidFill>
+          <a:ln w="9525">
+            <a:solidFill>
+              <a:srgbClr val="E1E4E9"/>
+            </a:solidFill>
+            <a:prstDash val="solid"/>
+          </a:ln>
+        </p:spPr>
+      </p:sp>
+      <p:sp>
+        <p:nvSpPr>
+          <p:cNvPr id="12" name="Text 10"/>
+          <p:cNvSpPr txBox="1"/>
+          <p:nvPr/>
+        </p:nvSpPr>
+        <p:spPr>
+          <a:xfrm>
+            <a:off x="777240" y="3730752"/>
+            <a:ext cx="6309360" cy="274320"/>
+          </a:xfrm>
+          <a:prstGeom prst="rect">
+            <a:avLst/>
+          </a:prstGeom>
+          <a:noFill/>
+          <a:ln/>
+        </p:spPr>
+        <p:txBody>
+          <a:bodyPr wrap="square" lIns="0" tIns="0" rIns="0" bIns="0" rtlCol="0" anchor="t"/>
+          <a:lstStyle/>
+          <a:p>
+            <a:pPr indent="0" marL="0">
+              <a:buNone/>
+            </a:pPr>
+            <a:r>
+              <a:rPr lang="en-US" sz="1350" b="1" dirty="0">
+                <a:solidFill>
+                  <a:srgbClr val="12161C"/>
+                </a:solidFill>
+                <a:latin typeface="Calibri" pitchFamily="34" charset="0"/>
+                <a:ea typeface="Calibri" pitchFamily="34" charset="-122"/>
+                <a:cs typeface="Calibri" pitchFamily="34" charset="-120"/>
+              </a:rPr>
+              <a:t>Benchmark plus generated attacks</a:t>
+            </a:r>
+            <a:endParaRPr lang="en-US" sz="1350" dirty="0"/>
+          </a:p>
+        </p:txBody>
+      </p:sp>
+      <p:sp>
+        <p:nvSpPr>
+          <p:cNvPr id="13" name="Text 11"/>
+          <p:cNvSpPr txBox="1"/>
+          <p:nvPr/>
+        </p:nvSpPr>
+        <p:spPr>
+          <a:xfrm>
+            <a:off x="777240" y="4023360"/>
+            <a:ext cx="6309360" cy="365760"/>
+          </a:xfrm>
+          <a:prstGeom prst="rect">
+            <a:avLst/>
+          </a:prstGeom>
+          <a:noFill/>
+          <a:ln/>
+        </p:spPr>
+        <p:txBody>
+          <a:bodyPr wrap="square" lIns="0" tIns="0" rIns="0" bIns="0" rtlCol="0" anchor="t"/>
+          <a:lstStyle/>
+          <a:p>
+            <a:pPr indent="0" marL="0">
+              <a:buNone/>
+            </a:pPr>
+            <a:r>
+              <a:rPr lang="en-US" sz="1150" dirty="0">
+                <a:solidFill>
+                  <a:srgbClr val="5B6472"/>
+                </a:solidFill>
+                <a:latin typeface="Calibri" pitchFamily="34" charset="0"/>
+                <a:ea typeface="Calibri" pitchFamily="34" charset="-122"/>
+                <a:cs typeface="Calibri" pitchFamily="34" charset="-120"/>
+              </a:rPr>
+              <a:t>An attack style far from every training source may slip through.</a:t>
+            </a:r>
+            <a:endParaRPr lang="en-US" sz="1150" dirty="0"/>
+          </a:p>
+        </p:txBody>
+      </p:sp>
+      <p:sp>
+        <p:nvSpPr>
+          <p:cNvPr id="14" name="Shape 12"/>
+          <p:cNvSpPr/>
+          <p:nvPr/>
+        </p:nvSpPr>
+        <p:spPr>
+          <a:xfrm>
+            <a:off x="548640" y="4489704"/>
+            <a:ext cx="6766560" cy="749808"/>
+          </a:xfrm>
+          <a:prstGeom prst="roundRect">
+            <a:avLst>
+              <a:gd name="adj" fmla="val 14634"/>
+            </a:avLst>
+          </a:prstGeom>
+          <a:solidFill>
+            <a:srgbClr val="FFFFFF"/>
+          </a:solidFill>
+          <a:ln w="9525">
+            <a:solidFill>
+              <a:srgbClr val="E1E4E9"/>
+            </a:solidFill>
+            <a:prstDash val="solid"/>
+          </a:ln>
+        </p:spPr>
+      </p:sp>
+      <p:sp>
+        <p:nvSpPr>
+          <p:cNvPr id="15" name="Text 13"/>
+          <p:cNvSpPr txBox="1"/>
+          <p:nvPr/>
+        </p:nvSpPr>
+        <p:spPr>
+          <a:xfrm>
+            <a:off x="777240" y="4572000"/>
+            <a:ext cx="6309360" cy="274320"/>
+          </a:xfrm>
+          <a:prstGeom prst="rect">
+            <a:avLst/>
+          </a:prstGeom>
+          <a:noFill/>
+          <a:ln/>
+        </p:spPr>
+        <p:txBody>
+          <a:bodyPr wrap="square" lIns="0" tIns="0" rIns="0" bIns="0" rtlCol="0" anchor="t"/>
+          <a:lstStyle/>
+          <a:p>
+            <a:pPr indent="0" marL="0">
+              <a:buNone/>
+            </a:pPr>
+            <a:r>
+              <a:rPr lang="en-US" sz="1350" b="1" dirty="0">
+                <a:solidFill>
+                  <a:srgbClr val="12161C"/>
+                </a:solidFill>
+                <a:latin typeface="Calibri" pitchFamily="34" charset="0"/>
+                <a:ea typeface="Calibri" pitchFamily="34" charset="-122"/>
+                <a:cs typeface="Calibri" pitchFamily="34" charset="-120"/>
+              </a:rPr>
+              <a:t>Small boundary test</a:t>
+            </a:r>
+            <a:endParaRPr lang="en-US" sz="1350" dirty="0"/>
+          </a:p>
+        </p:txBody>
+      </p:sp>
+      <p:sp>
+        <p:nvSpPr>
+          <p:cNvPr id="16" name="Text 14"/>
+          <p:cNvSpPr txBox="1"/>
+          <p:nvPr/>
+        </p:nvSpPr>
+        <p:spPr>
+          <a:xfrm>
+            <a:off x="777240" y="4864608"/>
+            <a:ext cx="6309360" cy="365760"/>
+          </a:xfrm>
+          <a:prstGeom prst="rect">
+            <a:avLst/>
+          </a:prstGeom>
+          <a:noFill/>
+          <a:ln/>
+        </p:spPr>
+        <p:txBody>
+          <a:bodyPr wrap="square" lIns="0" tIns="0" rIns="0" bIns="0" rtlCol="0" anchor="t"/>
+          <a:lstStyle/>
+          <a:p>
+            <a:pPr indent="0" marL="0">
+              <a:buNone/>
+            </a:pPr>
+            <a:r>
+              <a:rPr lang="en-US" sz="1150" dirty="0">
+                <a:solidFill>
+                  <a:srgbClr val="5B6472"/>
+                </a:solidFill>
+                <a:latin typeface="Calibri" pitchFamily="34" charset="0"/>
+                <a:ea typeface="Calibri" pitchFamily="34" charset="-122"/>
+                <a:cs typeface="Calibri" pitchFamily="34" charset="-120"/>
+              </a:rPr>
+              <a:t>Boundary accuracy is 100% on 16 hand-written cases; the rule is structural, the set is small.</a:t>
+            </a:r>
+            <a:endParaRPr lang="en-US" sz="1150" dirty="0"/>
+          </a:p>
+        </p:txBody>
+      </p:sp>
+      <p:sp>
+        <p:nvSpPr>
+          <p:cNvPr id="17" name="Shape 15"/>
+          <p:cNvSpPr/>
+          <p:nvPr/>
+        </p:nvSpPr>
+        <p:spPr>
+          <a:xfrm>
+            <a:off x="548640" y="5330952"/>
+            <a:ext cx="6766560" cy="749808"/>
+          </a:xfrm>
+          <a:prstGeom prst="roundRect">
+            <a:avLst>
+              <a:gd name="adj" fmla="val 14634"/>
+            </a:avLst>
+          </a:prstGeom>
+          <a:solidFill>
+            <a:srgbClr val="FFFFFF"/>
+          </a:solidFill>
+          <a:ln w="9525">
+            <a:solidFill>
+              <a:srgbClr val="E1E4E9"/>
+            </a:solidFill>
+            <a:prstDash val="solid"/>
+          </a:ln>
+        </p:spPr>
+      </p:sp>
+      <p:sp>
+        <p:nvSpPr>
+          <p:cNvPr id="18" name="Text 16"/>
+          <p:cNvSpPr txBox="1"/>
+          <p:nvPr/>
+        </p:nvSpPr>
+        <p:spPr>
+          <a:xfrm>
+            <a:off x="777240" y="5413248"/>
+            <a:ext cx="6309360" cy="274320"/>
+          </a:xfrm>
+          <a:prstGeom prst="rect">
+            <a:avLst/>
+          </a:prstGeom>
+          <a:noFill/>
+          <a:ln/>
+        </p:spPr>
+        <p:txBody>
+          <a:bodyPr wrap="square" lIns="0" tIns="0" rIns="0" bIns="0" rtlCol="0" anchor="t"/>
+          <a:lstStyle/>
+          <a:p>
+            <a:pPr indent="0" marL="0">
+              <a:buNone/>
+            </a:pPr>
+            <a:r>
+              <a:rPr lang="en-US" sz="1350" b="1" dirty="0">
+                <a:solidFill>
+                  <a:srgbClr val="12161C"/>
+                </a:solidFill>
+                <a:latin typeface="Calibri" pitchFamily="34" charset="0"/>
+                <a:ea typeface="Calibri" pitchFamily="34" charset="-122"/>
+                <a:cs typeface="Calibri" pitchFamily="34" charset="-120"/>
+              </a:rPr>
+              <a:t>Not a complete defense</a:t>
+            </a:r>
+            <a:endParaRPr lang="en-US" sz="1350" dirty="0"/>
+          </a:p>
+        </p:txBody>
+      </p:sp>
+      <p:sp>
+        <p:nvSpPr>
+          <p:cNvPr id="19" name="Text 17"/>
+          <p:cNvSpPr txBox="1"/>
+          <p:nvPr/>
+        </p:nvSpPr>
+        <p:spPr>
+          <a:xfrm>
+            <a:off x="777240" y="5705856"/>
+            <a:ext cx="6309360" cy="365760"/>
+          </a:xfrm>
+          <a:prstGeom prst="rect">
+            <a:avLst/>
+          </a:prstGeom>
+          <a:noFill/>
+          <a:ln/>
+        </p:spPr>
+        <p:txBody>
+          <a:bodyPr wrap="square" lIns="0" tIns="0" rIns="0" bIns="0" rtlCol="0" anchor="t"/>
+          <a:lstStyle/>
+          <a:p>
+            <a:pPr indent="0" marL="0">
+              <a:buNone/>
+            </a:pPr>
+            <a:r>
+              <a:rPr lang="en-US" sz="1150" dirty="0">
+                <a:solidFill>
+                  <a:srgbClr val="5B6472"/>
+                </a:solidFill>
+                <a:latin typeface="Calibri" pitchFamily="34" charset="0"/>
+                <a:ea typeface="Calibri" pitchFamily="34" charset="-122"/>
+                <a:cs typeface="Calibri" pitchFamily="34" charset="-120"/>
+              </a:rPr>
+              <a:t>Sentinel reduces what reaches the model. It does not replace least-privilege tools or human approval for risky actions.</a:t>
+            </a:r>
+            <a:endParaRPr lang="en-US" sz="1150" dirty="0"/>
+          </a:p>
+        </p:txBody>
+      </p:sp>
+      <p:sp>
+        <p:nvSpPr>
+          <p:cNvPr id="20" name="Text 18"/>
+          <p:cNvSpPr txBox="1"/>
+          <p:nvPr/>
+        </p:nvSpPr>
+        <p:spPr>
+          <a:xfrm>
+            <a:off x="7680960" y="1627632"/>
+            <a:ext cx="3931920" cy="256032"/>
+          </a:xfrm>
+          <a:prstGeom prst="rect">
+            <a:avLst/>
+          </a:prstGeom>
+          <a:noFill/>
+          <a:ln/>
+        </p:spPr>
+        <p:txBody>
+          <a:bodyPr wrap="square" lIns="0" tIns="0" rIns="0" bIns="0" rtlCol="0" anchor="t"/>
+          <a:lstStyle/>
+          <a:p>
+            <a:pPr indent="0" marL="0">
+              <a:buNone/>
+            </a:pPr>
+            <a:r>
+              <a:rPr lang="en-US" sz="1100" b="1" spc="250" kern="0" dirty="0">
+                <a:solidFill>
+                  <a:srgbClr val="FF5A36"/>
+                </a:solidFill>
+                <a:latin typeface="Calibri" pitchFamily="34" charset="0"/>
+                <a:ea typeface="Calibri" pitchFamily="34" charset="-122"/>
+                <a:cs typeface="Calibri" pitchFamily="34" charset="-120"/>
+              </a:rPr>
+              <a:t>WHAT WE WOULD BUILD NEXT</a:t>
+            </a:r>
+            <a:endParaRPr lang="en-US" sz="1100" dirty="0"/>
+          </a:p>
+        </p:txBody>
+      </p:sp>
+      <p:sp>
+        <p:nvSpPr>
+          <p:cNvPr id="21" name="Shape 19"/>
+          <p:cNvSpPr/>
+          <p:nvPr/>
+        </p:nvSpPr>
+        <p:spPr>
+          <a:xfrm>
             <a:off x="7680960" y="2011680"/>
-            <a:ext cx="384048" cy="384048"/>
-          </a:xfrm>
-          <a:prstGeom prst="rect">
-            <a:avLst/>
-          </a:prstGeom>
-          <a:noFill/>
-          <a:ln/>
-        </p:spPr>
-        <p:txBody>
-          <a:bodyPr wrap="square" lIns="0" tIns="0" rIns="0" bIns="0" rtlCol="0" anchor="ctr"/>
-          <a:lstStyle/>
-          <a:p>
-            <a:pPr algn="ctr" indent="0" marL="0">
-              <a:buNone/>
-            </a:pPr>
-            <a:r>
-              <a:rPr lang="en-US" sz="1300" b="1" dirty="0">
-                <a:solidFill>
-                  <a:srgbClr val="FFFFFF"/>
-                </a:solidFill>
-                <a:latin typeface="Calibri" pitchFamily="34" charset="0"/>
-                <a:ea typeface="Calibri" pitchFamily="34" charset="-122"/>
-                <a:cs typeface="Calibri" pitchFamily="34" charset="-120"/>
-              </a:rPr>
-              <a:t>1</a:t>
-            </a:r>
-            <a:endParaRPr lang="en-US" sz="1300" dirty="0"/>
-          </a:p>
-        </p:txBody>
-      </p:sp>
-      <p:sp>
-        <p:nvSpPr>
-          <p:cNvPr id="23" name="Text 21"/>
-          <p:cNvSpPr txBox="1"/>
-          <p:nvPr/>
-        </p:nvSpPr>
-        <p:spPr>
-          <a:xfrm>
-            <a:off x="8275320" y="1965960"/>
-            <a:ext cx="3337560" cy="868680"/>
-          </a:xfrm>
-          <a:prstGeom prst="rect">
-            <a:avLst/>
-          </a:prstGeom>
-          <a:noFill/>
-          <a:ln/>
-        </p:spPr>
-        <p:txBody>
-          <a:bodyPr wrap="square" lIns="0" tIns="0" rIns="0" bIns="0" rtlCol="0" anchor="t"/>
-          <a:lstStyle/>
-          <a:p>
-            <a:pPr indent="0" marL="0">
-              <a:buNone/>
-            </a:pPr>
-            <a:r>
-              <a:rPr lang="en-US" sz="1350" dirty="0">
-                <a:solidFill>
-                  <a:srgbClr val="12161C"/>
-                </a:solidFill>
-                <a:latin typeface="Calibri" pitchFamily="34" charset="0"/>
-                <a:ea typeface="Calibri" pitchFamily="34" charset="-122"/>
-                <a:cs typeface="Calibri" pitchFamily="34" charset="-120"/>
-              </a:rPr>
-              <a:t>Multilingual training data and evaluation slice</a:t>
-            </a:r>
-            <a:endParaRPr lang="en-US" sz="1350" dirty="0"/>
-          </a:p>
-        </p:txBody>
-      </p:sp>
-      <p:sp>
-        <p:nvSpPr>
-          <p:cNvPr id="24" name="Shape 22"/>
-          <p:cNvSpPr/>
-          <p:nvPr/>
-        </p:nvSpPr>
-        <p:spPr>
-          <a:xfrm>
-            <a:off x="7680960" y="3063240"/>
             <a:ext cx="384048" cy="384048"/>
           </a:xfrm>
           <a:prstGeom prst="ellipse">
@@ -3695,91 +4802,91 @@
       </p:sp>
       <p:sp>
         <p:nvSpPr>
-          <p:cNvPr id="25" name="Text 23"/>
-          <p:cNvSpPr txBox="1"/>
+          <p:cNvPr id="22" name="Text 20"/>
+          <p:cNvSpPr txBox="1"/>
+          <p:nvPr/>
+        </p:nvSpPr>
+        <p:spPr>
+          <a:xfrm>
+            <a:off x="7680960" y="2011680"/>
+            <a:ext cx="384048" cy="384048"/>
+          </a:xfrm>
+          <a:prstGeom prst="rect">
+            <a:avLst/>
+          </a:prstGeom>
+          <a:noFill/>
+          <a:ln/>
+        </p:spPr>
+        <p:txBody>
+          <a:bodyPr wrap="square" lIns="0" tIns="0" rIns="0" bIns="0" rtlCol="0" anchor="ctr"/>
+          <a:lstStyle/>
+          <a:p>
+            <a:pPr algn="ctr" indent="0" marL="0">
+              <a:buNone/>
+            </a:pPr>
+            <a:r>
+              <a:rPr lang="en-US" sz="1300" b="1" dirty="0">
+                <a:solidFill>
+                  <a:srgbClr val="FFFFFF"/>
+                </a:solidFill>
+                <a:latin typeface="Calibri" pitchFamily="34" charset="0"/>
+                <a:ea typeface="Calibri" pitchFamily="34" charset="-122"/>
+                <a:cs typeface="Calibri" pitchFamily="34" charset="-120"/>
+              </a:rPr>
+              <a:t>1</a:t>
+            </a:r>
+            <a:endParaRPr lang="en-US" sz="1300" dirty="0"/>
+          </a:p>
+        </p:txBody>
+      </p:sp>
+      <p:sp>
+        <p:nvSpPr>
+          <p:cNvPr id="23" name="Text 21"/>
+          <p:cNvSpPr txBox="1"/>
+          <p:nvPr/>
+        </p:nvSpPr>
+        <p:spPr>
+          <a:xfrm>
+            <a:off x="8275320" y="1965960"/>
+            <a:ext cx="3337560" cy="868680"/>
+          </a:xfrm>
+          <a:prstGeom prst="rect">
+            <a:avLst/>
+          </a:prstGeom>
+          <a:noFill/>
+          <a:ln/>
+        </p:spPr>
+        <p:txBody>
+          <a:bodyPr wrap="square" lIns="0" tIns="0" rIns="0" bIns="0" rtlCol="0" anchor="t"/>
+          <a:lstStyle/>
+          <a:p>
+            <a:pPr indent="0" marL="0">
+              <a:buNone/>
+            </a:pPr>
+            <a:r>
+              <a:rPr lang="en-US" sz="1350" dirty="0">
+                <a:solidFill>
+                  <a:srgbClr val="12161C"/>
+                </a:solidFill>
+                <a:latin typeface="Calibri" pitchFamily="34" charset="0"/>
+                <a:ea typeface="Calibri" pitchFamily="34" charset="-122"/>
+                <a:cs typeface="Calibri" pitchFamily="34" charset="-120"/>
+              </a:rPr>
+              <a:t>Multilingual training data and evaluation slice</a:t>
+            </a:r>
+            <a:endParaRPr lang="en-US" sz="1350" dirty="0"/>
+          </a:p>
+        </p:txBody>
+      </p:sp>
+      <p:sp>
+        <p:nvSpPr>
+          <p:cNvPr id="24" name="Shape 22"/>
+          <p:cNvSpPr/>
           <p:nvPr/>
         </p:nvSpPr>
         <p:spPr>
           <a:xfrm>
             <a:off x="7680960" y="3063240"/>
-            <a:ext cx="384048" cy="384048"/>
-          </a:xfrm>
-          <a:prstGeom prst="rect">
-            <a:avLst/>
-          </a:prstGeom>
-          <a:noFill/>
-          <a:ln/>
-        </p:spPr>
-        <p:txBody>
-          <a:bodyPr wrap="square" lIns="0" tIns="0" rIns="0" bIns="0" rtlCol="0" anchor="ctr"/>
-          <a:lstStyle/>
-          <a:p>
-            <a:pPr algn="ctr" indent="0" marL="0">
-              <a:buNone/>
-            </a:pPr>
-            <a:r>
-              <a:rPr lang="en-US" sz="1300" b="1" dirty="0">
-                <a:solidFill>
-                  <a:srgbClr val="FFFFFF"/>
-                </a:solidFill>
-                <a:latin typeface="Calibri" pitchFamily="34" charset="0"/>
-                <a:ea typeface="Calibri" pitchFamily="34" charset="-122"/>
-                <a:cs typeface="Calibri" pitchFamily="34" charset="-120"/>
-              </a:rPr>
-              <a:t>2</a:t>
-            </a:r>
-            <a:endParaRPr lang="en-US" sz="1300" dirty="0"/>
-          </a:p>
-        </p:txBody>
-      </p:sp>
-      <p:sp>
-        <p:nvSpPr>
-          <p:cNvPr id="26" name="Text 24"/>
-          <p:cNvSpPr txBox="1"/>
-          <p:nvPr/>
-        </p:nvSpPr>
-        <p:spPr>
-          <a:xfrm>
-            <a:off x="8275320" y="3017520"/>
-            <a:ext cx="3337560" cy="868680"/>
-          </a:xfrm>
-          <a:prstGeom prst="rect">
-            <a:avLst/>
-          </a:prstGeom>
-          <a:noFill/>
-          <a:ln/>
-        </p:spPr>
-        <p:txBody>
-          <a:bodyPr wrap="square" lIns="0" tIns="0" rIns="0" bIns="0" rtlCol="0" anchor="t"/>
-          <a:lstStyle/>
-          <a:p>
-            <a:pPr indent="0" marL="0">
-              <a:buNone/>
-            </a:pPr>
-            <a:r>
-              <a:rPr lang="en-US" sz="1350" dirty="0">
-                <a:solidFill>
-                  <a:srgbClr val="12161C"/>
-                </a:solidFill>
-                <a:latin typeface="Calibri" pitchFamily="34" charset="0"/>
-                <a:ea typeface="Calibri" pitchFamily="34" charset="-122"/>
-                <a:cs typeface="Calibri" pitchFamily="34" charset="-120"/>
-              </a:rPr>
-              <a:t>A larger verifier for the uncertain middle band</a:t>
-            </a:r>
-            <a:endParaRPr lang="en-US" sz="1350" dirty="0"/>
-          </a:p>
-        </p:txBody>
-      </p:sp>
-      <p:sp>
-        <p:nvSpPr>
-          <p:cNvPr id="27" name="Shape 25"/>
-          <p:cNvSpPr/>
-          <p:nvPr/>
-        </p:nvSpPr>
-        <p:spPr>
-          <a:xfrm>
-            <a:off x="7680960" y="4114800"/>
             <a:ext cx="384048" cy="384048"/>
           </a:xfrm>
           <a:prstGeom prst="ellipse">
@@ -3798,91 +4905,91 @@
       </p:sp>
       <p:sp>
         <p:nvSpPr>
-          <p:cNvPr id="28" name="Text 26"/>
-          <p:cNvSpPr txBox="1"/>
+          <p:cNvPr id="25" name="Text 23"/>
+          <p:cNvSpPr txBox="1"/>
+          <p:nvPr/>
+        </p:nvSpPr>
+        <p:spPr>
+          <a:xfrm>
+            <a:off x="7680960" y="3063240"/>
+            <a:ext cx="384048" cy="384048"/>
+          </a:xfrm>
+          <a:prstGeom prst="rect">
+            <a:avLst/>
+          </a:prstGeom>
+          <a:noFill/>
+          <a:ln/>
+        </p:spPr>
+        <p:txBody>
+          <a:bodyPr wrap="square" lIns="0" tIns="0" rIns="0" bIns="0" rtlCol="0" anchor="ctr"/>
+          <a:lstStyle/>
+          <a:p>
+            <a:pPr algn="ctr" indent="0" marL="0">
+              <a:buNone/>
+            </a:pPr>
+            <a:r>
+              <a:rPr lang="en-US" sz="1300" b="1" dirty="0">
+                <a:solidFill>
+                  <a:srgbClr val="FFFFFF"/>
+                </a:solidFill>
+                <a:latin typeface="Calibri" pitchFamily="34" charset="0"/>
+                <a:ea typeface="Calibri" pitchFamily="34" charset="-122"/>
+                <a:cs typeface="Calibri" pitchFamily="34" charset="-120"/>
+              </a:rPr>
+              <a:t>2</a:t>
+            </a:r>
+            <a:endParaRPr lang="en-US" sz="1300" dirty="0"/>
+          </a:p>
+        </p:txBody>
+      </p:sp>
+      <p:sp>
+        <p:nvSpPr>
+          <p:cNvPr id="26" name="Text 24"/>
+          <p:cNvSpPr txBox="1"/>
+          <p:nvPr/>
+        </p:nvSpPr>
+        <p:spPr>
+          <a:xfrm>
+            <a:off x="8275320" y="3017520"/>
+            <a:ext cx="3337560" cy="868680"/>
+          </a:xfrm>
+          <a:prstGeom prst="rect">
+            <a:avLst/>
+          </a:prstGeom>
+          <a:noFill/>
+          <a:ln/>
+        </p:spPr>
+        <p:txBody>
+          <a:bodyPr wrap="square" lIns="0" tIns="0" rIns="0" bIns="0" rtlCol="0" anchor="t"/>
+          <a:lstStyle/>
+          <a:p>
+            <a:pPr indent="0" marL="0">
+              <a:buNone/>
+            </a:pPr>
+            <a:r>
+              <a:rPr lang="en-US" sz="1350" dirty="0">
+                <a:solidFill>
+                  <a:srgbClr val="12161C"/>
+                </a:solidFill>
+                <a:latin typeface="Calibri" pitchFamily="34" charset="0"/>
+                <a:ea typeface="Calibri" pitchFamily="34" charset="-122"/>
+                <a:cs typeface="Calibri" pitchFamily="34" charset="-120"/>
+              </a:rPr>
+              <a:t>A larger verifier for the uncertain middle band</a:t>
+            </a:r>
+            <a:endParaRPr lang="en-US" sz="1350" dirty="0"/>
+          </a:p>
+        </p:txBody>
+      </p:sp>
+      <p:sp>
+        <p:nvSpPr>
+          <p:cNvPr id="27" name="Shape 25"/>
+          <p:cNvSpPr/>
           <p:nvPr/>
         </p:nvSpPr>
         <p:spPr>
           <a:xfrm>
             <a:off x="7680960" y="4114800"/>
-            <a:ext cx="384048" cy="384048"/>
-          </a:xfrm>
-          <a:prstGeom prst="rect">
-            <a:avLst/>
-          </a:prstGeom>
-          <a:noFill/>
-          <a:ln/>
-        </p:spPr>
-        <p:txBody>
-          <a:bodyPr wrap="square" lIns="0" tIns="0" rIns="0" bIns="0" rtlCol="0" anchor="ctr"/>
-          <a:lstStyle/>
-          <a:p>
-            <a:pPr algn="ctr" indent="0" marL="0">
-              <a:buNone/>
-            </a:pPr>
-            <a:r>
-              <a:rPr lang="en-US" sz="1300" b="1" dirty="0">
-                <a:solidFill>
-                  <a:srgbClr val="FFFFFF"/>
-                </a:solidFill>
-                <a:latin typeface="Calibri" pitchFamily="34" charset="0"/>
-                <a:ea typeface="Calibri" pitchFamily="34" charset="-122"/>
-                <a:cs typeface="Calibri" pitchFamily="34" charset="-120"/>
-              </a:rPr>
-              <a:t>3</a:t>
-            </a:r>
-            <a:endParaRPr lang="en-US" sz="1300" dirty="0"/>
-          </a:p>
-        </p:txBody>
-      </p:sp>
-      <p:sp>
-        <p:nvSpPr>
-          <p:cNvPr id="29" name="Text 27"/>
-          <p:cNvSpPr txBox="1"/>
-          <p:nvPr/>
-        </p:nvSpPr>
-        <p:spPr>
-          <a:xfrm>
-            <a:off x="8275320" y="4069080"/>
-            <a:ext cx="3337560" cy="868680"/>
-          </a:xfrm>
-          <a:prstGeom prst="rect">
-            <a:avLst/>
-          </a:prstGeom>
-          <a:noFill/>
-          <a:ln/>
-        </p:spPr>
-        <p:txBody>
-          <a:bodyPr wrap="square" lIns="0" tIns="0" rIns="0" bIns="0" rtlCol="0" anchor="t"/>
-          <a:lstStyle/>
-          <a:p>
-            <a:pPr indent="0" marL="0">
-              <a:buNone/>
-            </a:pPr>
-            <a:r>
-              <a:rPr lang="en-US" sz="1350" dirty="0">
-                <a:solidFill>
-                  <a:srgbClr val="12161C"/>
-                </a:solidFill>
-                <a:latin typeface="Calibri" pitchFamily="34" charset="0"/>
-                <a:ea typeface="Calibri" pitchFamily="34" charset="-122"/>
-                <a:cs typeface="Calibri" pitchFamily="34" charset="-120"/>
-              </a:rPr>
-              <a:t>Drop-in adapters for agent frameworks and MCP servers</a:t>
-            </a:r>
-            <a:endParaRPr lang="en-US" sz="1350" dirty="0"/>
-          </a:p>
-        </p:txBody>
-      </p:sp>
-      <p:sp>
-        <p:nvSpPr>
-          <p:cNvPr id="30" name="Shape 28"/>
-          <p:cNvSpPr/>
-          <p:nvPr/>
-        </p:nvSpPr>
-        <p:spPr>
-          <a:xfrm>
-            <a:off x="7680960" y="5166360"/>
             <a:ext cx="384048" cy="384048"/>
           </a:xfrm>
           <a:prstGeom prst="ellipse">
@@ -3901,8 +5008,86 @@
       </p:sp>
       <p:sp>
         <p:nvSpPr>
-          <p:cNvPr id="31" name="Text 29"/>
-          <p:cNvSpPr txBox="1"/>
+          <p:cNvPr id="28" name="Text 26"/>
+          <p:cNvSpPr txBox="1"/>
+          <p:nvPr/>
+        </p:nvSpPr>
+        <p:spPr>
+          <a:xfrm>
+            <a:off x="7680960" y="4114800"/>
+            <a:ext cx="384048" cy="384048"/>
+          </a:xfrm>
+          <a:prstGeom prst="rect">
+            <a:avLst/>
+          </a:prstGeom>
+          <a:noFill/>
+          <a:ln/>
+        </p:spPr>
+        <p:txBody>
+          <a:bodyPr wrap="square" lIns="0" tIns="0" rIns="0" bIns="0" rtlCol="0" anchor="ctr"/>
+          <a:lstStyle/>
+          <a:p>
+            <a:pPr algn="ctr" indent="0" marL="0">
+              <a:buNone/>
+            </a:pPr>
+            <a:r>
+              <a:rPr lang="en-US" sz="1300" b="1" dirty="0">
+                <a:solidFill>
+                  <a:srgbClr val="FFFFFF"/>
+                </a:solidFill>
+                <a:latin typeface="Calibri" pitchFamily="34" charset="0"/>
+                <a:ea typeface="Calibri" pitchFamily="34" charset="-122"/>
+                <a:cs typeface="Calibri" pitchFamily="34" charset="-120"/>
+              </a:rPr>
+              <a:t>3</a:t>
+            </a:r>
+            <a:endParaRPr lang="en-US" sz="1300" dirty="0"/>
+          </a:p>
+        </p:txBody>
+      </p:sp>
+      <p:sp>
+        <p:nvSpPr>
+          <p:cNvPr id="29" name="Text 27"/>
+          <p:cNvSpPr txBox="1"/>
+          <p:nvPr/>
+        </p:nvSpPr>
+        <p:spPr>
+          <a:xfrm>
+            <a:off x="8275320" y="4069080"/>
+            <a:ext cx="3337560" cy="868680"/>
+          </a:xfrm>
+          <a:prstGeom prst="rect">
+            <a:avLst/>
+          </a:prstGeom>
+          <a:noFill/>
+          <a:ln/>
+        </p:spPr>
+        <p:txBody>
+          <a:bodyPr wrap="square" lIns="0" tIns="0" rIns="0" bIns="0" rtlCol="0" anchor="t"/>
+          <a:lstStyle/>
+          <a:p>
+            <a:pPr indent="0" marL="0">
+              <a:buNone/>
+            </a:pPr>
+            <a:r>
+              <a:rPr lang="en-US" sz="1350" dirty="0">
+                <a:solidFill>
+                  <a:srgbClr val="12161C"/>
+                </a:solidFill>
+                <a:latin typeface="Calibri" pitchFamily="34" charset="0"/>
+                <a:ea typeface="Calibri" pitchFamily="34" charset="-122"/>
+                <a:cs typeface="Calibri" pitchFamily="34" charset="-120"/>
+              </a:rPr>
+              <a:t>Drop-in adapters for agent frameworks and MCP servers</a:t>
+            </a:r>
+            <a:endParaRPr lang="en-US" sz="1350" dirty="0"/>
+          </a:p>
+        </p:txBody>
+      </p:sp>
+      <p:sp>
+        <p:nvSpPr>
+          <p:cNvPr id="30" name="Shape 28"/>
+          <p:cNvSpPr/>
           <p:nvPr/>
         </p:nvSpPr>
         <p:spPr>
@@ -3910,6 +5095,31 @@
             <a:off x="7680960" y="5166360"/>
             <a:ext cx="384048" cy="384048"/>
           </a:xfrm>
+          <a:prstGeom prst="ellipse">
+            <a:avLst/>
+          </a:prstGeom>
+          <a:solidFill>
+            <a:srgbClr val="0E1116"/>
+          </a:solidFill>
+          <a:ln w="12700">
+            <a:solidFill>
+              <a:srgbClr val="0E1116"/>
+            </a:solidFill>
+            <a:prstDash val="solid"/>
+          </a:ln>
+        </p:spPr>
+      </p:sp>
+      <p:sp>
+        <p:nvSpPr>
+          <p:cNvPr id="31" name="Text 29"/>
+          <p:cNvSpPr txBox="1"/>
+          <p:nvPr/>
+        </p:nvSpPr>
+        <p:spPr>
+          <a:xfrm>
+            <a:off x="7680960" y="5166360"/>
+            <a:ext cx="384048" cy="384048"/>
+          </a:xfrm>
           <a:prstGeom prst="rect">
             <a:avLst/>
           </a:prstGeom>
@@ -3977,16 +5187,136 @@
           </a:p>
         </p:txBody>
       </p:sp>
+      <p:sp>
+        <p:nvSpPr>
+          <p:cNvPr id="33" name="Text 31"/>
+          <p:cNvSpPr txBox="1"/>
+          <p:nvPr/>
+        </p:nvSpPr>
+        <p:spPr>
+          <a:xfrm>
+            <a:off x="7680960" y="5742432"/>
+            <a:ext cx="4023360" cy="256032"/>
+          </a:xfrm>
+          <a:prstGeom prst="rect">
+            <a:avLst/>
+          </a:prstGeom>
+          <a:noFill/>
+          <a:ln/>
+        </p:spPr>
+        <p:txBody>
+          <a:bodyPr wrap="square" lIns="0" tIns="0" rIns="0" bIns="0" rtlCol="0" anchor="t"/>
+          <a:lstStyle/>
+          <a:p>
+            <a:pPr indent="0" marL="0">
+              <a:buNone/>
+            </a:pPr>
+            <a:r>
+              <a:rPr lang="en-US" sz="1200" b="1" spc="200" kern="0" dirty="0">
+                <a:solidFill>
+                  <a:srgbClr val="FF5A36"/>
+                </a:solidFill>
+                <a:latin typeface="Calibri" pitchFamily="34" charset="0"/>
+                <a:ea typeface="Calibri" pitchFamily="34" charset="-122"/>
+                <a:cs typeface="Calibri" pitchFamily="34" charset="-120"/>
+              </a:rPr>
+              <a:t>CODE   </a:t>
+            </a:r>
+            <a:pPr indent="0" marL="0">
+              <a:buNone/>
+            </a:pPr>
+            <a:r>
+              <a:rPr lang="en-US" sz="1200" u="sng" dirty="0">
+                <a:solidFill>
+                  <a:srgbClr val="12161C"/>
+                </a:solidFill>
+                <a:latin typeface="Calibri" pitchFamily="34" charset="0"/>
+                <a:ea typeface="Calibri" pitchFamily="34" charset="-122"/>
+                <a:cs typeface="Calibri" pitchFamily="34" charset="-120"/>
+                <a:hlinkClick r:id="rId1" invalidUrl="" action="" tgtFrame="" tooltip="" history="1" highlightClick="0" endSnd="0">
+                  <a:extLst>
+                    <a:ext uri="{A12FA001-AC4F-418D-AE19-62706E023703}">
+                      <ahyp:hlinkClr xmlns:ahyp="http://schemas.microsoft.com/office/drawing/2018/hyperlinkcolor" val="tx"/>
+                    </a:ext>
+                  </a:extLst>
+                </a:hlinkClick>
+              </a:rPr>
+              <a:t>github.com/ananya24s/Sentinel</a:t>
+            </a:r>
+            <a:endParaRPr lang="en-US" sz="1200" dirty="0"/>
+          </a:p>
+        </p:txBody>
+      </p:sp>
+      <p:sp>
+        <p:nvSpPr>
+          <p:cNvPr id="34" name="Text 32"/>
+          <p:cNvSpPr txBox="1"/>
+          <p:nvPr/>
+        </p:nvSpPr>
+        <p:spPr>
+          <a:xfrm>
+            <a:off x="7680960" y="6035040"/>
+            <a:ext cx="4023360" cy="256032"/>
+          </a:xfrm>
+          <a:prstGeom prst="rect">
+            <a:avLst/>
+          </a:prstGeom>
+          <a:noFill/>
+          <a:ln/>
+        </p:spPr>
+        <p:txBody>
+          <a:bodyPr wrap="square" lIns="0" tIns="0" rIns="0" bIns="0" rtlCol="0" anchor="t"/>
+          <a:lstStyle/>
+          <a:p>
+            <a:pPr indent="0" marL="0">
+              <a:buNone/>
+            </a:pPr>
+            <a:r>
+              <a:rPr lang="en-US" sz="1200" b="1" spc="200" kern="0" dirty="0">
+                <a:solidFill>
+                  <a:srgbClr val="FF5A36"/>
+                </a:solidFill>
+                <a:latin typeface="Calibri" pitchFamily="34" charset="0"/>
+                <a:ea typeface="Calibri" pitchFamily="34" charset="-122"/>
+                <a:cs typeface="Calibri" pitchFamily="34" charset="-120"/>
+              </a:rPr>
+              <a:t>VIDEO  </a:t>
+            </a:r>
+            <a:pPr indent="0" marL="0">
+              <a:buNone/>
+            </a:pPr>
+            <a:r>
+              <a:rPr lang="en-US" sz="1200" u="sng" dirty="0">
+                <a:solidFill>
+                  <a:srgbClr val="12161C"/>
+                </a:solidFill>
+                <a:latin typeface="Calibri" pitchFamily="34" charset="0"/>
+                <a:ea typeface="Calibri" pitchFamily="34" charset="-122"/>
+                <a:cs typeface="Calibri" pitchFamily="34" charset="-120"/>
+                <a:hlinkClick r:id="rId2" invalidUrl="" action="" tgtFrame="" tooltip="" history="1" highlightClick="0" endSnd="0">
+                  <a:extLst>
+                    <a:ext uri="{A12FA001-AC4F-418D-AE19-62706E023703}">
+                      <ahyp:hlinkClr xmlns:ahyp="http://schemas.microsoft.com/office/drawing/2018/hyperlinkcolor" val="tx"/>
+                    </a:ext>
+                  </a:extLst>
+                </a:hlinkClick>
+              </a:rPr>
+              <a:t>Demo video (Google Drive)</a:t>
+            </a:r>
+            <a:endParaRPr lang="en-US" sz="1200" dirty="0"/>
+          </a:p>
+        </p:txBody>
+      </p:sp>
       <p:pic>
         <p:nvPicPr>
-          <p:cNvPr id="33" name="Image 0" descr="/Users/ananyasingh/Developer/Sentinel/app/static/brand/mark-flat-256.png">    </p:cNvPr>
+          <p:cNvPr id="35" name="Image 0" descr="/Users/ananyasingh/Developer/Sentinel/app/static/brand/mark-flat-256.png">    </p:cNvPr>
           <p:cNvPicPr>
             <a:picLocks noChangeAspect="1"/>
           </p:cNvPicPr>
           <p:nvPr/>
         </p:nvPicPr>
         <p:blipFill>
-          <a:blip r:embed="rId1"/>
+          <a:blip r:embed="rId3"/>
           <a:stretch>
             <a:fillRect/>
           </a:stretch>
@@ -4003,7 +5333,7 @@
       </p:pic>
       <p:sp>
         <p:nvSpPr>
-          <p:cNvPr id="34" name="Text 31"/>
+          <p:cNvPr id="36" name="Text 33"/>
           <p:cNvSpPr txBox="1"/>
           <p:nvPr/>
         </p:nvSpPr>
@@ -4042,7 +5372,7 @@
       </p:sp>
       <p:sp>
         <p:nvSpPr>
-          <p:cNvPr id="35" name="Text 32"/>
+          <p:cNvPr id="37" name="Text 34"/>
           <p:cNvSpPr txBox="1"/>
           <p:nvPr/>
         </p:nvSpPr>
@@ -4073,7 +5403,7 @@
                 <a:ea typeface="Calibri" pitchFamily="34" charset="-122"/>
                 <a:cs typeface="Calibri" pitchFamily="34" charset="-120"/>
               </a:rPr>
-              <a:t>10 / 10</a:t>
+              <a:t>11 / 11</a:t>
             </a:r>
             <a:endParaRPr lang="en-US" sz="1000" dirty="0"/>
           </a:p>
@@ -5188,7 +6518,7 @@
                 <a:ea typeface="Calibri" pitchFamily="34" charset="-122"/>
                 <a:cs typeface="Calibri" pitchFamily="34" charset="-120"/>
               </a:rPr>
-              <a:t>2 / 10</a:t>
+              <a:t>2 / 11</a:t>
             </a:r>
             <a:endParaRPr lang="en-US" sz="1000" dirty="0"/>
           </a:p>
@@ -6561,7 +7891,7 @@
                 <a:ea typeface="Calibri" pitchFamily="34" charset="-122"/>
                 <a:cs typeface="Calibri" pitchFamily="34" charset="-120"/>
               </a:rPr>
-              <a:t>3 / 10</a:t>
+              <a:t>3 / 11</a:t>
             </a:r>
             <a:endParaRPr lang="en-US" sz="1000" dirty="0"/>
           </a:p>
@@ -7694,7 +9024,7 @@
                 <a:ea typeface="Calibri" pitchFamily="34" charset="-122"/>
                 <a:cs typeface="Calibri" pitchFamily="34" charset="-120"/>
               </a:rPr>
-              <a:t>4 / 10</a:t>
+              <a:t>4 / 11</a:t>
             </a:r>
             <a:endParaRPr lang="en-US" sz="1000" dirty="0"/>
           </a:p>
@@ -8715,7 +10045,7 @@
                 <a:ea typeface="Calibri" pitchFamily="34" charset="-122"/>
                 <a:cs typeface="Calibri" pitchFamily="34" charset="-120"/>
               </a:rPr>
-              <a:t>5 / 10</a:t>
+              <a:t>5 / 11</a:t>
             </a:r>
             <a:endParaRPr lang="en-US" sz="1000" dirty="0"/>
           </a:p>
@@ -10543,7 +11873,7 @@
                 <a:ea typeface="Calibri" pitchFamily="34" charset="-122"/>
                 <a:cs typeface="Calibri" pitchFamily="34" charset="-120"/>
               </a:rPr>
-              <a:t>6 / 10</a:t>
+              <a:t>6 / 11</a:t>
             </a:r>
             <a:endParaRPr lang="en-US" sz="1000" dirty="0"/>
           </a:p>
@@ -10923,7 +12253,7 @@
                 <a:ea typeface="Calibri" pitchFamily="34" charset="-122"/>
                 <a:cs typeface="Calibri" pitchFamily="34" charset="-120"/>
               </a:rPr>
-              <a:t>Twenty cases: attacks, harmless look-alikes and known limits, each scored live for Sentinel and the baseline.</a:t>
+              <a:t>Twenty fixed cases scored live for Sentinel and the baseline, plus a box to add your own attack.</a:t>
             </a:r>
             <a:endParaRPr lang="en-US" sz="1200" dirty="0"/>
           </a:p>
@@ -10965,7 +12295,7 @@
       </p:sp>
       <p:pic>
         <p:nvPicPr>
-          <p:cNvPr id="13" name="Image 2" descr="/private/tmp/claude-501/-Users-ananyasingh-Downloads-WIN-IF-YOU-CAN-PS/bf2c8522-e0b9-476e-a641-e8df935a7bd3/scratchpad/shots/how.png">    </p:cNvPr>
+          <p:cNvPr id="13" name="Image 2" descr="/private/tmp/claude-501/-Users-ananyasingh-Downloads-WIN-IF-YOU-CAN-PS/bf2c8522-e0b9-476e-a641-e8df935a7bd3/scratchpad/shots/integrate.png">    </p:cNvPr>
           <p:cNvPicPr>
             <a:picLocks noChangeAspect="1"/>
           </p:cNvPicPr>
@@ -11019,7 +12349,7 @@
                 <a:ea typeface="Cambria" pitchFamily="34" charset="-122"/>
                 <a:cs typeface="Cambria" pitchFamily="34" charset="-120"/>
               </a:rPr>
-              <a:t>How it works</a:t>
+              <a:t>Integrate</a:t>
             </a:r>
             <a:endParaRPr lang="en-US" sz="1700" dirty="0"/>
           </a:p>
@@ -11058,7 +12388,7 @@
                 <a:ea typeface="Calibri" pitchFamily="34" charset="-122"/>
                 <a:cs typeface="Calibri" pitchFamily="34" charset="-120"/>
               </a:rPr>
-              <a:t>Step through the five stages on a real sample and see each stage's actual output.</a:t>
+              <a:t>Call the real API, see what the model receives with and without Sentinel, and copy the code.</a:t>
             </a:r>
             <a:endParaRPr lang="en-US" sz="1200" dirty="0"/>
           </a:p>
@@ -11073,7 +12403,7 @@
         <p:spPr>
           <a:xfrm>
             <a:off x="548640" y="5577840"/>
-            <a:ext cx="2564892" cy="384048"/>
+            <a:ext cx="1243584" cy="384048"/>
           </a:xfrm>
           <a:prstGeom prst="roundRect">
             <a:avLst>
@@ -11101,7 +12431,7 @@
                 <a:ea typeface="Calibri" pitchFamily="34" charset="-122"/>
                 <a:cs typeface="Calibri" pitchFamily="34" charset="-120"/>
               </a:rPr>
-              <a:t>Activity log with JSON export</a:t>
+              <a:t>Activity log</a:t>
             </a:r>
             <a:endParaRPr lang="en-US" sz="1150" dirty="0"/>
           </a:p>
@@ -11115,7 +12445,7 @@
         </p:nvSpPr>
         <p:spPr>
           <a:xfrm>
-            <a:off x="3250692" y="5577840"/>
+            <a:off x="1929384" y="5577840"/>
             <a:ext cx="1865376" cy="384048"/>
           </a:xfrm>
           <a:prstGeom prst="roundRect">
@@ -11158,7 +12488,7 @@
         </p:nvSpPr>
         <p:spPr>
           <a:xfrm>
-            <a:off x="5253228" y="5577840"/>
+            <a:off x="3931920" y="5577840"/>
             <a:ext cx="1865376" cy="384048"/>
           </a:xfrm>
           <a:prstGeom prst="roundRect">
@@ -11201,7 +12531,7 @@
         </p:nvSpPr>
         <p:spPr>
           <a:xfrm>
-            <a:off x="7255764" y="5577840"/>
+            <a:off x="5934456" y="5577840"/>
             <a:ext cx="1243584" cy="384048"/>
           </a:xfrm>
           <a:prstGeom prst="roundRect">
@@ -11244,7 +12574,7 @@
         </p:nvSpPr>
         <p:spPr>
           <a:xfrm>
-            <a:off x="8636508" y="5577840"/>
+            <a:off x="7315200" y="5577840"/>
             <a:ext cx="932688" cy="384048"/>
           </a:xfrm>
           <a:prstGeom prst="roundRect">
@@ -11287,6 +12617,49 @@
         </p:nvSpPr>
         <p:spPr>
           <a:xfrm>
+            <a:off x="8385048" y="5577840"/>
+            <a:ext cx="2176272" cy="384048"/>
+          </a:xfrm>
+          <a:prstGeom prst="roundRect">
+            <a:avLst>
+              <a:gd name="adj" fmla="val 50000"/>
+            </a:avLst>
+          </a:prstGeom>
+          <a:solidFill>
+            <a:srgbClr val="0E1116"/>
+          </a:solidFill>
+          <a:ln/>
+        </p:spPr>
+        <p:txBody>
+          <a:bodyPr wrap="square" lIns="0" tIns="0" rIns="0" bIns="0" rtlCol="0" anchor="ctr"/>
+          <a:lstStyle/>
+          <a:p>
+            <a:pPr algn="ctr" indent="0" marL="0">
+              <a:buNone/>
+            </a:pPr>
+            <a:r>
+              <a:rPr lang="en-US" sz="1150" b="1" dirty="0">
+                <a:solidFill>
+                  <a:srgbClr val="FFFFFF"/>
+                </a:solidFill>
+                <a:latin typeface="Calibri" pitchFamily="34" charset="0"/>
+                <a:ea typeface="Calibri" pitchFamily="34" charset="-122"/>
+                <a:cs typeface="Calibri" pitchFamily="34" charset="-120"/>
+              </a:rPr>
+              <a:t>Live re-run on test data</a:t>
+            </a:r>
+            <a:endParaRPr lang="en-US" sz="1150" dirty="0"/>
+          </a:p>
+        </p:txBody>
+      </p:sp>
+      <p:sp>
+        <p:nvSpPr>
+          <p:cNvPr id="22" name="Text 17"/>
+          <p:cNvSpPr txBox="1"/>
+          <p:nvPr/>
+        </p:nvSpPr>
+        <p:spPr>
+          <a:xfrm>
             <a:off x="548640" y="6053328"/>
             <a:ext cx="7315200" cy="274320"/>
           </a:xfrm>
@@ -11320,7 +12693,7 @@
       </p:sp>
       <p:pic>
         <p:nvPicPr>
-          <p:cNvPr id="22" name="Image 3" descr="/Users/ananyasingh/Developer/Sentinel/app/static/brand/mark-flat-256.png">    </p:cNvPr>
+          <p:cNvPr id="23" name="Image 3" descr="/Users/ananyasingh/Developer/Sentinel/app/static/brand/mark-flat-256.png">    </p:cNvPr>
           <p:cNvPicPr>
             <a:picLocks noChangeAspect="1"/>
           </p:cNvPicPr>
@@ -11344,7 +12717,7 @@
       </p:pic>
       <p:sp>
         <p:nvSpPr>
-          <p:cNvPr id="23" name="Text 17"/>
+          <p:cNvPr id="24" name="Text 18"/>
           <p:cNvSpPr txBox="1"/>
           <p:nvPr/>
         </p:nvSpPr>
@@ -11383,7 +12756,7 @@
       </p:sp>
       <p:sp>
         <p:nvSpPr>
-          <p:cNvPr id="24" name="Text 18"/>
+          <p:cNvPr id="25" name="Text 19"/>
           <p:cNvSpPr txBox="1"/>
           <p:nvPr/>
         </p:nvSpPr>
@@ -11414,7 +12787,7 @@
                 <a:ea typeface="Calibri" pitchFamily="34" charset="-122"/>
                 <a:cs typeface="Calibri" pitchFamily="34" charset="-120"/>
               </a:rPr>
-              <a:t>7 / 10</a:t>
+              <a:t>7 / 11</a:t>
             </a:r>
             <a:endParaRPr lang="en-US" sz="1000" dirty="0"/>
           </a:p>
@@ -12316,7 +13689,7 @@
                 <a:ea typeface="Calibri" pitchFamily="34" charset="-122"/>
                 <a:cs typeface="Calibri" pitchFamily="34" charset="-120"/>
               </a:rPr>
-              <a:t>8 / 10</a:t>
+              <a:t>8 / 11</a:t>
             </a:r>
             <a:endParaRPr lang="en-US" sz="1000" dirty="0"/>
           </a:p>
@@ -12387,7 +13760,7 @@
                 <a:ea typeface="Calibri" pitchFamily="34" charset="-122"/>
                 <a:cs typeface="Calibri" pitchFamily="34" charset="-120"/>
               </a:rPr>
-              <a:t>08  ·  RESTRICTION HANDLING</a:t>
+              <a:t>08  ·  VERIFY IT</a:t>
             </a:r>
             <a:endParaRPr lang="en-US" sz="1200" dirty="0"/>
           </a:p>
@@ -12426,7 +13799,7 @@
                 <a:ea typeface="Cambria" pitchFamily="34" charset="-122"/>
                 <a:cs typeface="Cambria" pitchFamily="34" charset="-120"/>
               </a:rPr>
-              <a:t>Where it could go wrong, and what we do about it</a:t>
+              <a:t>Don't take our word for it: re-run it, then read the failures</a:t>
             </a:r>
             <a:endParaRPr lang="en-US" sz="3200" dirty="0"/>
           </a:p>
@@ -12440,12 +13813,12 @@
         </p:nvSpPr>
         <p:spPr>
           <a:xfrm>
-            <a:off x="548640" y="1600200"/>
-            <a:ext cx="7040880" cy="804672"/>
+            <a:off x="548640" y="1645920"/>
+            <a:ext cx="6492240" cy="4343400"/>
           </a:xfrm>
           <a:prstGeom prst="roundRect">
             <a:avLst>
-              <a:gd name="adj" fmla="val 13636"/>
+              <a:gd name="adj" fmla="val 2526"/>
             </a:avLst>
           </a:prstGeom>
           <a:solidFill>
@@ -12454,531 +13827,6 @@
           <a:ln w="9525">
             <a:solidFill>
               <a:srgbClr val="E1E4E9"/>
-            </a:solidFill>
-            <a:prstDash val="solid"/>
-          </a:ln>
-        </p:spPr>
-      </p:sp>
-      <p:sp>
-        <p:nvSpPr>
-          <p:cNvPr id="5" name="Text 3"/>
-          <p:cNvSpPr txBox="1"/>
-          <p:nvPr/>
-        </p:nvSpPr>
-        <p:spPr>
-          <a:xfrm>
-            <a:off x="777240" y="1691640"/>
-            <a:ext cx="6583680" cy="292608"/>
-          </a:xfrm>
-          <a:prstGeom prst="rect">
-            <a:avLst/>
-          </a:prstGeom>
-          <a:noFill/>
-          <a:ln/>
-        </p:spPr>
-        <p:txBody>
-          <a:bodyPr wrap="square" lIns="0" tIns="0" rIns="0" bIns="0" rtlCol="0" anchor="t"/>
-          <a:lstStyle/>
-          <a:p>
-            <a:pPr indent="0" marL="0">
-              <a:buNone/>
-            </a:pPr>
-            <a:r>
-              <a:rPr lang="en-US" sz="1400" b="1" dirty="0">
-                <a:solidFill>
-                  <a:srgbClr val="12161C"/>
-                </a:solidFill>
-                <a:latin typeface="Calibri" pitchFamily="34" charset="0"/>
-                <a:ea typeface="Calibri" pitchFamily="34" charset="-122"/>
-                <a:cs typeface="Calibri" pitchFamily="34" charset="-120"/>
-              </a:rPr>
-              <a:t>Useful content must survive</a:t>
-            </a:r>
-            <a:endParaRPr lang="en-US" sz="1400" dirty="0"/>
-          </a:p>
-        </p:txBody>
-      </p:sp>
-      <p:sp>
-        <p:nvSpPr>
-          <p:cNvPr id="6" name="Text 4"/>
-          <p:cNvSpPr txBox="1"/>
-          <p:nvPr/>
-        </p:nvSpPr>
-        <p:spPr>
-          <a:xfrm>
-            <a:off x="777240" y="2011680"/>
-            <a:ext cx="6583680" cy="365760"/>
-          </a:xfrm>
-          <a:prstGeom prst="rect">
-            <a:avLst/>
-          </a:prstGeom>
-          <a:noFill/>
-          <a:ln/>
-        </p:spPr>
-        <p:txBody>
-          <a:bodyPr wrap="square" lIns="0" tIns="0" rIns="0" bIns="0" rtlCol="0" anchor="t"/>
-          <a:lstStyle/>
-          <a:p>
-            <a:pPr indent="0" marL="0">
-              <a:buNone/>
-            </a:pPr>
-            <a:r>
-              <a:rPr lang="en-US" sz="1200" dirty="0">
-                <a:solidFill>
-                  <a:srgbClr val="5B6472"/>
-                </a:solidFill>
-                <a:latin typeface="Calibri" pitchFamily="34" charset="0"/>
-                <a:ea typeface="Calibri" pitchFamily="34" charset="-122"/>
-                <a:cs typeface="Calibri" pitchFamily="34" charset="-120"/>
-              </a:rPr>
-              <a:t>Only the offending span is removed; every other word passes through unchanged.</a:t>
-            </a:r>
-            <a:endParaRPr lang="en-US" sz="1200" dirty="0"/>
-          </a:p>
-        </p:txBody>
-      </p:sp>
-      <p:sp>
-        <p:nvSpPr>
-          <p:cNvPr id="7" name="Shape 5"/>
-          <p:cNvSpPr/>
-          <p:nvPr/>
-        </p:nvSpPr>
-        <p:spPr>
-          <a:xfrm>
-            <a:off x="548640" y="2496312"/>
-            <a:ext cx="7040880" cy="804672"/>
-          </a:xfrm>
-          <a:prstGeom prst="roundRect">
-            <a:avLst>
-              <a:gd name="adj" fmla="val 13636"/>
-            </a:avLst>
-          </a:prstGeom>
-          <a:solidFill>
-            <a:srgbClr val="FFFFFF"/>
-          </a:solidFill>
-          <a:ln w="9525">
-            <a:solidFill>
-              <a:srgbClr val="E1E4E9"/>
-            </a:solidFill>
-            <a:prstDash val="solid"/>
-          </a:ln>
-        </p:spPr>
-      </p:sp>
-      <p:sp>
-        <p:nvSpPr>
-          <p:cNvPr id="8" name="Text 6"/>
-          <p:cNvSpPr txBox="1"/>
-          <p:nvPr/>
-        </p:nvSpPr>
-        <p:spPr>
-          <a:xfrm>
-            <a:off x="777240" y="2587752"/>
-            <a:ext cx="6583680" cy="292608"/>
-          </a:xfrm>
-          <a:prstGeom prst="rect">
-            <a:avLst/>
-          </a:prstGeom>
-          <a:noFill/>
-          <a:ln/>
-        </p:spPr>
-        <p:txBody>
-          <a:bodyPr wrap="square" lIns="0" tIns="0" rIns="0" bIns="0" rtlCol="0" anchor="t"/>
-          <a:lstStyle/>
-          <a:p>
-            <a:pPr indent="0" marL="0">
-              <a:buNone/>
-            </a:pPr>
-            <a:r>
-              <a:rPr lang="en-US" sz="1400" b="1" dirty="0">
-                <a:solidFill>
-                  <a:srgbClr val="12161C"/>
-                </a:solidFill>
-                <a:latin typeface="Calibri" pitchFamily="34" charset="0"/>
-                <a:ea typeface="Calibri" pitchFamily="34" charset="-122"/>
-                <a:cs typeface="Calibri" pitchFamily="34" charset="-120"/>
-              </a:rPr>
-              <a:t>Harmless commands must not be blocked</a:t>
-            </a:r>
-            <a:endParaRPr lang="en-US" sz="1400" dirty="0"/>
-          </a:p>
-        </p:txBody>
-      </p:sp>
-      <p:sp>
-        <p:nvSpPr>
-          <p:cNvPr id="9" name="Text 7"/>
-          <p:cNvSpPr txBox="1"/>
-          <p:nvPr/>
-        </p:nvSpPr>
-        <p:spPr>
-          <a:xfrm>
-            <a:off x="777240" y="2907792"/>
-            <a:ext cx="6583680" cy="365760"/>
-          </a:xfrm>
-          <a:prstGeom prst="rect">
-            <a:avLst/>
-          </a:prstGeom>
-          <a:noFill/>
-          <a:ln/>
-        </p:spPr>
-        <p:txBody>
-          <a:bodyPr wrap="square" lIns="0" tIns="0" rIns="0" bIns="0" rtlCol="0" anchor="t"/>
-          <a:lstStyle/>
-          <a:p>
-            <a:pPr indent="0" marL="0">
-              <a:buNone/>
-            </a:pPr>
-            <a:r>
-              <a:rPr lang="en-US" sz="1200" dirty="0">
-                <a:solidFill>
-                  <a:srgbClr val="5B6472"/>
-                </a:solidFill>
-                <a:latin typeface="Calibri" pitchFamily="34" charset="0"/>
-                <a:ea typeface="Calibri" pitchFamily="34" charset="-122"/>
-                <a:cs typeface="Calibri" pitchFamily="34" charset="-120"/>
-              </a:rPr>
-              <a:t>The off-task check clears command-shaped text that belongs on the page; harmless look-alikes are scored.</a:t>
-            </a:r>
-            <a:endParaRPr lang="en-US" sz="1200" dirty="0"/>
-          </a:p>
-        </p:txBody>
-      </p:sp>
-      <p:sp>
-        <p:nvSpPr>
-          <p:cNvPr id="10" name="Shape 8"/>
-          <p:cNvSpPr/>
-          <p:nvPr/>
-        </p:nvSpPr>
-        <p:spPr>
-          <a:xfrm>
-            <a:off x="548640" y="3392424"/>
-            <a:ext cx="7040880" cy="804672"/>
-          </a:xfrm>
-          <a:prstGeom prst="roundRect">
-            <a:avLst>
-              <a:gd name="adj" fmla="val 13636"/>
-            </a:avLst>
-          </a:prstGeom>
-          <a:solidFill>
-            <a:srgbClr val="FFFFFF"/>
-          </a:solidFill>
-          <a:ln w="9525">
-            <a:solidFill>
-              <a:srgbClr val="E1E4E9"/>
-            </a:solidFill>
-            <a:prstDash val="solid"/>
-          </a:ln>
-        </p:spPr>
-      </p:sp>
-      <p:sp>
-        <p:nvSpPr>
-          <p:cNvPr id="11" name="Text 9"/>
-          <p:cNvSpPr txBox="1"/>
-          <p:nvPr/>
-        </p:nvSpPr>
-        <p:spPr>
-          <a:xfrm>
-            <a:off x="777240" y="3483864"/>
-            <a:ext cx="6583680" cy="292608"/>
-          </a:xfrm>
-          <a:prstGeom prst="rect">
-            <a:avLst/>
-          </a:prstGeom>
-          <a:noFill/>
-          <a:ln/>
-        </p:spPr>
-        <p:txBody>
-          <a:bodyPr wrap="square" lIns="0" tIns="0" rIns="0" bIns="0" rtlCol="0" anchor="t"/>
-          <a:lstStyle/>
-          <a:p>
-            <a:pPr indent="0" marL="0">
-              <a:buNone/>
-            </a:pPr>
-            <a:r>
-              <a:rPr lang="en-US" sz="1400" b="1" dirty="0">
-                <a:solidFill>
-                  <a:srgbClr val="12161C"/>
-                </a:solidFill>
-                <a:latin typeface="Calibri" pitchFamily="34" charset="0"/>
-                <a:ea typeface="Calibri" pitchFamily="34" charset="-122"/>
-                <a:cs typeface="Calibri" pitchFamily="34" charset="-120"/>
-              </a:rPr>
-              <a:t>Unseen attack styles</a:t>
-            </a:r>
-            <a:endParaRPr lang="en-US" sz="1400" dirty="0"/>
-          </a:p>
-        </p:txBody>
-      </p:sp>
-      <p:sp>
-        <p:nvSpPr>
-          <p:cNvPr id="12" name="Text 10"/>
-          <p:cNvSpPr txBox="1"/>
-          <p:nvPr/>
-        </p:nvSpPr>
-        <p:spPr>
-          <a:xfrm>
-            <a:off x="777240" y="3803904"/>
-            <a:ext cx="6583680" cy="365760"/>
-          </a:xfrm>
-          <a:prstGeom prst="rect">
-            <a:avLst/>
-          </a:prstGeom>
-          <a:noFill/>
-          <a:ln/>
-        </p:spPr>
-        <p:txBody>
-          <a:bodyPr wrap="square" lIns="0" tIns="0" rIns="0" bIns="0" rtlCol="0" anchor="t"/>
-          <a:lstStyle/>
-          <a:p>
-            <a:pPr indent="0" marL="0">
-              <a:buNone/>
-            </a:pPr>
-            <a:r>
-              <a:rPr lang="en-US" sz="1200" dirty="0">
-                <a:solidFill>
-                  <a:srgbClr val="5B6472"/>
-                </a:solidFill>
-                <a:latin typeface="Calibri" pitchFamily="34" charset="0"/>
-                <a:ea typeface="Calibri" pitchFamily="34" charset="-122"/>
-                <a:cs typeface="Calibri" pitchFamily="34" charset="-120"/>
-              </a:rPr>
-              <a:t>Whole attack families and whole sites are held out of training and calibration.</a:t>
-            </a:r>
-            <a:endParaRPr lang="en-US" sz="1200" dirty="0"/>
-          </a:p>
-        </p:txBody>
-      </p:sp>
-      <p:sp>
-        <p:nvSpPr>
-          <p:cNvPr id="13" name="Shape 11"/>
-          <p:cNvSpPr/>
-          <p:nvPr/>
-        </p:nvSpPr>
-        <p:spPr>
-          <a:xfrm>
-            <a:off x="548640" y="4288536"/>
-            <a:ext cx="7040880" cy="804672"/>
-          </a:xfrm>
-          <a:prstGeom prst="roundRect">
-            <a:avLst>
-              <a:gd name="adj" fmla="val 13636"/>
-            </a:avLst>
-          </a:prstGeom>
-          <a:solidFill>
-            <a:srgbClr val="FFFFFF"/>
-          </a:solidFill>
-          <a:ln w="9525">
-            <a:solidFill>
-              <a:srgbClr val="E1E4E9"/>
-            </a:solidFill>
-            <a:prstDash val="solid"/>
-          </a:ln>
-        </p:spPr>
-      </p:sp>
-      <p:sp>
-        <p:nvSpPr>
-          <p:cNvPr id="14" name="Text 12"/>
-          <p:cNvSpPr txBox="1"/>
-          <p:nvPr/>
-        </p:nvSpPr>
-        <p:spPr>
-          <a:xfrm>
-            <a:off x="777240" y="4379976"/>
-            <a:ext cx="6583680" cy="292608"/>
-          </a:xfrm>
-          <a:prstGeom prst="rect">
-            <a:avLst/>
-          </a:prstGeom>
-          <a:noFill/>
-          <a:ln/>
-        </p:spPr>
-        <p:txBody>
-          <a:bodyPr wrap="square" lIns="0" tIns="0" rIns="0" bIns="0" rtlCol="0" anchor="t"/>
-          <a:lstStyle/>
-          <a:p>
-            <a:pPr indent="0" marL="0">
-              <a:buNone/>
-            </a:pPr>
-            <a:r>
-              <a:rPr lang="en-US" sz="1400" b="1" dirty="0">
-                <a:solidFill>
-                  <a:srgbClr val="12161C"/>
-                </a:solidFill>
-                <a:latin typeface="Calibri" pitchFamily="34" charset="0"/>
-                <a:ea typeface="Calibri" pitchFamily="34" charset="-122"/>
-                <a:cs typeface="Calibri" pitchFamily="34" charset="-120"/>
-              </a:rPr>
-              <a:t>Hidden and forged instructions</a:t>
-            </a:r>
-            <a:endParaRPr lang="en-US" sz="1400" dirty="0"/>
-          </a:p>
-        </p:txBody>
-      </p:sp>
-      <p:sp>
-        <p:nvSpPr>
-          <p:cNvPr id="15" name="Text 13"/>
-          <p:cNvSpPr txBox="1"/>
-          <p:nvPr/>
-        </p:nvSpPr>
-        <p:spPr>
-          <a:xfrm>
-            <a:off x="777240" y="4700016"/>
-            <a:ext cx="6583680" cy="365760"/>
-          </a:xfrm>
-          <a:prstGeom prst="rect">
-            <a:avLst/>
-          </a:prstGeom>
-          <a:noFill/>
-          <a:ln/>
-        </p:spPr>
-        <p:txBody>
-          <a:bodyPr wrap="square" lIns="0" tIns="0" rIns="0" bIns="0" rtlCol="0" anchor="t"/>
-          <a:lstStyle/>
-          <a:p>
-            <a:pPr indent="0" marL="0">
-              <a:buNone/>
-            </a:pPr>
-            <a:r>
-              <a:rPr lang="en-US" sz="1200" dirty="0">
-                <a:solidFill>
-                  <a:srgbClr val="5B6472"/>
-                </a:solidFill>
-                <a:latin typeface="Calibri" pitchFamily="34" charset="0"/>
-                <a:ea typeface="Calibri" pitchFamily="34" charset="-122"/>
-                <a:cs typeface="Calibri" pitchFamily="34" charset="-120"/>
-              </a:rPr>
-              <a:t>HTML comments and code blocks stay whole; forged system or assistant roles are removed by rule.</a:t>
-            </a:r>
-            <a:endParaRPr lang="en-US" sz="1200" dirty="0"/>
-          </a:p>
-        </p:txBody>
-      </p:sp>
-      <p:sp>
-        <p:nvSpPr>
-          <p:cNvPr id="16" name="Shape 14"/>
-          <p:cNvSpPr/>
-          <p:nvPr/>
-        </p:nvSpPr>
-        <p:spPr>
-          <a:xfrm>
-            <a:off x="548640" y="5184648"/>
-            <a:ext cx="7040880" cy="804672"/>
-          </a:xfrm>
-          <a:prstGeom prst="roundRect">
-            <a:avLst>
-              <a:gd name="adj" fmla="val 13636"/>
-            </a:avLst>
-          </a:prstGeom>
-          <a:solidFill>
-            <a:srgbClr val="FFFFFF"/>
-          </a:solidFill>
-          <a:ln w="9525">
-            <a:solidFill>
-              <a:srgbClr val="E1E4E9"/>
-            </a:solidFill>
-            <a:prstDash val="solid"/>
-          </a:ln>
-        </p:spPr>
-      </p:sp>
-      <p:sp>
-        <p:nvSpPr>
-          <p:cNvPr id="17" name="Text 15"/>
-          <p:cNvSpPr txBox="1"/>
-          <p:nvPr/>
-        </p:nvSpPr>
-        <p:spPr>
-          <a:xfrm>
-            <a:off x="777240" y="5276088"/>
-            <a:ext cx="6583680" cy="292608"/>
-          </a:xfrm>
-          <a:prstGeom prst="rect">
-            <a:avLst/>
-          </a:prstGeom>
-          <a:noFill/>
-          <a:ln/>
-        </p:spPr>
-        <p:txBody>
-          <a:bodyPr wrap="square" lIns="0" tIns="0" rIns="0" bIns="0" rtlCol="0" anchor="t"/>
-          <a:lstStyle/>
-          <a:p>
-            <a:pPr indent="0" marL="0">
-              <a:buNone/>
-            </a:pPr>
-            <a:r>
-              <a:rPr lang="en-US" sz="1400" b="1" dirty="0">
-                <a:solidFill>
-                  <a:srgbClr val="12161C"/>
-                </a:solidFill>
-                <a:latin typeface="Calibri" pitchFamily="34" charset="0"/>
-                <a:ea typeface="Calibri" pitchFamily="34" charset="-122"/>
-                <a:cs typeface="Calibri" pitchFamily="34" charset="-120"/>
-              </a:rPr>
-              <a:t>Latency and cost</a:t>
-            </a:r>
-            <a:endParaRPr lang="en-US" sz="1400" dirty="0"/>
-          </a:p>
-        </p:txBody>
-      </p:sp>
-      <p:sp>
-        <p:nvSpPr>
-          <p:cNvPr id="18" name="Text 16"/>
-          <p:cNvSpPr txBox="1"/>
-          <p:nvPr/>
-        </p:nvSpPr>
-        <p:spPr>
-          <a:xfrm>
-            <a:off x="777240" y="5596128"/>
-            <a:ext cx="6583680" cy="365760"/>
-          </a:xfrm>
-          <a:prstGeom prst="rect">
-            <a:avLst/>
-          </a:prstGeom>
-          <a:noFill/>
-          <a:ln/>
-        </p:spPr>
-        <p:txBody>
-          <a:bodyPr wrap="square" lIns="0" tIns="0" rIns="0" bIns="0" rtlCol="0" anchor="t"/>
-          <a:lstStyle/>
-          <a:p>
-            <a:pPr indent="0" marL="0">
-              <a:buNone/>
-            </a:pPr>
-            <a:r>
-              <a:rPr lang="en-US" sz="1200" dirty="0">
-                <a:solidFill>
-                  <a:srgbClr val="5B6472"/>
-                </a:solidFill>
-                <a:latin typeface="Calibri" pitchFamily="34" charset="0"/>
-                <a:ea typeface="Calibri" pitchFamily="34" charset="-122"/>
-                <a:cs typeface="Calibri" pitchFamily="34" charset="-120"/>
-              </a:rPr>
-              <a:t>A small local model and a tiny fusion: about a fifth of a second, no API calls.</a:t>
-            </a:r>
-            <a:endParaRPr lang="en-US" sz="1200" dirty="0"/>
-          </a:p>
-        </p:txBody>
-      </p:sp>
-      <p:sp>
-        <p:nvSpPr>
-          <p:cNvPr id="19" name="Shape 17"/>
-          <p:cNvSpPr/>
-          <p:nvPr/>
-        </p:nvSpPr>
-        <p:spPr>
-          <a:xfrm>
-            <a:off x="7818120" y="1600200"/>
-            <a:ext cx="3822192" cy="4389120"/>
-          </a:xfrm>
-          <a:prstGeom prst="roundRect">
-            <a:avLst>
-              <a:gd name="adj" fmla="val 2871"/>
-            </a:avLst>
-          </a:prstGeom>
-          <a:solidFill>
-            <a:srgbClr val="0E1116"/>
-          </a:solidFill>
-          <a:ln w="12700">
-            <a:solidFill>
-              <a:srgbClr val="0E1116"/>
             </a:solidFill>
             <a:prstDash val="solid"/>
           </a:ln>
@@ -12991,299 +13839,9 @@
           </a:effectLst>
         </p:spPr>
       </p:sp>
-      <p:sp>
-        <p:nvSpPr>
-          <p:cNvPr id="20" name="Text 18"/>
-          <p:cNvSpPr txBox="1"/>
-          <p:nvPr/>
-        </p:nvSpPr>
-        <p:spPr>
-          <a:xfrm>
-            <a:off x="8092440" y="1783080"/>
-            <a:ext cx="3383280" cy="256032"/>
-          </a:xfrm>
-          <a:prstGeom prst="rect">
-            <a:avLst/>
-          </a:prstGeom>
-          <a:noFill/>
-          <a:ln/>
-        </p:spPr>
-        <p:txBody>
-          <a:bodyPr wrap="square" lIns="0" tIns="0" rIns="0" bIns="0" rtlCol="0" anchor="t"/>
-          <a:lstStyle/>
-          <a:p>
-            <a:pPr indent="0" marL="0">
-              <a:buNone/>
-            </a:pPr>
-            <a:r>
-              <a:rPr lang="en-US" sz="1000" b="1" spc="180" kern="0" dirty="0">
-                <a:solidFill>
-                  <a:srgbClr val="FF5A36"/>
-                </a:solidFill>
-                <a:latin typeface="Calibri" pitchFamily="34" charset="0"/>
-                <a:ea typeface="Calibri" pitchFamily="34" charset="-122"/>
-                <a:cs typeface="Calibri" pitchFamily="34" charset="-120"/>
-              </a:rPr>
-              <a:t>ATTACK LAB · 20 CASES RUN LIVE</a:t>
-            </a:r>
-            <a:endParaRPr lang="en-US" sz="1000" dirty="0"/>
-          </a:p>
-        </p:txBody>
-      </p:sp>
-      <p:sp>
-        <p:nvSpPr>
-          <p:cNvPr id="21" name="Text 19"/>
-          <p:cNvSpPr txBox="1"/>
-          <p:nvPr/>
-        </p:nvSpPr>
-        <p:spPr>
-          <a:xfrm>
-            <a:off x="8092440" y="2240280"/>
-            <a:ext cx="3291840" cy="274320"/>
-          </a:xfrm>
-          <a:prstGeom prst="rect">
-            <a:avLst/>
-          </a:prstGeom>
-          <a:noFill/>
-          <a:ln/>
-        </p:spPr>
-        <p:txBody>
-          <a:bodyPr wrap="square" lIns="0" tIns="0" rIns="0" bIns="0" rtlCol="0" anchor="t"/>
-          <a:lstStyle/>
-          <a:p>
-            <a:pPr indent="0" marL="0">
-              <a:buNone/>
-            </a:pPr>
-            <a:r>
-              <a:rPr lang="en-US" sz="1200" dirty="0">
-                <a:solidFill>
-                  <a:srgbClr val="8A93A0"/>
-                </a:solidFill>
-                <a:latin typeface="Calibri" pitchFamily="34" charset="0"/>
-                <a:ea typeface="Calibri" pitchFamily="34" charset="-122"/>
-                <a:cs typeface="Calibri" pitchFamily="34" charset="-120"/>
-              </a:rPr>
-              <a:t>Attacks removed</a:t>
-            </a:r>
-            <a:endParaRPr lang="en-US" sz="1200" dirty="0"/>
-          </a:p>
-        </p:txBody>
-      </p:sp>
-      <p:sp>
-        <p:nvSpPr>
-          <p:cNvPr id="22" name="Text 20"/>
-          <p:cNvSpPr txBox="1"/>
-          <p:nvPr/>
-        </p:nvSpPr>
-        <p:spPr>
-          <a:xfrm>
-            <a:off x="8092440" y="2496312"/>
-            <a:ext cx="3383280" cy="640080"/>
-          </a:xfrm>
-          <a:prstGeom prst="rect">
-            <a:avLst/>
-          </a:prstGeom>
-          <a:noFill/>
-          <a:ln/>
-        </p:spPr>
-        <p:txBody>
-          <a:bodyPr wrap="square" lIns="0" tIns="0" rIns="0" bIns="0" rtlCol="0" anchor="t"/>
-          <a:lstStyle/>
-          <a:p>
-            <a:pPr indent="0" marL="0">
-              <a:buNone/>
-            </a:pPr>
-            <a:r>
-              <a:rPr lang="en-US" sz="3600" b="1" dirty="0">
-                <a:solidFill>
-                  <a:srgbClr val="FF5A36"/>
-                </a:solidFill>
-                <a:latin typeface="Cambria" pitchFamily="34" charset="0"/>
-                <a:ea typeface="Cambria" pitchFamily="34" charset="-122"/>
-                <a:cs typeface="Cambria" pitchFamily="34" charset="-120"/>
-              </a:rPr>
-              <a:t>12</a:t>
-            </a:r>
-            <a:pPr indent="0" marL="0">
-              <a:buNone/>
-            </a:pPr>
-            <a:r>
-              <a:rPr lang="en-US" sz="1600" dirty="0">
-                <a:solidFill>
-                  <a:srgbClr val="8A93A0"/>
-                </a:solidFill>
-                <a:latin typeface="Calibri" pitchFamily="34" charset="0"/>
-                <a:ea typeface="Calibri" pitchFamily="34" charset="-122"/>
-                <a:cs typeface="Calibri" pitchFamily="34" charset="-120"/>
-              </a:rPr>
-              <a:t> / 14</a:t>
-            </a:r>
-            <a:pPr indent="0" marL="0">
-              <a:buNone/>
-            </a:pPr>
-            <a:r>
-              <a:rPr lang="en-US" sz="1300" dirty="0">
-                <a:solidFill>
-                  <a:srgbClr val="8A93A0"/>
-                </a:solidFill>
-                <a:latin typeface="Calibri" pitchFamily="34" charset="0"/>
-                <a:ea typeface="Calibri" pitchFamily="34" charset="-122"/>
-                <a:cs typeface="Calibri" pitchFamily="34" charset="-120"/>
-              </a:rPr>
-              <a:t>      baseline 9</a:t>
-            </a:r>
-            <a:endParaRPr lang="en-US" sz="1400" dirty="0"/>
-          </a:p>
-        </p:txBody>
-      </p:sp>
-      <p:sp>
-        <p:nvSpPr>
-          <p:cNvPr id="23" name="Text 21"/>
-          <p:cNvSpPr txBox="1"/>
-          <p:nvPr/>
-        </p:nvSpPr>
-        <p:spPr>
-          <a:xfrm>
-            <a:off x="8092440" y="3429000"/>
-            <a:ext cx="3291840" cy="274320"/>
-          </a:xfrm>
-          <a:prstGeom prst="rect">
-            <a:avLst/>
-          </a:prstGeom>
-          <a:noFill/>
-          <a:ln/>
-        </p:spPr>
-        <p:txBody>
-          <a:bodyPr wrap="square" lIns="0" tIns="0" rIns="0" bIns="0" rtlCol="0" anchor="t"/>
-          <a:lstStyle/>
-          <a:p>
-            <a:pPr indent="0" marL="0">
-              <a:buNone/>
-            </a:pPr>
-            <a:r>
-              <a:rPr lang="en-US" sz="1200" dirty="0">
-                <a:solidFill>
-                  <a:srgbClr val="8A93A0"/>
-                </a:solidFill>
-                <a:latin typeface="Calibri" pitchFamily="34" charset="0"/>
-                <a:ea typeface="Calibri" pitchFamily="34" charset="-122"/>
-                <a:cs typeface="Calibri" pitchFamily="34" charset="-120"/>
-              </a:rPr>
-              <a:t>Harmless look-alikes passed</a:t>
-            </a:r>
-            <a:endParaRPr lang="en-US" sz="1200" dirty="0"/>
-          </a:p>
-        </p:txBody>
-      </p:sp>
-      <p:sp>
-        <p:nvSpPr>
-          <p:cNvPr id="24" name="Text 22"/>
-          <p:cNvSpPr txBox="1"/>
-          <p:nvPr/>
-        </p:nvSpPr>
-        <p:spPr>
-          <a:xfrm>
-            <a:off x="8092440" y="3685032"/>
-            <a:ext cx="3383280" cy="640080"/>
-          </a:xfrm>
-          <a:prstGeom prst="rect">
-            <a:avLst/>
-          </a:prstGeom>
-          <a:noFill/>
-          <a:ln/>
-        </p:spPr>
-        <p:txBody>
-          <a:bodyPr wrap="square" lIns="0" tIns="0" rIns="0" bIns="0" rtlCol="0" anchor="t"/>
-          <a:lstStyle/>
-          <a:p>
-            <a:pPr indent="0" marL="0">
-              <a:buNone/>
-            </a:pPr>
-            <a:r>
-              <a:rPr lang="en-US" sz="3600" b="1" dirty="0">
-                <a:solidFill>
-                  <a:srgbClr val="FF5A36"/>
-                </a:solidFill>
-                <a:latin typeface="Cambria" pitchFamily="34" charset="0"/>
-                <a:ea typeface="Cambria" pitchFamily="34" charset="-122"/>
-                <a:cs typeface="Cambria" pitchFamily="34" charset="-120"/>
-              </a:rPr>
-              <a:t>4</a:t>
-            </a:r>
-            <a:pPr indent="0" marL="0">
-              <a:buNone/>
-            </a:pPr>
-            <a:r>
-              <a:rPr lang="en-US" sz="1600" dirty="0">
-                <a:solidFill>
-                  <a:srgbClr val="8A93A0"/>
-                </a:solidFill>
-                <a:latin typeface="Calibri" pitchFamily="34" charset="0"/>
-                <a:ea typeface="Calibri" pitchFamily="34" charset="-122"/>
-                <a:cs typeface="Calibri" pitchFamily="34" charset="-120"/>
-              </a:rPr>
-              <a:t> / 4</a:t>
-            </a:r>
-            <a:pPr indent="0" marL="0">
-              <a:buNone/>
-            </a:pPr>
-            <a:r>
-              <a:rPr lang="en-US" sz="1300" dirty="0">
-                <a:solidFill>
-                  <a:srgbClr val="8A93A0"/>
-                </a:solidFill>
-                <a:latin typeface="Calibri" pitchFamily="34" charset="0"/>
-                <a:ea typeface="Calibri" pitchFamily="34" charset="-122"/>
-                <a:cs typeface="Calibri" pitchFamily="34" charset="-120"/>
-              </a:rPr>
-              <a:t>      baseline 2</a:t>
-            </a:r>
-            <a:endParaRPr lang="en-US" sz="1400" dirty="0"/>
-          </a:p>
-        </p:txBody>
-      </p:sp>
-      <p:sp>
-        <p:nvSpPr>
-          <p:cNvPr id="25" name="Text 23"/>
-          <p:cNvSpPr txBox="1"/>
-          <p:nvPr/>
-        </p:nvSpPr>
-        <p:spPr>
-          <a:xfrm>
-            <a:off x="8092440" y="4663440"/>
-            <a:ext cx="3291840" cy="1097280"/>
-          </a:xfrm>
-          <a:prstGeom prst="rect">
-            <a:avLst/>
-          </a:prstGeom>
-          <a:noFill/>
-          <a:ln/>
-        </p:spPr>
-        <p:txBody>
-          <a:bodyPr wrap="square" lIns="0" tIns="0" rIns="0" bIns="0" rtlCol="0" anchor="t"/>
-          <a:lstStyle/>
-          <a:p>
-            <a:pPr indent="0" marL="0">
-              <a:buNone/>
-            </a:pPr>
-            <a:r>
-              <a:rPr lang="en-US" sz="1200" i="1" dirty="0">
-                <a:solidFill>
-                  <a:srgbClr val="C9CFD8"/>
-                </a:solidFill>
-                <a:latin typeface="Calibri" pitchFamily="34" charset="0"/>
-                <a:ea typeface="Calibri" pitchFamily="34" charset="-122"/>
-                <a:cs typeface="Calibri" pitchFamily="34" charset="-120"/>
-              </a:rPr>
-              <a:t>Two attacks slip through, and we show them: a sales push that reads like normal page copy, and one reworded override. An override in French is a stated limit.</a:t>
-            </a:r>
-            <a:endParaRPr lang="en-US" sz="1200" dirty="0"/>
-          </a:p>
-        </p:txBody>
-      </p:sp>
       <p:pic>
         <p:nvPicPr>
-          <p:cNvPr id="26" name="Image 0" descr="/Users/ananyasingh/Developer/Sentinel/app/static/brand/mark-flat-256.png">    </p:cNvPr>
+          <p:cNvPr id="5" name="Image 0" descr="/private/tmp/claude-501/-Users-ananyasingh-Downloads-WIN-IF-YOU-CAN-PS/bf2c8522-e0b9-476e-a641-e8df935a7bd3/scratchpad/shots/g-live.png">    </p:cNvPr>
           <p:cNvPicPr>
             <a:picLocks noChangeAspect="1"/>
           </p:cNvPicPr>
@@ -13297,6 +13855,283 @@
         </p:blipFill>
         <p:spPr>
           <a:xfrm>
+            <a:off x="685800" y="1783080"/>
+            <a:ext cx="6217920" cy="2029460"/>
+          </a:xfrm>
+          <a:prstGeom prst="rect">
+            <a:avLst/>
+          </a:prstGeom>
+        </p:spPr>
+      </p:pic>
+      <p:sp>
+        <p:nvSpPr>
+          <p:cNvPr id="6" name="Text 3"/>
+          <p:cNvSpPr txBox="1"/>
+          <p:nvPr/>
+        </p:nvSpPr>
+        <p:spPr>
+          <a:xfrm>
+            <a:off x="777240" y="3977640"/>
+            <a:ext cx="5943600" cy="237744"/>
+          </a:xfrm>
+          <a:prstGeom prst="rect">
+            <a:avLst/>
+          </a:prstGeom>
+          <a:noFill/>
+          <a:ln/>
+        </p:spPr>
+        <p:txBody>
+          <a:bodyPr wrap="square" lIns="0" tIns="0" rIns="0" bIns="0" rtlCol="0" anchor="t"/>
+          <a:lstStyle/>
+          <a:p>
+            <a:pPr indent="0" marL="0">
+              <a:buNone/>
+            </a:pPr>
+            <a:r>
+              <a:rPr lang="en-US" sz="1100" b="1" spc="250" kern="0" dirty="0">
+                <a:solidFill>
+                  <a:srgbClr val="FF5A36"/>
+                </a:solidFill>
+                <a:latin typeface="Calibri" pitchFamily="34" charset="0"/>
+                <a:ea typeface="Calibri" pitchFamily="34" charset="-122"/>
+                <a:cs typeface="Calibri" pitchFamily="34" charset="-120"/>
+              </a:rPr>
+              <a:t>RE-RUN IT LIVE</a:t>
+            </a:r>
+            <a:endParaRPr lang="en-US" sz="1100" dirty="0"/>
+          </a:p>
+        </p:txBody>
+      </p:sp>
+      <p:sp>
+        <p:nvSpPr>
+          <p:cNvPr id="7" name="Text 4"/>
+          <p:cNvSpPr txBox="1"/>
+          <p:nvPr/>
+        </p:nvSpPr>
+        <p:spPr>
+          <a:xfrm>
+            <a:off x="777240" y="4279392"/>
+            <a:ext cx="5943600" cy="548640"/>
+          </a:xfrm>
+          <a:prstGeom prst="rect">
+            <a:avLst/>
+          </a:prstGeom>
+          <a:noFill/>
+          <a:ln/>
+        </p:spPr>
+        <p:txBody>
+          <a:bodyPr wrap="square" lIns="0" tIns="0" rIns="0" bIns="0" rtlCol="0" anchor="t"/>
+          <a:lstStyle/>
+          <a:p>
+            <a:pPr indent="0" marL="0">
+              <a:buNone/>
+            </a:pPr>
+            <a:r>
+              <a:rPr lang="en-US" sz="1300" dirty="0">
+                <a:solidFill>
+                  <a:srgbClr val="12161C"/>
+                </a:solidFill>
+                <a:latin typeface="Calibri" pitchFamily="34" charset="0"/>
+                <a:ea typeface="Calibri" pitchFamily="34" charset="-122"/>
+                <a:cs typeface="Calibri" pitchFamily="34" charset="-120"/>
+              </a:rPr>
+              <a:t>One button runs 120 random held-out test documents through the real pipeline, one request each, with a live tally next to the baseline.</a:t>
+            </a:r>
+            <a:endParaRPr lang="en-US" sz="1300" dirty="0"/>
+          </a:p>
+        </p:txBody>
+      </p:sp>
+      <p:sp>
+        <p:nvSpPr>
+          <p:cNvPr id="8" name="Text 5"/>
+          <p:cNvSpPr txBox="1"/>
+          <p:nvPr/>
+        </p:nvSpPr>
+        <p:spPr>
+          <a:xfrm>
+            <a:off x="777240" y="4937760"/>
+            <a:ext cx="5943600" cy="822960"/>
+          </a:xfrm>
+          <a:prstGeom prst="rect">
+            <a:avLst/>
+          </a:prstGeom>
+          <a:noFill/>
+          <a:ln/>
+        </p:spPr>
+        <p:txBody>
+          <a:bodyPr wrap="square" lIns="0" tIns="0" rIns="0" bIns="0" rtlCol="0" anchor="t"/>
+          <a:lstStyle/>
+          <a:p>
+            <a:pPr indent="0" marL="0">
+              <a:buNone/>
+            </a:pPr>
+            <a:r>
+              <a:rPr lang="en-US" sz="1200" dirty="0">
+                <a:solidFill>
+                  <a:srgbClr val="5B6472"/>
+                </a:solidFill>
+                <a:latin typeface="Calibri" pitchFamily="34" charset="0"/>
+                <a:ea typeface="Calibri" pitchFamily="34" charset="-122"/>
+                <a:cs typeface="Calibri" pitchFamily="34" charset="-120"/>
+              </a:rPr>
+              <a:t>On this sample Sentinel caught 55 of 60 poisoned documents. On the full 1,749 documents the figure is 86.7%; a sample this small moves by a few points, and the page says so.</a:t>
+            </a:r>
+            <a:endParaRPr lang="en-US" sz="1200" dirty="0"/>
+          </a:p>
+        </p:txBody>
+      </p:sp>
+      <p:sp>
+        <p:nvSpPr>
+          <p:cNvPr id="9" name="Shape 6"/>
+          <p:cNvSpPr/>
+          <p:nvPr/>
+        </p:nvSpPr>
+        <p:spPr>
+          <a:xfrm>
+            <a:off x="7269480" y="1645920"/>
+            <a:ext cx="4389120" cy="4343400"/>
+          </a:xfrm>
+          <a:prstGeom prst="roundRect">
+            <a:avLst>
+              <a:gd name="adj" fmla="val 2526"/>
+            </a:avLst>
+          </a:prstGeom>
+          <a:solidFill>
+            <a:srgbClr val="FFFFFF"/>
+          </a:solidFill>
+          <a:ln w="9525">
+            <a:solidFill>
+              <a:srgbClr val="E1E4E9"/>
+            </a:solidFill>
+            <a:prstDash val="solid"/>
+          </a:ln>
+          <a:effectLst>
+            <a:outerShdw sx="100000" sy="100000" kx="0" ky="0" algn="bl" rotWithShape="0" blurRad="127000" dist="25400" dir="5400000">
+              <a:srgbClr val="000000">
+                <a:alpha val="10000"/>
+              </a:srgbClr>
+            </a:outerShdw>
+          </a:effectLst>
+        </p:spPr>
+      </p:sp>
+      <p:pic>
+        <p:nvPicPr>
+          <p:cNvPr id="10" name="Image 1" descr="/private/tmp/claude-501/-Users-ananyasingh-Downloads-WIN-IF-YOU-CAN-PS/bf2c8522-e0b9-476e-a641-e8df935a7bd3/scratchpad/shots/g-err.png">    </p:cNvPr>
+          <p:cNvPicPr>
+            <a:picLocks noChangeAspect="1"/>
+          </p:cNvPicPr>
+          <p:nvPr/>
+        </p:nvPicPr>
+        <p:blipFill>
+          <a:blip r:embed="rId2"/>
+          <a:stretch>
+            <a:fillRect/>
+          </a:stretch>
+        </p:blipFill>
+        <p:spPr>
+          <a:xfrm>
+            <a:off x="7406640" y="1783080"/>
+            <a:ext cx="4114800" cy="2571750"/>
+          </a:xfrm>
+          <a:prstGeom prst="rect">
+            <a:avLst/>
+          </a:prstGeom>
+        </p:spPr>
+      </p:pic>
+      <p:sp>
+        <p:nvSpPr>
+          <p:cNvPr id="11" name="Text 7"/>
+          <p:cNvSpPr txBox="1"/>
+          <p:nvPr/>
+        </p:nvSpPr>
+        <p:spPr>
+          <a:xfrm>
+            <a:off x="7498080" y="4526280"/>
+            <a:ext cx="3931920" cy="237744"/>
+          </a:xfrm>
+          <a:prstGeom prst="rect">
+            <a:avLst/>
+          </a:prstGeom>
+          <a:noFill/>
+          <a:ln/>
+        </p:spPr>
+        <p:txBody>
+          <a:bodyPr wrap="square" lIns="0" tIns="0" rIns="0" bIns="0" rtlCol="0" anchor="t"/>
+          <a:lstStyle/>
+          <a:p>
+            <a:pPr indent="0" marL="0">
+              <a:buNone/>
+            </a:pPr>
+            <a:r>
+              <a:rPr lang="en-US" sz="1100" b="1" spc="250" kern="0" dirty="0">
+                <a:solidFill>
+                  <a:srgbClr val="FF5A36"/>
+                </a:solidFill>
+                <a:latin typeface="Calibri" pitchFamily="34" charset="0"/>
+                <a:ea typeface="Calibri" pitchFamily="34" charset="-122"/>
+                <a:cs typeface="Calibri" pitchFamily="34" charset="-120"/>
+              </a:rPr>
+              <a:t>WHERE IT FAILS</a:t>
+            </a:r>
+            <a:endParaRPr lang="en-US" sz="1100" dirty="0"/>
+          </a:p>
+        </p:txBody>
+      </p:sp>
+      <p:sp>
+        <p:nvSpPr>
+          <p:cNvPr id="12" name="Text 8"/>
+          <p:cNvSpPr txBox="1"/>
+          <p:nvPr/>
+        </p:nvSpPr>
+        <p:spPr>
+          <a:xfrm>
+            <a:off x="7498080" y="4828032"/>
+            <a:ext cx="3931920" cy="1005840"/>
+          </a:xfrm>
+          <a:prstGeom prst="rect">
+            <a:avLst/>
+          </a:prstGeom>
+          <a:noFill/>
+          <a:ln/>
+        </p:spPr>
+        <p:txBody>
+          <a:bodyPr wrap="square" lIns="0" tIns="0" rIns="0" bIns="0" rtlCol="0" anchor="t"/>
+          <a:lstStyle/>
+          <a:p>
+            <a:pPr indent="0" marL="0">
+              <a:buNone/>
+            </a:pPr>
+            <a:r>
+              <a:rPr lang="en-US" sz="1250" dirty="0">
+                <a:solidFill>
+                  <a:srgbClr val="12161C"/>
+                </a:solidFill>
+                <a:latin typeface="Calibri" pitchFamily="34" charset="0"/>
+                <a:ea typeface="Calibri" pitchFamily="34" charset="-122"/>
+                <a:cs typeface="Calibri" pitchFamily="34" charset="-120"/>
+              </a:rPr>
+              <a:t>117 of 879 attacks missed and 20 of 870 harmless documents flagged. Each miss shows its score against the cut-off, and opens in Home.</a:t>
+            </a:r>
+            <a:endParaRPr lang="en-US" sz="1250" dirty="0"/>
+          </a:p>
+        </p:txBody>
+      </p:sp>
+      <p:pic>
+        <p:nvPicPr>
+          <p:cNvPr id="13" name="Image 2" descr="/Users/ananyasingh/Developer/Sentinel/app/static/brand/mark-flat-256.png">    </p:cNvPr>
+          <p:cNvPicPr>
+            <a:picLocks noChangeAspect="1"/>
+          </p:cNvPicPr>
+          <p:nvPr/>
+        </p:nvPicPr>
+        <p:blipFill>
+          <a:blip r:embed="rId3"/>
+          <a:stretch>
+            <a:fillRect/>
+          </a:stretch>
+        </p:blipFill>
+        <p:spPr>
+          <a:xfrm>
             <a:off x="548640" y="6382512"/>
             <a:ext cx="201168" cy="201168"/>
           </a:xfrm>
@@ -13307,7 +14142,7 @@
       </p:pic>
       <p:sp>
         <p:nvSpPr>
-          <p:cNvPr id="27" name="Text 24"/>
+          <p:cNvPr id="14" name="Text 9"/>
           <p:cNvSpPr txBox="1"/>
           <p:nvPr/>
         </p:nvSpPr>
@@ -13346,7 +14181,7 @@
       </p:sp>
       <p:sp>
         <p:nvSpPr>
-          <p:cNvPr id="28" name="Text 25"/>
+          <p:cNvPr id="15" name="Text 10"/>
           <p:cNvSpPr txBox="1"/>
           <p:nvPr/>
         </p:nvSpPr>
@@ -13377,7 +14212,7 @@
                 <a:ea typeface="Calibri" pitchFamily="34" charset="-122"/>
                 <a:cs typeface="Calibri" pitchFamily="34" charset="-120"/>
               </a:rPr>
-              <a:t>9 / 10</a:t>
+              <a:t>9 / 11</a:t>
             </a:r>
             <a:endParaRPr lang="en-US" sz="1000" dirty="0"/>
           </a:p>

</xml_diff>